<commit_message>
feat: restore case-deck screenshots and fact tables, verified end to end
</commit_message>
<xml_diff>
--- a/presentation/case_vibe_vs_spec/vibe_vs_spec.pptx
+++ b/presentation/case_vibe_vs_spec/vibe_vs_spec.pptx
@@ -14,6 +14,9 @@
     <p:sldId id="262" r:id="rId14"/>
     <p:sldId id="263" r:id="rId15"/>
     <p:sldId id="264" r:id="rId16"/>
+    <p:sldId id="265" r:id="rId17"/>
+    <p:sldId id="266" r:id="rId18"/>
+    <p:sldId id="267" r:id="rId19"/>
   </p:sldIdLst>
   <p:sldSz cx="12191695" cy="6858000" type="screen4x3"/>
   <p:notesSz cx="6858000" cy="9144000"/>
@@ -550,6 +553,276 @@
 </p:notes>
 </file>
 
+<file path=ppt/notesSlides/notesSlide10.xml><?xml version="1.0" encoding="utf-8"?>
+<p:notes xmlns:a="http://schemas.openxmlformats.org/drawingml/2006/main" xmlns:p="http://schemas.openxmlformats.org/presentationml/2006/main" xmlns:r="http://schemas.openxmlformats.org/officeDocument/2006/relationships">
+  <p:cSld>
+    <p:spTree>
+      <p:nvGrpSpPr>
+        <p:cNvPr id="1" name=""/>
+        <p:cNvGrpSpPr/>
+        <p:nvPr/>
+      </p:nvGrpSpPr>
+      <p:grpSpPr>
+        <a:xfrm>
+          <a:off x="0" y="0"/>
+          <a:ext cx="0" cy="0"/>
+          <a:chOff x="0" y="0"/>
+          <a:chExt cx="0" cy="0"/>
+        </a:xfrm>
+      </p:grpSpPr>
+      <p:sp>
+        <p:nvSpPr>
+          <p:cNvPr id="2" name="Slide Image Placeholder 1"/>
+          <p:cNvSpPr>
+            <a:spLocks noGrp="1"/>
+          </p:cNvSpPr>
+          <p:nvPr>
+            <p:ph type="sldImg" idx="2"/>
+          </p:nvPr>
+        </p:nvSpPr>
+        <p:spPr/>
+      </p:sp>
+      <p:sp>
+        <p:nvSpPr>
+          <p:cNvPr id="3" name="Notes Placeholder 2"/>
+          <p:cNvSpPr>
+            <a:spLocks noGrp="1"/>
+          </p:cNvSpPr>
+          <p:nvPr>
+            <p:ph type="body" idx="3" sz="quarter"/>
+          </p:nvPr>
+        </p:nvSpPr>
+        <p:spPr/>
+        <p:txBody>
+          <a:bodyPr/>
+          <a:lstStyle/>
+          <a:p>
+            <a:r>
+              <a:t>변조 회귀</a:t>
+            </a:r>
+          </a:p>
+          <a:p>
+            <a:r>
+              <a:t>CSS에 미디어쿼리 문자열이 있다는 것만으로 1열 전환이 보장되지 않는다.</a:t>
+            </a:r>
+          </a:p>
+          <a:p>
+            <a:r>
+              <a:t>실제 렌더링된 gridTemplateColumns를 확인한다.</a:t>
+            </a:r>
+          </a:p>
+          <a:p>
+            <a:r>
+              <a:t>브라우저가 없으면 PASS가 아니라 UNVERIFIED(exit 2).</a:t>
+            </a:r>
+          </a:p>
+          <a:p>
+            <a:r>
+              <a:t>근거: experiments/exp04_agent_loop_sdd.py (--warm-cache = legacy)</a:t>
+            </a:r>
+          </a:p>
+        </p:txBody>
+      </p:sp>
+      <p:sp>
+        <p:nvSpPr>
+          <p:cNvPr id="4" name="Slide Number Placeholder 3"/>
+          <p:cNvSpPr>
+            <a:spLocks noGrp="1"/>
+          </p:cNvSpPr>
+          <p:nvPr>
+            <p:ph type="sldNum" idx="5" sz="quarter"/>
+          </p:nvPr>
+        </p:nvSpPr>
+        <p:spPr/>
+      </p:sp>
+    </p:spTree>
+  </p:cSld>
+  <p:clrMapOvr>
+    <a:masterClrMapping/>
+  </p:clrMapOvr>
+</p:notes>
+</file>
+
+<file path=ppt/notesSlides/notesSlide11.xml><?xml version="1.0" encoding="utf-8"?>
+<p:notes xmlns:a="http://schemas.openxmlformats.org/drawingml/2006/main" xmlns:p="http://schemas.openxmlformats.org/presentationml/2006/main" xmlns:r="http://schemas.openxmlformats.org/officeDocument/2006/relationships">
+  <p:cSld>
+    <p:spTree>
+      <p:nvGrpSpPr>
+        <p:cNvPr id="1" name=""/>
+        <p:cNvGrpSpPr/>
+        <p:nvPr/>
+      </p:nvGrpSpPr>
+      <p:grpSpPr>
+        <a:xfrm>
+          <a:off x="0" y="0"/>
+          <a:ext cx="0" cy="0"/>
+          <a:chOff x="0" y="0"/>
+          <a:chExt cx="0" cy="0"/>
+        </a:xfrm>
+      </p:grpSpPr>
+      <p:sp>
+        <p:nvSpPr>
+          <p:cNvPr id="2" name="Slide Image Placeholder 1"/>
+          <p:cNvSpPr>
+            <a:spLocks noGrp="1"/>
+          </p:cNvSpPr>
+          <p:nvPr>
+            <p:ph type="sldImg" idx="2"/>
+          </p:nvPr>
+        </p:nvSpPr>
+        <p:spPr/>
+      </p:sp>
+      <p:sp>
+        <p:nvSpPr>
+          <p:cNvPr id="3" name="Notes Placeholder 2"/>
+          <p:cNvSpPr>
+            <a:spLocks noGrp="1"/>
+          </p:cNvSpPr>
+          <p:nvPr>
+            <p:ph type="body" idx="3" sz="quarter"/>
+          </p:nvPr>
+        </p:nvSpPr>
+        <p:spPr/>
+        <p:txBody>
+          <a:bodyPr/>
+          <a:lstStyle/>
+          <a:p>
+            <a:r>
+              <a:t>외부 보고의 범위 제한</a:t>
+            </a:r>
+          </a:p>
+          <a:p>
+            <a:r>
+              <a:t>Spec-Kit +97~109%: OpenSpec 대비 두 사례의 외부 블로그 보고. 둘 다 SDD 접근.</a:t>
+            </a:r>
+          </a:p>
+          <a:p>
+            <a:r>
+              <a:t>ETH AGENTS.md 연구: 저장소 컨텍스트 파일 조건. 모든 짧은 스펙이 손해라는 실험 아님.</a:t>
+            </a:r>
+          </a:p>
+          <a:p>
+            <a:r>
+              <a:t>짧고 필요한 요구사항만 쓰라는 실무 원칙은 유지하되 효과를 직접 측정한다.</a:t>
+            </a:r>
+          </a:p>
+          <a:p>
+            <a:r>
+              <a:t>근거: SOURCES.md §4 · arxiv.org/html/2602.11988v1</a:t>
+            </a:r>
+          </a:p>
+        </p:txBody>
+      </p:sp>
+      <p:sp>
+        <p:nvSpPr>
+          <p:cNvPr id="4" name="Slide Number Placeholder 3"/>
+          <p:cNvSpPr>
+            <a:spLocks noGrp="1"/>
+          </p:cNvSpPr>
+          <p:nvPr>
+            <p:ph type="sldNum" idx="5" sz="quarter"/>
+          </p:nvPr>
+        </p:nvSpPr>
+        <p:spPr/>
+      </p:sp>
+    </p:spTree>
+  </p:cSld>
+  <p:clrMapOvr>
+    <a:masterClrMapping/>
+  </p:clrMapOvr>
+</p:notes>
+</file>
+
+<file path=ppt/notesSlides/notesSlide12.xml><?xml version="1.0" encoding="utf-8"?>
+<p:notes xmlns:a="http://schemas.openxmlformats.org/drawingml/2006/main" xmlns:p="http://schemas.openxmlformats.org/presentationml/2006/main" xmlns:r="http://schemas.openxmlformats.org/officeDocument/2006/relationships">
+  <p:cSld>
+    <p:spTree>
+      <p:nvGrpSpPr>
+        <p:cNvPr id="1" name=""/>
+        <p:cNvGrpSpPr/>
+        <p:nvPr/>
+      </p:nvGrpSpPr>
+      <p:grpSpPr>
+        <a:xfrm>
+          <a:off x="0" y="0"/>
+          <a:ext cx="0" cy="0"/>
+          <a:chOff x="0" y="0"/>
+          <a:chExt cx="0" cy="0"/>
+        </a:xfrm>
+      </p:grpSpPr>
+      <p:sp>
+        <p:nvSpPr>
+          <p:cNvPr id="2" name="Slide Image Placeholder 1"/>
+          <p:cNvSpPr>
+            <a:spLocks noGrp="1"/>
+          </p:cNvSpPr>
+          <p:nvPr>
+            <p:ph type="sldImg" idx="2"/>
+          </p:nvPr>
+        </p:nvSpPr>
+        <p:spPr/>
+      </p:sp>
+      <p:sp>
+        <p:nvSpPr>
+          <p:cNvPr id="3" name="Notes Placeholder 2"/>
+          <p:cNvSpPr>
+            <a:spLocks noGrp="1"/>
+          </p:cNvSpPr>
+          <p:nvPr>
+            <p:ph type="body" idx="3" sz="quarter"/>
+          </p:nvPr>
+        </p:nvSpPr>
+        <p:spPr/>
+        <p:txBody>
+          <a:bodyPr/>
+          <a:lstStyle/>
+          <a:p>
+            <a:r>
+              <a:t>후속 계획 / 미실행</a:t>
+            </a:r>
+          </a:p>
+          <a:p>
+            <a:r>
+              <a:t>백지 스펙 작성 비용부터 포함하고 다수 과제를 무작위 배정한다.</a:t>
+            </a:r>
+          </a:p>
+          <a:p>
+            <a:r>
+              <a:t>같은 AC·모델·출력 예산·가격·캐시 조건으로 성공률과 총비용을 기록한다.</a:t>
+            </a:r>
+          </a:p>
+          <a:p>
+            <a:r>
+              <a:t>진행하지 않은 실험의 절감률은 결과로 채우지 않는다.</a:t>
+            </a:r>
+          </a:p>
+          <a:p>
+            <a:r>
+              <a:t>근거: demo/vibe_vs_spec/EXPERIMENT_A_PROTOCOL.md</a:t>
+            </a:r>
+          </a:p>
+        </p:txBody>
+      </p:sp>
+      <p:sp>
+        <p:nvSpPr>
+          <p:cNvPr id="4" name="Slide Number Placeholder 3"/>
+          <p:cNvSpPr>
+            <a:spLocks noGrp="1"/>
+          </p:cNvSpPr>
+          <p:nvPr>
+            <p:ph type="sldNum" idx="5" sz="quarter"/>
+          </p:nvPr>
+        </p:nvSpPr>
+        <p:spPr/>
+      </p:sp>
+    </p:spTree>
+  </p:cSld>
+  <p:clrMapOvr>
+    <a:masterClrMapping/>
+  </p:clrMapOvr>
+</p:notes>
+</file>
+
 <file path=ppt/notesSlides/notesSlide2.xml><?xml version="1.0" encoding="utf-8"?>
 <p:notes xmlns:a="http://schemas.openxmlformats.org/drawingml/2006/main" xmlns:p="http://schemas.openxmlformats.org/presentationml/2006/main" xmlns:r="http://schemas.openxmlformats.org/officeDocument/2006/relationships">
   <p:cSld>
@@ -690,27 +963,32 @@
           <a:lstStyle/>
           <a:p>
             <a:r>
-              <a:t>추정치 재계산</a:t>
-            </a:r>
-          </a:p>
-          <a:p>
-            <a:r>
-              <a:t>입력 +666, 추론+출력 -680, 캐시 +156 (추정값 고정)</a:t>
-            </a:r>
-          </a:p>
-          <a:p>
-            <a:r>
-              <a:t>이 케이스에서 input과 cache는 서로 겹치지 않는 버킷으로 정의했다.</a:t>
-            </a:r>
-          </a:p>
-          <a:p>
-            <a:r>
-              <a:t>벤더 usage 필드 이름과 동일하다고 가정하면 이중 계상할 수 있다.</a:t>
-            </a:r>
-          </a:p>
-          <a:p>
-            <a:r>
-              <a:t>근거: demo/vibe_vs_spec/usage.json</a:t>
+              <a:t>산출물 스크린샷</a:t>
+            </a:r>
+          </a:p>
+          <a:p>
+            <a:r>
+              <a:t>두 장 모두 실제 생성 HTML을 Chromium 1280px에서 캡처한 화면이다.</a:t>
+            </a:r>
+          </a:p>
+          <a:p>
+            <a:r>
+              <a:t>보이는 화면이 비슷하다는 것이 품질 동등성의 증거는 아니다.</a:t>
+            </a:r>
+          </a:p>
+          <a:p>
+            <a:r>
+              <a:t>그림: 위: Vibe 산출물 첫 화면 (1280px) (demo/vibe_vs_spec/shots/vibe_top.png)</a:t>
+            </a:r>
+          </a:p>
+          <a:p>
+            <a:r>
+              <a:t>그림: 아래: Spec 산출물 첫 화면 (1280px) (demo/vibe_vs_spec/shots/spec_top.png)</a:t>
+            </a:r>
+          </a:p>
+          <a:p>
+            <a:r>
+              <a:t>근거: demo/vibe_vs_spec/shots/vibe_top.png · demo/vibe_vs_spec/shots/spec_top.png</a:t>
             </a:r>
           </a:p>
         </p:txBody>
@@ -780,27 +1058,27 @@
           <a:lstStyle/>
           <a:p>
             <a:r>
-              <a:t>단가 민감도</a:t>
-            </a:r>
-          </a:p>
-          <a:p>
-            <a:r>
-              <a:t>r = 출력/입력 단가, h = 캐시 읽기/입력 단가</a:t>
-            </a:r>
-          </a:p>
-          <a:p>
-            <a:r>
-              <a:t>h=0.1이면 손익분기 r=1.0024. 모든 가격 체계에서의 보편 법칙은 아니다.</a:t>
-            </a:r>
-          </a:p>
-          <a:p>
-            <a:r>
-              <a:t>다른 모델 단가에 고정 토큰을 대입한 감도 분석이지 다른 모델의 실호출이 아니다.</a:t>
-            </a:r>
-          </a:p>
-          <a:p>
-            <a:r>
-              <a:t>근거: demo/vibe_vs_spec/sensitivity.py</a:t>
+              <a:t>반응형 스크린샷</a:t>
+            </a:r>
+          </a:p>
+          <a:p>
+            <a:r>
+              <a:t>문자열 검사만으로는 2열로 바뀌어도 통과한다.</a:t>
+            </a:r>
+          </a:p>
+          <a:p>
+            <a:r>
+              <a:t>아래 그림은 현재 Spec 산출물을 390px에서 캡처한 것이다.</a:t>
+            </a:r>
+          </a:p>
+          <a:p>
+            <a:r>
+              <a:t>그림: Spec 산출물 · 390×844 캡처 (demo/vibe_vs_spec/shots/spec_mobile.png)</a:t>
+            </a:r>
+          </a:p>
+          <a:p>
+            <a:r>
+              <a:t>근거: demo/vibe_vs_spec/shots/spec_mobile.png</a:t>
             </a:r>
           </a:p>
         </p:txBody>
@@ -870,27 +1148,27 @@
           <a:lstStyle/>
           <a:p>
             <a:r>
-              <a:t>현재 산출물의 실행 검사</a:t>
-            </a:r>
-          </a:p>
-          <a:p>
-            <a:r>
-              <a:t>390/820/821/1280px 그리드·메뉴 표시·가로 스크롤 검사</a:t>
-            </a:r>
-          </a:p>
-          <a:p>
-            <a:r>
-              <a:t>각 카드의 내용과 세 앵커의 실제 스크롤 이동 검사</a:t>
-            </a:r>
-          </a:p>
-          <a:p>
-            <a:r>
-              <a:t>디자인 선호도·모든 사용자 의도·두 생성 과정의 품질 동등성은 검증하지 않는다.</a:t>
-            </a:r>
-          </a:p>
-          <a:p>
-            <a:r>
-              <a:t>근거: demo/vibe_vs_spec/verify_ac.py · tools/browser_ac.py</a:t>
+              <a:t>전체 페이지 축소 비교</a:t>
+            </a:r>
+          </a:p>
+          <a:p>
+            <a:r>
+              <a:t>원본 캡처 1,280×3,400 두 장을 같은 높이로 축소해 나란히 붙였다.</a:t>
+            </a:r>
+          </a:p>
+          <a:p>
+            <a:r>
+              <a:t>스크롤 길이가 비슷하다는 사실은 비용·품질 동등성 판정이 아니다.</a:t>
+            </a:r>
+          </a:p>
+          <a:p>
+            <a:r>
+              <a:t>그림: 왼쪽 Vibe 전체 페이지 · 오른쪽 Spec 전체 페이지 (축소) (demo/vibe_vs_spec/shots/vibe_spec_full_2up.png)</a:t>
+            </a:r>
+          </a:p>
+          <a:p>
+            <a:r>
+              <a:t>근거: demo/vibe_vs_spec/shots/vibe_full.png · demo/vibe_vs_spec/shots/spec_full.png · demo/vibe_vs_spec/make_fullpage_2up.py</a:t>
             </a:r>
           </a:p>
         </p:txBody>
@@ -960,27 +1238,42 @@
           <a:lstStyle/>
           <a:p>
             <a:r>
-              <a:t>변조 회귀</a:t>
-            </a:r>
-          </a:p>
-          <a:p>
-            <a:r>
-              <a:t>CSS에 미디어쿼리 문자열이 있다는 것만으로 1열 전환이 보장되지 않는다.</a:t>
-            </a:r>
-          </a:p>
-          <a:p>
-            <a:r>
-              <a:t>실제 렌더링된 gridTemplateColumns를 확인한다.</a:t>
-            </a:r>
-          </a:p>
-          <a:p>
-            <a:r>
-              <a:t>브라우저가 없으면 PASS가 아니라 UNVERIFIED(exit 2).</a:t>
-            </a:r>
-          </a:p>
-          <a:p>
-            <a:r>
-              <a:t>근거: tests/test_browser_ac.py</a:t>
+              <a:t>추정치 재계산</a:t>
+            </a:r>
+          </a:p>
+          <a:p>
+            <a:r>
+              <a:t>이 케이스에서 input과 cache는 서로 겹치지 않는 버킷으로 정의했다.</a:t>
+            </a:r>
+          </a:p>
+          <a:p>
+            <a:r>
+              <a:t>벤더 usage 필드 이름과 동일하다고 가정하면 이중 계상할 수 있다.</a:t>
+            </a:r>
+          </a:p>
+          <a:p>
+            <a:r>
+              <a:t>비캐시 입력: 486 → 1,152  (증가 666)</a:t>
+            </a:r>
+          </a:p>
+          <a:p>
+            <a:r>
+              <a:t>추론+보이는 출력: 7,070 → 6,390  (감소 680)</a:t>
+            </a:r>
+          </a:p>
+          <a:p>
+            <a:r>
+              <a:t>캐시 입력(추정): 312 → 468  (증가 156)</a:t>
+            </a:r>
+          </a:p>
+          <a:p>
+            <a:r>
+              <a:t>합계: 7,868 → 8,010  (증가 1.8%)</a:t>
+            </a:r>
+          </a:p>
+          <a:p>
+            <a:r>
+              <a:t>근거: demo/vibe_vs_spec/usage.json</a:t>
             </a:r>
           </a:p>
         </p:txBody>
@@ -1050,27 +1343,37 @@
           <a:lstStyle/>
           <a:p>
             <a:r>
-              <a:t>외부 보고의 범위 제한</a:t>
-            </a:r>
-          </a:p>
-          <a:p>
-            <a:r>
-              <a:t>Spec-Kit +97~109%: OpenSpec 대비 두 사례의 외부 블로그 보고. 둘 다 SDD 접근.</a:t>
-            </a:r>
-          </a:p>
-          <a:p>
-            <a:r>
-              <a:t>ETH AGENTS.md 연구: 저장소 컨텍스트 파일 조건. 모든 짧은 스펙이 손해라는 실험 아님.</a:t>
-            </a:r>
-          </a:p>
-          <a:p>
-            <a:r>
-              <a:t>짧고 필요한 요구사항만 쓰라는 실무 원칙은 유지하되 효과를 직접 측정한다.</a:t>
-            </a:r>
-          </a:p>
-          <a:p>
-            <a:r>
-              <a:t>근거: SOURCES.md §4 · arxiv.org/html/2602.11988v1</a:t>
+              <a:t>단가별 비용 재계산</a:t>
+            </a:r>
+          </a:p>
+          <a:p>
+            <a:r>
+              <a:t>토큰은 그대로 두고 단가와 캐시 가정만 바꾼 산술이다.</a:t>
+            </a:r>
+          </a:p>
+          <a:p>
+            <a:r>
+              <a:t>다른 모델을 실행한 실측이 아니며, 캐시 적격성은 미확인이다.</a:t>
+            </a:r>
+          </a:p>
+          <a:p>
+            <a:r>
+              <a:t>GPT-5 · 캐시 $0.125/M: $0.0713465 → $0.0653985  (8.3% 감소)</a:t>
+            </a:r>
+          </a:p>
+          <a:p>
+            <a:r>
+              <a:t>Claude Sonnet 4.6 · 캐시 0.1×: $0.1076016 → $0.0994464  (7.6% 감소)</a:t>
+            </a:r>
+          </a:p>
+          <a:p>
+            <a:r>
+              <a:t>GPT-5 · 캐시 전부 미적용: $0.0716975 → $0.0659250  (8.1% 감소)</a:t>
+            </a:r>
+          </a:p>
+          <a:p>
+            <a:r>
+              <a:t>근거: demo/vibe_vs_spec/cost_comparison.md · verify_case.py</a:t>
             </a:r>
           </a:p>
         </p:txBody>
@@ -1140,32 +1443,42 @@
           <a:lstStyle/>
           <a:p>
             <a:r>
-              <a:t>SDD 비용 시나리오</a:t>
-            </a:r>
-          </a:p>
-          <a:p>
-            <a:r>
-              <a:t>40턴 → 12턴은 모델의 입력 가정. 스펙이 실제 이만큼 줄였다는 관측은 없다.</a:t>
-            </a:r>
-          </a:p>
-          <a:p>
-            <a:r>
-              <a:t>스펙 작성: 입력 3,000 + 출력 4,000 비용을 이미 포함한다.</a:t>
-            </a:r>
-          </a:p>
-          <a:p>
-            <a:r>
-              <a:t>기존 약 71%는 캐시 예열 비용 제외. 기본은 사이클별 첫 쓰기까지 포함한다.</a:t>
-            </a:r>
-          </a:p>
-          <a:p>
-            <a:r>
-              <a:t>주장 유지: 짧고 결정적인 스펙을 우선 시도하되 재작업·품질·총비용으로 검증한다.</a:t>
-            </a:r>
-          </a:p>
-          <a:p>
-            <a:r>
-              <a:t>근거: experiments/exp04_agent_loop_sdd.py (--warm-cache = legacy)</a:t>
+              <a:t>단가 민감도</a:t>
+            </a:r>
+          </a:p>
+          <a:p>
+            <a:r>
+              <a:t>r = 출력/입력 단가, h = 캐시 읽기/입력 단가.</a:t>
+            </a:r>
+          </a:p>
+          <a:p>
+            <a:r>
+              <a:t>모든 가격 체계에서의 보편 법칙이 아니라 고정 토큰 이동의 감도 분석이다.</a:t>
+            </a:r>
+          </a:p>
+          <a:p>
+            <a:r>
+              <a:t>손익분기 조건: r &gt; (666 + 156h) / 680</a:t>
+            </a:r>
+          </a:p>
+          <a:p>
+            <a:r>
+              <a:t>h = 0.1이면: r = 1.0024</a:t>
+            </a:r>
+          </a:p>
+          <a:p>
+            <a:r>
+              <a:t>r → ∞ 수렴: 약 9.62% 감소에 수렴</a:t>
+            </a:r>
+          </a:p>
+          <a:p>
+            <a:r>
+              <a:t>실제 청구서: 미확인 (usage 추정치 산술)</a:t>
+            </a:r>
+          </a:p>
+          <a:p>
+            <a:r>
+              <a:t>근거: demo/vibe_vs_spec/sensitivity.py</a:t>
             </a:r>
           </a:p>
         </p:txBody>
@@ -1235,27 +1548,27 @@
           <a:lstStyle/>
           <a:p>
             <a:r>
-              <a:t>후속 계획 / 미실행</a:t>
-            </a:r>
-          </a:p>
-          <a:p>
-            <a:r>
-              <a:t>백지 스펙 작성 비용부터 포함하고 다수 과제를 무작위 배정한다.</a:t>
-            </a:r>
-          </a:p>
-          <a:p>
-            <a:r>
-              <a:t>같은 AC·모델·출력 예산·가격·캐시 조건으로 성공률과 총비용을 기록한다.</a:t>
-            </a:r>
-          </a:p>
-          <a:p>
-            <a:r>
-              <a:t>진행하지 않은 실험의 절감률은 결과로 채우지 않는다.</a:t>
-            </a:r>
-          </a:p>
-          <a:p>
-            <a:r>
-              <a:t>근거: demo/vibe_vs_spec/EXPERIMENT_A_PROTOCOL.md</a:t>
+              <a:t>현재 산출물의 실행 검사</a:t>
+            </a:r>
+          </a:p>
+          <a:p>
+            <a:r>
+              <a:t>390/820/821/1280px 그리드·메뉴 표시·가로 스크롤 검사</a:t>
+            </a:r>
+          </a:p>
+          <a:p>
+            <a:r>
+              <a:t>각 카드의 내용과 세 앵커의 실제 스크롤 이동 검사</a:t>
+            </a:r>
+          </a:p>
+          <a:p>
+            <a:r>
+              <a:t>디자인 선호도·모든 사용자 의도·두 생성 과정의 품질 동등성은 검증하지 않는다.</a:t>
+            </a:r>
+          </a:p>
+          <a:p>
+            <a:r>
+              <a:t>근거: demo/vibe_vs_spec/verify_ac.py · tools/browser_ac.py</a:t>
             </a:r>
           </a:p>
         </p:txBody>
@@ -4608,6 +4921,1185 @@
 </p:sld>
 </file>
 
+<file path=ppt/slides/slide10.xml><?xml version="1.0" encoding="utf-8"?>
+<p:sld xmlns:a="http://schemas.openxmlformats.org/drawingml/2006/main" xmlns:p="http://schemas.openxmlformats.org/presentationml/2006/main" xmlns:r="http://schemas.openxmlformats.org/officeDocument/2006/relationships">
+  <p:cSld>
+    <p:bg>
+      <p:bgPr>
+        <a:solidFill>
+          <a:srgbClr val="0E141B"/>
+        </a:solidFill>
+        <a:effectLst/>
+      </p:bgPr>
+    </p:bg>
+    <p:spTree>
+      <p:nvGrpSpPr>
+        <p:cNvPr id="1" name=""/>
+        <p:cNvGrpSpPr/>
+        <p:nvPr/>
+      </p:nvGrpSpPr>
+      <p:grpSpPr/>
+      <p:sp>
+        <p:nvSpPr>
+          <p:cNvPr id="2" name="Rectangle 1"/>
+          <p:cNvSpPr/>
+          <p:nvPr/>
+        </p:nvSpPr>
+        <p:spPr>
+          <a:xfrm>
+            <a:off x="0" y="0"/>
+            <a:ext cx="100584" cy="6858000"/>
+          </a:xfrm>
+          <a:prstGeom prst="rect">
+            <a:avLst/>
+          </a:prstGeom>
+          <a:solidFill>
+            <a:srgbClr val="36D399"/>
+          </a:solidFill>
+          <a:ln>
+            <a:noFill/>
+          </a:ln>
+        </p:spPr>
+        <p:style>
+          <a:lnRef idx="1">
+            <a:schemeClr val="accent1"/>
+          </a:lnRef>
+          <a:fillRef idx="3">
+            <a:schemeClr val="accent1"/>
+          </a:fillRef>
+          <a:effectRef idx="2">
+            <a:schemeClr val="accent1"/>
+          </a:effectRef>
+          <a:fontRef idx="minor">
+            <a:schemeClr val="lt1"/>
+          </a:fontRef>
+        </p:style>
+        <p:txBody>
+          <a:bodyPr rtlCol="0" anchor="ctr"/>
+          <a:lstStyle/>
+          <a:p>
+            <a:pPr algn="ctr"/>
+          </a:p>
+        </p:txBody>
+      </p:sp>
+      <p:sp>
+        <p:nvSpPr>
+          <p:cNvPr id="3" name="audit:index"/>
+          <p:cNvSpPr txBox="1"/>
+          <p:nvPr/>
+        </p:nvSpPr>
+        <p:spPr>
+          <a:xfrm>
+            <a:off x="640080" y="274320"/>
+            <a:ext cx="4572000" cy="274320"/>
+          </a:xfrm>
+          <a:prstGeom prst="rect">
+            <a:avLst/>
+          </a:prstGeom>
+          <a:noFill/>
+        </p:spPr>
+        <p:txBody>
+          <a:bodyPr wrap="square" lIns="0" rIns="0" tIns="0" bIns="0">
+            <a:spAutoFit/>
+          </a:bodyPr>
+          <a:lstStyle/>
+          <a:p>
+            <a:r>
+              <a:rPr sz="1100" b="0">
+                <a:solidFill>
+                  <a:srgbClr val="93A4B5"/>
+                </a:solidFill>
+                <a:latin typeface="NanumGothic"/>
+                <a:ea typeface="NanumGothic"/>
+                <a:cs typeface="NanumGothic"/>
+              </a:rPr>
+              <a:t>TOKEN COST LAB  /  10</a:t>
+            </a:r>
+          </a:p>
+        </p:txBody>
+      </p:sp>
+      <p:sp>
+        <p:nvSpPr>
+          <p:cNvPr id="4" name="audit:scope"/>
+          <p:cNvSpPr txBox="1"/>
+          <p:nvPr/>
+        </p:nvSpPr>
+        <p:spPr>
+          <a:xfrm>
+            <a:off x="5760720" y="274320"/>
+            <a:ext cx="5760720" cy="274320"/>
+          </a:xfrm>
+          <a:prstGeom prst="rect">
+            <a:avLst/>
+          </a:prstGeom>
+          <a:noFill/>
+        </p:spPr>
+        <p:txBody>
+          <a:bodyPr wrap="square" lIns="0" rIns="0" tIns="0" bIns="0">
+            <a:spAutoFit/>
+          </a:bodyPr>
+          <a:lstStyle/>
+          <a:p>
+            <a:r>
+              <a:rPr sz="1100" b="0">
+                <a:solidFill>
+                  <a:srgbClr val="36D399"/>
+                </a:solidFill>
+                <a:latin typeface="NanumGothic"/>
+                <a:ea typeface="NanumGothic"/>
+                <a:cs typeface="NanumGothic"/>
+              </a:rPr>
+              <a:t>변조 회귀</a:t>
+            </a:r>
+          </a:p>
+        </p:txBody>
+      </p:sp>
+      <p:sp>
+        <p:nvSpPr>
+          <p:cNvPr id="5" name="audit:title"/>
+          <p:cNvSpPr txBox="1"/>
+          <p:nvPr/>
+        </p:nvSpPr>
+        <p:spPr>
+          <a:xfrm>
+            <a:off x="640080" y="822960"/>
+            <a:ext cx="10881360" cy="822960"/>
+          </a:xfrm>
+          <a:prstGeom prst="rect">
+            <a:avLst/>
+          </a:prstGeom>
+          <a:noFill/>
+        </p:spPr>
+        <p:txBody>
+          <a:bodyPr wrap="square" lIns="0" rIns="0" tIns="0" bIns="0">
+            <a:spAutoFit/>
+          </a:bodyPr>
+          <a:lstStyle/>
+          <a:p>
+            <a:r>
+              <a:rPr sz="2900" b="1">
+                <a:solidFill>
+                  <a:srgbClr val="ECF1F6"/>
+                </a:solidFill>
+                <a:latin typeface="NanumGothic"/>
+                <a:ea typeface="NanumGothic"/>
+                <a:cs typeface="NanumGothic"/>
+              </a:rPr>
+              <a:t>실패하는 반례도 넣는다</a:t>
+            </a:r>
+          </a:p>
+        </p:txBody>
+      </p:sp>
+      <p:sp>
+        <p:nvSpPr>
+          <p:cNvPr id="6" name="audit:hero"/>
+          <p:cNvSpPr txBox="1"/>
+          <p:nvPr/>
+        </p:nvSpPr>
+        <p:spPr>
+          <a:xfrm>
+            <a:off x="640080" y="1783080"/>
+            <a:ext cx="10881360" cy="777240"/>
+          </a:xfrm>
+          <a:prstGeom prst="rect">
+            <a:avLst/>
+          </a:prstGeom>
+          <a:noFill/>
+        </p:spPr>
+        <p:txBody>
+          <a:bodyPr wrap="square" lIns="0" rIns="0" tIns="0" bIns="0">
+            <a:spAutoFit/>
+          </a:bodyPr>
+          <a:lstStyle/>
+          <a:p>
+            <a:r>
+              <a:rPr sz="2900" b="1">
+                <a:solidFill>
+                  <a:srgbClr val="36D399"/>
+                </a:solidFill>
+                <a:latin typeface="NanumGothic"/>
+                <a:ea typeface="NanumGothic"/>
+                <a:cs typeface="NanumGothic"/>
+              </a:rPr>
+              <a:t>모바일 2열 변조 → FAIL</a:t>
+            </a:r>
+          </a:p>
+        </p:txBody>
+      </p:sp>
+      <p:sp>
+        <p:nvSpPr>
+          <p:cNvPr id="7" name="audit:body-0"/>
+          <p:cNvSpPr txBox="1"/>
+          <p:nvPr/>
+        </p:nvSpPr>
+        <p:spPr>
+          <a:xfrm>
+            <a:off x="777240" y="2862072"/>
+            <a:ext cx="10652760" cy="612648"/>
+          </a:xfrm>
+          <a:prstGeom prst="rect">
+            <a:avLst/>
+          </a:prstGeom>
+          <a:noFill/>
+        </p:spPr>
+        <p:txBody>
+          <a:bodyPr wrap="square" lIns="0" rIns="0" tIns="0" bIns="0">
+            <a:spAutoFit/>
+          </a:bodyPr>
+          <a:lstStyle/>
+          <a:p>
+            <a:r>
+              <a:rPr sz="1750" b="0">
+                <a:solidFill>
+                  <a:srgbClr val="ECF1F6"/>
+                </a:solidFill>
+                <a:latin typeface="NanumGothic"/>
+                <a:ea typeface="NanumGothic"/>
+                <a:cs typeface="NanumGothic"/>
+              </a:rPr>
+              <a:t>CSS에 미디어쿼리 문자열이 있다는 것만으로 1열 전환이 보장되지 않는다.</a:t>
+            </a:r>
+          </a:p>
+        </p:txBody>
+      </p:sp>
+      <p:sp>
+        <p:nvSpPr>
+          <p:cNvPr id="8" name="audit:body-1"/>
+          <p:cNvSpPr txBox="1"/>
+          <p:nvPr/>
+        </p:nvSpPr>
+        <p:spPr>
+          <a:xfrm>
+            <a:off x="777240" y="3502152"/>
+            <a:ext cx="10652760" cy="612648"/>
+          </a:xfrm>
+          <a:prstGeom prst="rect">
+            <a:avLst/>
+          </a:prstGeom>
+          <a:noFill/>
+        </p:spPr>
+        <p:txBody>
+          <a:bodyPr wrap="square" lIns="0" rIns="0" tIns="0" bIns="0">
+            <a:spAutoFit/>
+          </a:bodyPr>
+          <a:lstStyle/>
+          <a:p>
+            <a:r>
+              <a:rPr sz="1750" b="0">
+                <a:solidFill>
+                  <a:srgbClr val="ECF1F6"/>
+                </a:solidFill>
+                <a:latin typeface="NanumGothic"/>
+                <a:ea typeface="NanumGothic"/>
+                <a:cs typeface="NanumGothic"/>
+              </a:rPr>
+              <a:t>실제 렌더링된 gridTemplateColumns를 확인한다.</a:t>
+            </a:r>
+          </a:p>
+        </p:txBody>
+      </p:sp>
+      <p:sp>
+        <p:nvSpPr>
+          <p:cNvPr id="9" name="audit:body-2"/>
+          <p:cNvSpPr txBox="1"/>
+          <p:nvPr/>
+        </p:nvSpPr>
+        <p:spPr>
+          <a:xfrm>
+            <a:off x="777240" y="4142231"/>
+            <a:ext cx="10652760" cy="612648"/>
+          </a:xfrm>
+          <a:prstGeom prst="rect">
+            <a:avLst/>
+          </a:prstGeom>
+          <a:noFill/>
+        </p:spPr>
+        <p:txBody>
+          <a:bodyPr wrap="square" lIns="0" rIns="0" tIns="0" bIns="0">
+            <a:spAutoFit/>
+          </a:bodyPr>
+          <a:lstStyle/>
+          <a:p>
+            <a:r>
+              <a:rPr sz="1750" b="0">
+                <a:solidFill>
+                  <a:srgbClr val="ECF1F6"/>
+                </a:solidFill>
+                <a:latin typeface="NanumGothic"/>
+                <a:ea typeface="NanumGothic"/>
+                <a:cs typeface="NanumGothic"/>
+              </a:rPr>
+              <a:t>브라우저가 없으면 PASS가 아니라 UNVERIFIED(exit 2).</a:t>
+            </a:r>
+          </a:p>
+        </p:txBody>
+      </p:sp>
+      <p:sp>
+        <p:nvSpPr>
+          <p:cNvPr id="10" name="audit:source"/>
+          <p:cNvSpPr txBox="1"/>
+          <p:nvPr/>
+        </p:nvSpPr>
+        <p:spPr>
+          <a:xfrm>
+            <a:off x="640080" y="6080760"/>
+            <a:ext cx="10972800" cy="274320"/>
+          </a:xfrm>
+          <a:prstGeom prst="rect">
+            <a:avLst/>
+          </a:prstGeom>
+          <a:noFill/>
+        </p:spPr>
+        <p:txBody>
+          <a:bodyPr wrap="square" lIns="0" rIns="0" tIns="0" bIns="0">
+            <a:spAutoFit/>
+          </a:bodyPr>
+          <a:lstStyle/>
+          <a:p>
+            <a:r>
+              <a:rPr sz="1000" b="0">
+                <a:solidFill>
+                  <a:srgbClr val="93A4B5"/>
+                </a:solidFill>
+                <a:latin typeface="NanumGothic"/>
+                <a:ea typeface="NanumGothic"/>
+                <a:cs typeface="NanumGothic"/>
+              </a:rPr>
+              <a:t>experiments/exp04_agent_loop_sdd.py (--warm-cache = legacy)</a:t>
+            </a:r>
+          </a:p>
+        </p:txBody>
+      </p:sp>
+      <p:sp>
+        <p:nvSpPr>
+          <p:cNvPr id="11" name="audit:footer"/>
+          <p:cNvSpPr txBox="1"/>
+          <p:nvPr/>
+        </p:nvSpPr>
+        <p:spPr>
+          <a:xfrm>
+            <a:off x="640080" y="6419088"/>
+            <a:ext cx="10972800" cy="256032"/>
+          </a:xfrm>
+          <a:prstGeom prst="rect">
+            <a:avLst/>
+          </a:prstGeom>
+          <a:noFill/>
+        </p:spPr>
+        <p:txBody>
+          <a:bodyPr wrap="square" lIns="0" rIns="0" tIns="0" bIns="0">
+            <a:spAutoFit/>
+          </a:bodyPr>
+          <a:lstStyle/>
+          <a:p>
+            <a:r>
+              <a:rPr sz="1000" b="0">
+                <a:solidFill>
+                  <a:srgbClr val="93A4B5"/>
+                </a:solidFill>
+                <a:latin typeface="NanumGothic"/>
+                <a:ea typeface="NanumGothic"/>
+                <a:cs typeface="NanumGothic"/>
+              </a:rPr>
+              <a:t>2026-09-20  ·  근거와 조건을 함께 인용</a:t>
+            </a:r>
+          </a:p>
+        </p:txBody>
+      </p:sp>
+    </p:spTree>
+  </p:cSld>
+  <p:clrMapOvr>
+    <a:masterClrMapping/>
+  </p:clrMapOvr>
+</p:sld>
+</file>
+
+<file path=ppt/slides/slide11.xml><?xml version="1.0" encoding="utf-8"?>
+<p:sld xmlns:a="http://schemas.openxmlformats.org/drawingml/2006/main" xmlns:p="http://schemas.openxmlformats.org/presentationml/2006/main" xmlns:r="http://schemas.openxmlformats.org/officeDocument/2006/relationships">
+  <p:cSld>
+    <p:bg>
+      <p:bgPr>
+        <a:solidFill>
+          <a:srgbClr val="0E141B"/>
+        </a:solidFill>
+        <a:effectLst/>
+      </p:bgPr>
+    </p:bg>
+    <p:spTree>
+      <p:nvGrpSpPr>
+        <p:cNvPr id="1" name=""/>
+        <p:cNvGrpSpPr/>
+        <p:nvPr/>
+      </p:nvGrpSpPr>
+      <p:grpSpPr/>
+      <p:sp>
+        <p:nvSpPr>
+          <p:cNvPr id="2" name="Rectangle 1"/>
+          <p:cNvSpPr/>
+          <p:nvPr/>
+        </p:nvSpPr>
+        <p:spPr>
+          <a:xfrm>
+            <a:off x="0" y="0"/>
+            <a:ext cx="100584" cy="6858000"/>
+          </a:xfrm>
+          <a:prstGeom prst="rect">
+            <a:avLst/>
+          </a:prstGeom>
+          <a:solidFill>
+            <a:srgbClr val="36D399"/>
+          </a:solidFill>
+          <a:ln>
+            <a:noFill/>
+          </a:ln>
+        </p:spPr>
+        <p:style>
+          <a:lnRef idx="1">
+            <a:schemeClr val="accent1"/>
+          </a:lnRef>
+          <a:fillRef idx="3">
+            <a:schemeClr val="accent1"/>
+          </a:fillRef>
+          <a:effectRef idx="2">
+            <a:schemeClr val="accent1"/>
+          </a:effectRef>
+          <a:fontRef idx="minor">
+            <a:schemeClr val="lt1"/>
+          </a:fontRef>
+        </p:style>
+        <p:txBody>
+          <a:bodyPr rtlCol="0" anchor="ctr"/>
+          <a:lstStyle/>
+          <a:p>
+            <a:pPr algn="ctr"/>
+          </a:p>
+        </p:txBody>
+      </p:sp>
+      <p:sp>
+        <p:nvSpPr>
+          <p:cNvPr id="3" name="audit:index"/>
+          <p:cNvSpPr txBox="1"/>
+          <p:nvPr/>
+        </p:nvSpPr>
+        <p:spPr>
+          <a:xfrm>
+            <a:off x="640080" y="274320"/>
+            <a:ext cx="4572000" cy="274320"/>
+          </a:xfrm>
+          <a:prstGeom prst="rect">
+            <a:avLst/>
+          </a:prstGeom>
+          <a:noFill/>
+        </p:spPr>
+        <p:txBody>
+          <a:bodyPr wrap="square" lIns="0" rIns="0" tIns="0" bIns="0">
+            <a:spAutoFit/>
+          </a:bodyPr>
+          <a:lstStyle/>
+          <a:p>
+            <a:r>
+              <a:rPr sz="1100" b="0">
+                <a:solidFill>
+                  <a:srgbClr val="93A4B5"/>
+                </a:solidFill>
+                <a:latin typeface="NanumGothic"/>
+                <a:ea typeface="NanumGothic"/>
+                <a:cs typeface="NanumGothic"/>
+              </a:rPr>
+              <a:t>TOKEN COST LAB  /  11</a:t>
+            </a:r>
+          </a:p>
+        </p:txBody>
+      </p:sp>
+      <p:sp>
+        <p:nvSpPr>
+          <p:cNvPr id="4" name="audit:scope"/>
+          <p:cNvSpPr txBox="1"/>
+          <p:nvPr/>
+        </p:nvSpPr>
+        <p:spPr>
+          <a:xfrm>
+            <a:off x="5760720" y="274320"/>
+            <a:ext cx="5760720" cy="274320"/>
+          </a:xfrm>
+          <a:prstGeom prst="rect">
+            <a:avLst/>
+          </a:prstGeom>
+          <a:noFill/>
+        </p:spPr>
+        <p:txBody>
+          <a:bodyPr wrap="square" lIns="0" rIns="0" tIns="0" bIns="0">
+            <a:spAutoFit/>
+          </a:bodyPr>
+          <a:lstStyle/>
+          <a:p>
+            <a:r>
+              <a:rPr sz="1100" b="0">
+                <a:solidFill>
+                  <a:srgbClr val="36D399"/>
+                </a:solidFill>
+                <a:latin typeface="NanumGothic"/>
+                <a:ea typeface="NanumGothic"/>
+                <a:cs typeface="NanumGothic"/>
+              </a:rPr>
+              <a:t>외부 보고의 범위 제한</a:t>
+            </a:r>
+          </a:p>
+        </p:txBody>
+      </p:sp>
+      <p:sp>
+        <p:nvSpPr>
+          <p:cNvPr id="5" name="audit:title"/>
+          <p:cNvSpPr txBox="1"/>
+          <p:nvPr/>
+        </p:nvSpPr>
+        <p:spPr>
+          <a:xfrm>
+            <a:off x="640080" y="822960"/>
+            <a:ext cx="10881360" cy="822960"/>
+          </a:xfrm>
+          <a:prstGeom prst="rect">
+            <a:avLst/>
+          </a:prstGeom>
+          <a:noFill/>
+        </p:spPr>
+        <p:txBody>
+          <a:bodyPr wrap="square" lIns="0" rIns="0" tIns="0" bIns="0">
+            <a:spAutoFit/>
+          </a:bodyPr>
+          <a:lstStyle/>
+          <a:p>
+            <a:r>
+              <a:rPr sz="2900" b="1">
+                <a:solidFill>
+                  <a:srgbClr val="ECF1F6"/>
+                </a:solidFill>
+                <a:latin typeface="NanumGothic"/>
+                <a:ea typeface="NanumGothic"/>
+                <a:cs typeface="NanumGothic"/>
+              </a:rPr>
+              <a:t>반례의 비교 대상을 정확히 읽는다</a:t>
+            </a:r>
+          </a:p>
+        </p:txBody>
+      </p:sp>
+      <p:sp>
+        <p:nvSpPr>
+          <p:cNvPr id="6" name="audit:hero"/>
+          <p:cNvSpPr txBox="1"/>
+          <p:nvPr/>
+        </p:nvSpPr>
+        <p:spPr>
+          <a:xfrm>
+            <a:off x="640080" y="1783080"/>
+            <a:ext cx="10881360" cy="777240"/>
+          </a:xfrm>
+          <a:prstGeom prst="rect">
+            <a:avLst/>
+          </a:prstGeom>
+          <a:noFill/>
+        </p:spPr>
+        <p:txBody>
+          <a:bodyPr wrap="square" lIns="0" rIns="0" tIns="0" bIns="0">
+            <a:spAutoFit/>
+          </a:bodyPr>
+          <a:lstStyle/>
+          <a:p>
+            <a:r>
+              <a:rPr sz="2900" b="1">
+                <a:solidFill>
+                  <a:srgbClr val="36D399"/>
+                </a:solidFill>
+                <a:latin typeface="NanumGothic"/>
+                <a:ea typeface="NanumGothic"/>
+                <a:cs typeface="NanumGothic"/>
+              </a:rPr>
+              <a:t>SDD 도구 간 비교 ≠ SDD 대 무스펙</a:t>
+            </a:r>
+          </a:p>
+        </p:txBody>
+      </p:sp>
+      <p:sp>
+        <p:nvSpPr>
+          <p:cNvPr id="7" name="audit:body-0"/>
+          <p:cNvSpPr txBox="1"/>
+          <p:nvPr/>
+        </p:nvSpPr>
+        <p:spPr>
+          <a:xfrm>
+            <a:off x="777240" y="2862072"/>
+            <a:ext cx="10652760" cy="612648"/>
+          </a:xfrm>
+          <a:prstGeom prst="rect">
+            <a:avLst/>
+          </a:prstGeom>
+          <a:noFill/>
+        </p:spPr>
+        <p:txBody>
+          <a:bodyPr wrap="square" lIns="0" rIns="0" tIns="0" bIns="0">
+            <a:spAutoFit/>
+          </a:bodyPr>
+          <a:lstStyle/>
+          <a:p>
+            <a:r>
+              <a:rPr sz="1750" b="0">
+                <a:solidFill>
+                  <a:srgbClr val="ECF1F6"/>
+                </a:solidFill>
+                <a:latin typeface="NanumGothic"/>
+                <a:ea typeface="NanumGothic"/>
+                <a:cs typeface="NanumGothic"/>
+              </a:rPr>
+              <a:t>Spec-Kit +97~109%: OpenSpec 대비 두 사례의 외부 블로그 보고. 둘 다 SDD 접근.</a:t>
+            </a:r>
+          </a:p>
+        </p:txBody>
+      </p:sp>
+      <p:sp>
+        <p:nvSpPr>
+          <p:cNvPr id="8" name="audit:body-1"/>
+          <p:cNvSpPr txBox="1"/>
+          <p:nvPr/>
+        </p:nvSpPr>
+        <p:spPr>
+          <a:xfrm>
+            <a:off x="777240" y="3502152"/>
+            <a:ext cx="10652760" cy="612648"/>
+          </a:xfrm>
+          <a:prstGeom prst="rect">
+            <a:avLst/>
+          </a:prstGeom>
+          <a:noFill/>
+        </p:spPr>
+        <p:txBody>
+          <a:bodyPr wrap="square" lIns="0" rIns="0" tIns="0" bIns="0">
+            <a:spAutoFit/>
+          </a:bodyPr>
+          <a:lstStyle/>
+          <a:p>
+            <a:r>
+              <a:rPr sz="1750" b="0">
+                <a:solidFill>
+                  <a:srgbClr val="ECF1F6"/>
+                </a:solidFill>
+                <a:latin typeface="NanumGothic"/>
+                <a:ea typeface="NanumGothic"/>
+                <a:cs typeface="NanumGothic"/>
+              </a:rPr>
+              <a:t>ETH AGENTS.md 연구: 저장소 컨텍스트 파일 조건. 모든 짧은 스펙이 손해라는 실험 아님.</a:t>
+            </a:r>
+          </a:p>
+        </p:txBody>
+      </p:sp>
+      <p:sp>
+        <p:nvSpPr>
+          <p:cNvPr id="9" name="audit:body-2"/>
+          <p:cNvSpPr txBox="1"/>
+          <p:nvPr/>
+        </p:nvSpPr>
+        <p:spPr>
+          <a:xfrm>
+            <a:off x="777240" y="4142231"/>
+            <a:ext cx="10652760" cy="612648"/>
+          </a:xfrm>
+          <a:prstGeom prst="rect">
+            <a:avLst/>
+          </a:prstGeom>
+          <a:noFill/>
+        </p:spPr>
+        <p:txBody>
+          <a:bodyPr wrap="square" lIns="0" rIns="0" tIns="0" bIns="0">
+            <a:spAutoFit/>
+          </a:bodyPr>
+          <a:lstStyle/>
+          <a:p>
+            <a:r>
+              <a:rPr sz="1750" b="0">
+                <a:solidFill>
+                  <a:srgbClr val="ECF1F6"/>
+                </a:solidFill>
+                <a:latin typeface="NanumGothic"/>
+                <a:ea typeface="NanumGothic"/>
+                <a:cs typeface="NanumGothic"/>
+              </a:rPr>
+              <a:t>짧고 필요한 요구사항만 쓰라는 실무 원칙은 유지하되 효과를 직접 측정한다.</a:t>
+            </a:r>
+          </a:p>
+        </p:txBody>
+      </p:sp>
+      <p:sp>
+        <p:nvSpPr>
+          <p:cNvPr id="10" name="audit:source"/>
+          <p:cNvSpPr txBox="1"/>
+          <p:nvPr/>
+        </p:nvSpPr>
+        <p:spPr>
+          <a:xfrm>
+            <a:off x="640080" y="6080760"/>
+            <a:ext cx="10972800" cy="274320"/>
+          </a:xfrm>
+          <a:prstGeom prst="rect">
+            <a:avLst/>
+          </a:prstGeom>
+          <a:noFill/>
+        </p:spPr>
+        <p:txBody>
+          <a:bodyPr wrap="square" lIns="0" rIns="0" tIns="0" bIns="0">
+            <a:spAutoFit/>
+          </a:bodyPr>
+          <a:lstStyle/>
+          <a:p>
+            <a:r>
+              <a:rPr sz="1000" b="0">
+                <a:solidFill>
+                  <a:srgbClr val="93A4B5"/>
+                </a:solidFill>
+                <a:latin typeface="NanumGothic"/>
+                <a:ea typeface="NanumGothic"/>
+                <a:cs typeface="NanumGothic"/>
+              </a:rPr>
+              <a:t>SOURCES.md §4 · arxiv.org/html/2602.11988v1</a:t>
+            </a:r>
+          </a:p>
+        </p:txBody>
+      </p:sp>
+      <p:sp>
+        <p:nvSpPr>
+          <p:cNvPr id="11" name="audit:footer"/>
+          <p:cNvSpPr txBox="1"/>
+          <p:nvPr/>
+        </p:nvSpPr>
+        <p:spPr>
+          <a:xfrm>
+            <a:off x="640080" y="6419088"/>
+            <a:ext cx="10972800" cy="256032"/>
+          </a:xfrm>
+          <a:prstGeom prst="rect">
+            <a:avLst/>
+          </a:prstGeom>
+          <a:noFill/>
+        </p:spPr>
+        <p:txBody>
+          <a:bodyPr wrap="square" lIns="0" rIns="0" tIns="0" bIns="0">
+            <a:spAutoFit/>
+          </a:bodyPr>
+          <a:lstStyle/>
+          <a:p>
+            <a:r>
+              <a:rPr sz="1000" b="0">
+                <a:solidFill>
+                  <a:srgbClr val="93A4B5"/>
+                </a:solidFill>
+                <a:latin typeface="NanumGothic"/>
+                <a:ea typeface="NanumGothic"/>
+                <a:cs typeface="NanumGothic"/>
+              </a:rPr>
+              <a:t>2026-09-20  ·  근거와 조건을 함께 인용</a:t>
+            </a:r>
+          </a:p>
+        </p:txBody>
+      </p:sp>
+    </p:spTree>
+  </p:cSld>
+  <p:clrMapOvr>
+    <a:masterClrMapping/>
+  </p:clrMapOvr>
+</p:sld>
+</file>
+
+<file path=ppt/slides/slide12.xml><?xml version="1.0" encoding="utf-8"?>
+<p:sld xmlns:a="http://schemas.openxmlformats.org/drawingml/2006/main" xmlns:p="http://schemas.openxmlformats.org/presentationml/2006/main" xmlns:r="http://schemas.openxmlformats.org/officeDocument/2006/relationships">
+  <p:cSld>
+    <p:bg>
+      <p:bgPr>
+        <a:solidFill>
+          <a:srgbClr val="0E141B"/>
+        </a:solidFill>
+        <a:effectLst/>
+      </p:bgPr>
+    </p:bg>
+    <p:spTree>
+      <p:nvGrpSpPr>
+        <p:cNvPr id="1" name=""/>
+        <p:cNvGrpSpPr/>
+        <p:nvPr/>
+      </p:nvGrpSpPr>
+      <p:grpSpPr/>
+      <p:sp>
+        <p:nvSpPr>
+          <p:cNvPr id="2" name="Rectangle 1"/>
+          <p:cNvSpPr/>
+          <p:nvPr/>
+        </p:nvSpPr>
+        <p:spPr>
+          <a:xfrm>
+            <a:off x="0" y="0"/>
+            <a:ext cx="100584" cy="6858000"/>
+          </a:xfrm>
+          <a:prstGeom prst="rect">
+            <a:avLst/>
+          </a:prstGeom>
+          <a:solidFill>
+            <a:srgbClr val="36D399"/>
+          </a:solidFill>
+          <a:ln>
+            <a:noFill/>
+          </a:ln>
+        </p:spPr>
+        <p:style>
+          <a:lnRef idx="1">
+            <a:schemeClr val="accent1"/>
+          </a:lnRef>
+          <a:fillRef idx="3">
+            <a:schemeClr val="accent1"/>
+          </a:fillRef>
+          <a:effectRef idx="2">
+            <a:schemeClr val="accent1"/>
+          </a:effectRef>
+          <a:fontRef idx="minor">
+            <a:schemeClr val="lt1"/>
+          </a:fontRef>
+        </p:style>
+        <p:txBody>
+          <a:bodyPr rtlCol="0" anchor="ctr"/>
+          <a:lstStyle/>
+          <a:p>
+            <a:pPr algn="ctr"/>
+          </a:p>
+        </p:txBody>
+      </p:sp>
+      <p:sp>
+        <p:nvSpPr>
+          <p:cNvPr id="3" name="audit:index"/>
+          <p:cNvSpPr txBox="1"/>
+          <p:nvPr/>
+        </p:nvSpPr>
+        <p:spPr>
+          <a:xfrm>
+            <a:off x="640080" y="274320"/>
+            <a:ext cx="4572000" cy="274320"/>
+          </a:xfrm>
+          <a:prstGeom prst="rect">
+            <a:avLst/>
+          </a:prstGeom>
+          <a:noFill/>
+        </p:spPr>
+        <p:txBody>
+          <a:bodyPr wrap="square" lIns="0" rIns="0" tIns="0" bIns="0">
+            <a:spAutoFit/>
+          </a:bodyPr>
+          <a:lstStyle/>
+          <a:p>
+            <a:r>
+              <a:rPr sz="1100" b="0">
+                <a:solidFill>
+                  <a:srgbClr val="93A4B5"/>
+                </a:solidFill>
+                <a:latin typeface="NanumGothic"/>
+                <a:ea typeface="NanumGothic"/>
+                <a:cs typeface="NanumGothic"/>
+              </a:rPr>
+              <a:t>TOKEN COST LAB  /  12</a:t>
+            </a:r>
+          </a:p>
+        </p:txBody>
+      </p:sp>
+      <p:sp>
+        <p:nvSpPr>
+          <p:cNvPr id="4" name="audit:scope"/>
+          <p:cNvSpPr txBox="1"/>
+          <p:nvPr/>
+        </p:nvSpPr>
+        <p:spPr>
+          <a:xfrm>
+            <a:off x="5760720" y="274320"/>
+            <a:ext cx="5760720" cy="274320"/>
+          </a:xfrm>
+          <a:prstGeom prst="rect">
+            <a:avLst/>
+          </a:prstGeom>
+          <a:noFill/>
+        </p:spPr>
+        <p:txBody>
+          <a:bodyPr wrap="square" lIns="0" rIns="0" tIns="0" bIns="0">
+            <a:spAutoFit/>
+          </a:bodyPr>
+          <a:lstStyle/>
+          <a:p>
+            <a:r>
+              <a:rPr sz="1100" b="0">
+                <a:solidFill>
+                  <a:srgbClr val="36D399"/>
+                </a:solidFill>
+                <a:latin typeface="NanumGothic"/>
+                <a:ea typeface="NanumGothic"/>
+                <a:cs typeface="NanumGothic"/>
+              </a:rPr>
+              <a:t>후속 계획 / 미실행</a:t>
+            </a:r>
+          </a:p>
+        </p:txBody>
+      </p:sp>
+      <p:sp>
+        <p:nvSpPr>
+          <p:cNvPr id="5" name="audit:title"/>
+          <p:cNvSpPr txBox="1"/>
+          <p:nvPr/>
+        </p:nvSpPr>
+        <p:spPr>
+          <a:xfrm>
+            <a:off x="640080" y="822960"/>
+            <a:ext cx="10881360" cy="822960"/>
+          </a:xfrm>
+          <a:prstGeom prst="rect">
+            <a:avLst/>
+          </a:prstGeom>
+          <a:noFill/>
+        </p:spPr>
+        <p:txBody>
+          <a:bodyPr wrap="square" lIns="0" rIns="0" tIns="0" bIns="0">
+            <a:spAutoFit/>
+          </a:bodyPr>
+          <a:lstStyle/>
+          <a:p>
+            <a:r>
+              <a:rPr sz="2900" b="1">
+                <a:solidFill>
+                  <a:srgbClr val="ECF1F6"/>
+                </a:solidFill>
+                <a:latin typeface="NanumGothic"/>
+                <a:ea typeface="NanumGothic"/>
+                <a:cs typeface="NanumGothic"/>
+              </a:rPr>
+              <a:t>다음 실험: 스펙이 재작업을 줄이는가</a:t>
+            </a:r>
+          </a:p>
+        </p:txBody>
+      </p:sp>
+      <p:sp>
+        <p:nvSpPr>
+          <p:cNvPr id="6" name="audit:hero"/>
+          <p:cNvSpPr txBox="1"/>
+          <p:nvPr/>
+        </p:nvSpPr>
+        <p:spPr>
+          <a:xfrm>
+            <a:off x="640080" y="1783080"/>
+            <a:ext cx="10881360" cy="777240"/>
+          </a:xfrm>
+          <a:prstGeom prst="rect">
+            <a:avLst/>
+          </a:prstGeom>
+          <a:noFill/>
+        </p:spPr>
+        <p:txBody>
+          <a:bodyPr wrap="square" lIns="0" rIns="0" tIns="0" bIns="0">
+            <a:spAutoFit/>
+          </a:bodyPr>
+          <a:lstStyle/>
+          <a:p>
+            <a:r>
+              <a:rPr sz="2900" b="1">
+                <a:solidFill>
+                  <a:srgbClr val="36D399"/>
+                </a:solidFill>
+                <a:latin typeface="NanumGothic"/>
+                <a:ea typeface="NanumGothic"/>
+                <a:cs typeface="NanumGothic"/>
+              </a:rPr>
+              <a:t>사전등록된 품질·비용 비교</a:t>
+            </a:r>
+          </a:p>
+        </p:txBody>
+      </p:sp>
+      <p:sp>
+        <p:nvSpPr>
+          <p:cNvPr id="7" name="audit:body-0"/>
+          <p:cNvSpPr txBox="1"/>
+          <p:nvPr/>
+        </p:nvSpPr>
+        <p:spPr>
+          <a:xfrm>
+            <a:off x="777240" y="2862072"/>
+            <a:ext cx="10652760" cy="612648"/>
+          </a:xfrm>
+          <a:prstGeom prst="rect">
+            <a:avLst/>
+          </a:prstGeom>
+          <a:noFill/>
+        </p:spPr>
+        <p:txBody>
+          <a:bodyPr wrap="square" lIns="0" rIns="0" tIns="0" bIns="0">
+            <a:spAutoFit/>
+          </a:bodyPr>
+          <a:lstStyle/>
+          <a:p>
+            <a:r>
+              <a:rPr sz="1750" b="0">
+                <a:solidFill>
+                  <a:srgbClr val="ECF1F6"/>
+                </a:solidFill>
+                <a:latin typeface="NanumGothic"/>
+                <a:ea typeface="NanumGothic"/>
+                <a:cs typeface="NanumGothic"/>
+              </a:rPr>
+              <a:t>백지 스펙 작성 비용부터 포함하고 다수 과제를 무작위 배정한다.</a:t>
+            </a:r>
+          </a:p>
+        </p:txBody>
+      </p:sp>
+      <p:sp>
+        <p:nvSpPr>
+          <p:cNvPr id="8" name="audit:body-1"/>
+          <p:cNvSpPr txBox="1"/>
+          <p:nvPr/>
+        </p:nvSpPr>
+        <p:spPr>
+          <a:xfrm>
+            <a:off x="777240" y="3502152"/>
+            <a:ext cx="10652760" cy="612648"/>
+          </a:xfrm>
+          <a:prstGeom prst="rect">
+            <a:avLst/>
+          </a:prstGeom>
+          <a:noFill/>
+        </p:spPr>
+        <p:txBody>
+          <a:bodyPr wrap="square" lIns="0" rIns="0" tIns="0" bIns="0">
+            <a:spAutoFit/>
+          </a:bodyPr>
+          <a:lstStyle/>
+          <a:p>
+            <a:r>
+              <a:rPr sz="1750" b="0">
+                <a:solidFill>
+                  <a:srgbClr val="ECF1F6"/>
+                </a:solidFill>
+                <a:latin typeface="NanumGothic"/>
+                <a:ea typeface="NanumGothic"/>
+                <a:cs typeface="NanumGothic"/>
+              </a:rPr>
+              <a:t>같은 AC·모델·출력 예산·가격·캐시 조건으로 성공률과 총비용을 기록한다.</a:t>
+            </a:r>
+          </a:p>
+        </p:txBody>
+      </p:sp>
+      <p:sp>
+        <p:nvSpPr>
+          <p:cNvPr id="9" name="audit:body-2"/>
+          <p:cNvSpPr txBox="1"/>
+          <p:nvPr/>
+        </p:nvSpPr>
+        <p:spPr>
+          <a:xfrm>
+            <a:off x="777240" y="4142231"/>
+            <a:ext cx="10652760" cy="612648"/>
+          </a:xfrm>
+          <a:prstGeom prst="rect">
+            <a:avLst/>
+          </a:prstGeom>
+          <a:noFill/>
+        </p:spPr>
+        <p:txBody>
+          <a:bodyPr wrap="square" lIns="0" rIns="0" tIns="0" bIns="0">
+            <a:spAutoFit/>
+          </a:bodyPr>
+          <a:lstStyle/>
+          <a:p>
+            <a:r>
+              <a:rPr sz="1750" b="0">
+                <a:solidFill>
+                  <a:srgbClr val="ECF1F6"/>
+                </a:solidFill>
+                <a:latin typeface="NanumGothic"/>
+                <a:ea typeface="NanumGothic"/>
+                <a:cs typeface="NanumGothic"/>
+              </a:rPr>
+              <a:t>진행하지 않은 실험의 절감률은 결과로 채우지 않는다.</a:t>
+            </a:r>
+          </a:p>
+        </p:txBody>
+      </p:sp>
+      <p:sp>
+        <p:nvSpPr>
+          <p:cNvPr id="10" name="audit:source"/>
+          <p:cNvSpPr txBox="1"/>
+          <p:nvPr/>
+        </p:nvSpPr>
+        <p:spPr>
+          <a:xfrm>
+            <a:off x="640080" y="6080760"/>
+            <a:ext cx="10972800" cy="274320"/>
+          </a:xfrm>
+          <a:prstGeom prst="rect">
+            <a:avLst/>
+          </a:prstGeom>
+          <a:noFill/>
+        </p:spPr>
+        <p:txBody>
+          <a:bodyPr wrap="square" lIns="0" rIns="0" tIns="0" bIns="0">
+            <a:spAutoFit/>
+          </a:bodyPr>
+          <a:lstStyle/>
+          <a:p>
+            <a:r>
+              <a:rPr sz="1000" b="0">
+                <a:solidFill>
+                  <a:srgbClr val="93A4B5"/>
+                </a:solidFill>
+                <a:latin typeface="NanumGothic"/>
+                <a:ea typeface="NanumGothic"/>
+                <a:cs typeface="NanumGothic"/>
+              </a:rPr>
+              <a:t>demo/vibe_vs_spec/EXPERIMENT_A_PROTOCOL.md</a:t>
+            </a:r>
+          </a:p>
+        </p:txBody>
+      </p:sp>
+      <p:sp>
+        <p:nvSpPr>
+          <p:cNvPr id="11" name="audit:footer"/>
+          <p:cNvSpPr txBox="1"/>
+          <p:nvPr/>
+        </p:nvSpPr>
+        <p:spPr>
+          <a:xfrm>
+            <a:off x="640080" y="6419088"/>
+            <a:ext cx="10972800" cy="256032"/>
+          </a:xfrm>
+          <a:prstGeom prst="rect">
+            <a:avLst/>
+          </a:prstGeom>
+          <a:noFill/>
+        </p:spPr>
+        <p:txBody>
+          <a:bodyPr wrap="square" lIns="0" rIns="0" tIns="0" bIns="0">
+            <a:spAutoFit/>
+          </a:bodyPr>
+          <a:lstStyle/>
+          <a:p>
+            <a:r>
+              <a:rPr sz="1000" b="0">
+                <a:solidFill>
+                  <a:srgbClr val="93A4B5"/>
+                </a:solidFill>
+                <a:latin typeface="NanumGothic"/>
+                <a:ea typeface="NanumGothic"/>
+                <a:cs typeface="NanumGothic"/>
+              </a:rPr>
+              <a:t>2026-09-20  ·  근거와 조건을 함께 인용</a:t>
+            </a:r>
+          </a:p>
+        </p:txBody>
+      </p:sp>
+    </p:spTree>
+  </p:cSld>
+  <p:clrMapOvr>
+    <a:masterClrMapping/>
+  </p:clrMapOvr>
+</p:sld>
+</file>
+
 <file path=ppt/slides/slide2.xml><?xml version="1.0" encoding="utf-8"?>
 <p:sld xmlns:a="http://schemas.openxmlformats.org/drawingml/2006/main" xmlns:p="http://schemas.openxmlformats.org/presentationml/2006/main" xmlns:r="http://schemas.openxmlformats.org/officeDocument/2006/relationships">
   <p:cSld>
@@ -5165,7 +6657,7 @@
                 <a:ea typeface="NanumGothic"/>
                 <a:cs typeface="NanumGothic"/>
               </a:rPr>
-              <a:t>추정치 재계산</a:t>
+              <a:t>산출물 스크린샷</a:t>
             </a:r>
           </a:p>
         </p:txBody>
@@ -5201,7 +6693,7 @@
                 <a:ea typeface="NanumGothic"/>
                 <a:cs typeface="NanumGothic"/>
               </a:rPr>
-              <a:t>입력이 늘고 비싼 출력이 줄었다</a:t>
+              <a:t>두 산출물의 첫 화면</a:t>
             </a:r>
           </a:p>
         </p:txBody>
@@ -5237,7 +6729,7 @@
                 <a:ea typeface="NanumGothic"/>
                 <a:cs typeface="NanumGothic"/>
               </a:rPr>
-              <a:t>+666 / -680 / +156</a:t>
+              <a:t>같은 목표, 다른 생성 과정</a:t>
             </a:r>
           </a:p>
         </p:txBody>
@@ -5251,7 +6743,7 @@
         <p:spPr>
           <a:xfrm>
             <a:off x="777240" y="2862072"/>
-            <a:ext cx="10652760" cy="612648"/>
+            <a:ext cx="6400800" cy="612648"/>
           </a:xfrm>
           <a:prstGeom prst="rect">
             <a:avLst/>
@@ -5273,7 +6765,7 @@
                 <a:ea typeface="NanumGothic"/>
                 <a:cs typeface="NanumGothic"/>
               </a:rPr>
-              <a:t>입력 +666, 추론+출력 -680, 캐시 +156 (추정값 고정)</a:t>
+              <a:t>두 장 모두 실제 생성 HTML을 Chromium 1280px에서 캡처한 화면이다.</a:t>
             </a:r>
           </a:p>
         </p:txBody>
@@ -5287,7 +6779,7 @@
         <p:spPr>
           <a:xfrm>
             <a:off x="777240" y="3502152"/>
-            <a:ext cx="10652760" cy="612648"/>
+            <a:ext cx="6400800" cy="612648"/>
           </a:xfrm>
           <a:prstGeom prst="rect">
             <a:avLst/>
@@ -5309,21 +6801,45 @@
                 <a:ea typeface="NanumGothic"/>
                 <a:cs typeface="NanumGothic"/>
               </a:rPr>
-              <a:t>이 케이스에서 input과 cache는 서로 겹치지 않는 버킷으로 정의했다.</a:t>
-            </a:r>
-          </a:p>
-        </p:txBody>
-      </p:sp>
-      <p:sp>
-        <p:nvSpPr>
-          <p:cNvPr id="9" name="audit:body-2"/>
+              <a:t>보이는 화면이 비슷하다는 것이 품질 동등성의 증거는 아니다.</a:t>
+            </a:r>
+          </a:p>
+        </p:txBody>
+      </p:sp>
+      <p:pic>
+        <p:nvPicPr>
+          <p:cNvPr id="9" name="Picture 8" descr="vibe_top.png"/>
+          <p:cNvPicPr>
+            <a:picLocks noChangeAspect="1"/>
+          </p:cNvPicPr>
+          <p:nvPr/>
+        </p:nvPicPr>
+        <p:blipFill>
+          <a:blip r:embed="rId2"/>
+          <a:stretch>
+            <a:fillRect/>
+          </a:stretch>
+        </p:blipFill>
+        <p:spPr>
+          <a:xfrm>
+            <a:off x="8180222" y="2103120"/>
+            <a:ext cx="2567635" cy="1604772"/>
+          </a:xfrm>
+          <a:prstGeom prst="rect">
+            <a:avLst/>
+          </a:prstGeom>
+        </p:spPr>
+      </p:pic>
+      <p:sp>
+        <p:nvSpPr>
+          <p:cNvPr id="10" name="audit:image-caption-0"/>
           <p:cNvSpPr txBox="1"/>
           <p:nvPr/>
         </p:nvSpPr>
         <p:spPr>
           <a:xfrm>
-            <a:off x="777240" y="4142231"/>
-            <a:ext cx="10652760" cy="612648"/>
+            <a:off x="7360920" y="3726180"/>
+            <a:ext cx="4206240" cy="256032"/>
           </a:xfrm>
           <a:prstGeom prst="rect">
             <a:avLst/>
@@ -5337,29 +6853,53 @@
           <a:lstStyle/>
           <a:p>
             <a:r>
-              <a:rPr sz="1750" b="0">
-                <a:solidFill>
-                  <a:srgbClr val="ECF1F6"/>
+              <a:rPr sz="950" b="0">
+                <a:solidFill>
+                  <a:srgbClr val="93A4B5"/>
                 </a:solidFill>
                 <a:latin typeface="NanumGothic"/>
                 <a:ea typeface="NanumGothic"/>
                 <a:cs typeface="NanumGothic"/>
               </a:rPr>
-              <a:t>벤더 usage 필드 이름과 동일하다고 가정하면 이중 계상할 수 있다.</a:t>
-            </a:r>
-          </a:p>
-        </p:txBody>
-      </p:sp>
-      <p:sp>
-        <p:nvSpPr>
-          <p:cNvPr id="10" name="audit:source"/>
+              <a:t>위: Vibe 산출물 첫 화면 (1280px)</a:t>
+            </a:r>
+          </a:p>
+        </p:txBody>
+      </p:sp>
+      <p:pic>
+        <p:nvPicPr>
+          <p:cNvPr id="11" name="Picture 10" descr="spec_top.png"/>
+          <p:cNvPicPr>
+            <a:picLocks noChangeAspect="1"/>
+          </p:cNvPicPr>
+          <p:nvPr/>
+        </p:nvPicPr>
+        <p:blipFill>
+          <a:blip r:embed="rId3"/>
+          <a:stretch>
+            <a:fillRect/>
+          </a:stretch>
+        </p:blipFill>
+        <p:spPr>
+          <a:xfrm>
+            <a:off x="8180222" y="4000500"/>
+            <a:ext cx="2567635" cy="1604772"/>
+          </a:xfrm>
+          <a:prstGeom prst="rect">
+            <a:avLst/>
+          </a:prstGeom>
+        </p:spPr>
+      </p:pic>
+      <p:sp>
+        <p:nvSpPr>
+          <p:cNvPr id="12" name="audit:image-caption-1"/>
           <p:cNvSpPr txBox="1"/>
           <p:nvPr/>
         </p:nvSpPr>
         <p:spPr>
           <a:xfrm>
-            <a:off x="640080" y="6080760"/>
-            <a:ext cx="10972800" cy="274320"/>
+            <a:off x="7360920" y="5623560"/>
+            <a:ext cx="4206240" cy="256032"/>
           </a:xfrm>
           <a:prstGeom prst="rect">
             <a:avLst/>
@@ -5373,7 +6913,7 @@
           <a:lstStyle/>
           <a:p>
             <a:r>
-              <a:rPr sz="1000" b="0">
+              <a:rPr sz="950" b="0">
                 <a:solidFill>
                   <a:srgbClr val="93A4B5"/>
                 </a:solidFill>
@@ -5381,14 +6921,50 @@
                 <a:ea typeface="NanumGothic"/>
                 <a:cs typeface="NanumGothic"/>
               </a:rPr>
-              <a:t>demo/vibe_vs_spec/usage.json</a:t>
-            </a:r>
-          </a:p>
-        </p:txBody>
-      </p:sp>
-      <p:sp>
-        <p:nvSpPr>
-          <p:cNvPr id="11" name="audit:footer"/>
+              <a:t>아래: Spec 산출물 첫 화면 (1280px)</a:t>
+            </a:r>
+          </a:p>
+        </p:txBody>
+      </p:sp>
+      <p:sp>
+        <p:nvSpPr>
+          <p:cNvPr id="13" name="audit:source"/>
+          <p:cNvSpPr txBox="1"/>
+          <p:nvPr/>
+        </p:nvSpPr>
+        <p:spPr>
+          <a:xfrm>
+            <a:off x="640080" y="6080760"/>
+            <a:ext cx="10972800" cy="274320"/>
+          </a:xfrm>
+          <a:prstGeom prst="rect">
+            <a:avLst/>
+          </a:prstGeom>
+          <a:noFill/>
+        </p:spPr>
+        <p:txBody>
+          <a:bodyPr wrap="square" lIns="0" rIns="0" tIns="0" bIns="0">
+            <a:spAutoFit/>
+          </a:bodyPr>
+          <a:lstStyle/>
+          <a:p>
+            <a:r>
+              <a:rPr sz="1000" b="0">
+                <a:solidFill>
+                  <a:srgbClr val="93A4B5"/>
+                </a:solidFill>
+                <a:latin typeface="NanumGothic"/>
+                <a:ea typeface="NanumGothic"/>
+                <a:cs typeface="NanumGothic"/>
+              </a:rPr>
+              <a:t>demo/vibe_vs_spec/shots/vibe_top.png · demo/vibe_vs_spec/shots/spec_top.png</a:t>
+            </a:r>
+          </a:p>
+        </p:txBody>
+      </p:sp>
+      <p:sp>
+        <p:nvSpPr>
+          <p:cNvPr id="14" name="audit:footer"/>
           <p:cNvSpPr txBox="1"/>
           <p:nvPr/>
         </p:nvSpPr>
@@ -5558,7 +7134,7 @@
                 <a:ea typeface="NanumGothic"/>
                 <a:cs typeface="NanumGothic"/>
               </a:rPr>
-              <a:t>단가 민감도</a:t>
+              <a:t>반응형 스크린샷</a:t>
             </a:r>
           </a:p>
         </p:txBody>
@@ -5594,7 +7170,7 @@
                 <a:ea typeface="NanumGothic"/>
                 <a:cs typeface="NanumGothic"/>
               </a:rPr>
-              <a:t>단가비가 손익을 결정한다</a:t>
+              <a:t>모바일 390px에서도 같은 1열</a:t>
             </a:r>
           </a:p>
         </p:txBody>
@@ -5630,7 +7206,7 @@
                 <a:ea typeface="NanumGothic"/>
                 <a:cs typeface="NanumGothic"/>
               </a:rPr>
-              <a:t>r &gt; (666 + 156h) / 680</a:t>
+              <a:t>정적 문자열이 아니라 실제 렌더링</a:t>
             </a:r>
           </a:p>
         </p:txBody>
@@ -5644,7 +7220,7 @@
         <p:spPr>
           <a:xfrm>
             <a:off x="777240" y="2862072"/>
-            <a:ext cx="10652760" cy="612648"/>
+            <a:ext cx="6400800" cy="612648"/>
           </a:xfrm>
           <a:prstGeom prst="rect">
             <a:avLst/>
@@ -5666,7 +7242,7 @@
                 <a:ea typeface="NanumGothic"/>
                 <a:cs typeface="NanumGothic"/>
               </a:rPr>
-              <a:t>r = 출력/입력 단가, h = 캐시 읽기/입력 단가</a:t>
+              <a:t>문자열 검사만으로는 2열로 바뀌어도 통과한다.</a:t>
             </a:r>
           </a:p>
         </p:txBody>
@@ -5680,7 +7256,7 @@
         <p:spPr>
           <a:xfrm>
             <a:off x="777240" y="3502152"/>
-            <a:ext cx="10652760" cy="612648"/>
+            <a:ext cx="6400800" cy="612648"/>
           </a:xfrm>
           <a:prstGeom prst="rect">
             <a:avLst/>
@@ -5702,21 +7278,45 @@
                 <a:ea typeface="NanumGothic"/>
                 <a:cs typeface="NanumGothic"/>
               </a:rPr>
-              <a:t>h=0.1이면 손익분기 r=1.0024. 모든 가격 체계에서의 보편 법칙은 아니다.</a:t>
-            </a:r>
-          </a:p>
-        </p:txBody>
-      </p:sp>
-      <p:sp>
-        <p:nvSpPr>
-          <p:cNvPr id="9" name="audit:body-2"/>
+              <a:t>아래 그림은 현재 Spec 산출물을 390px에서 캡처한 것이다.</a:t>
+            </a:r>
+          </a:p>
+        </p:txBody>
+      </p:sp>
+      <p:pic>
+        <p:nvPicPr>
+          <p:cNvPr id="9" name="Picture 8" descr="spec_mobile.png"/>
+          <p:cNvPicPr>
+            <a:picLocks noChangeAspect="1"/>
+          </p:cNvPicPr>
+          <p:nvPr/>
+        </p:nvPicPr>
+        <p:blipFill>
+          <a:blip r:embed="rId2"/>
+          <a:stretch>
+            <a:fillRect/>
+          </a:stretch>
+        </p:blipFill>
+        <p:spPr>
+          <a:xfrm>
+            <a:off x="8654893" y="2103120"/>
+            <a:ext cx="1618292" cy="3502152"/>
+          </a:xfrm>
+          <a:prstGeom prst="rect">
+            <a:avLst/>
+          </a:prstGeom>
+        </p:spPr>
+      </p:pic>
+      <p:sp>
+        <p:nvSpPr>
+          <p:cNvPr id="10" name="audit:image-caption-0"/>
           <p:cNvSpPr txBox="1"/>
           <p:nvPr/>
         </p:nvSpPr>
         <p:spPr>
           <a:xfrm>
-            <a:off x="777240" y="4142231"/>
-            <a:ext cx="10652760" cy="612648"/>
+            <a:off x="7360920" y="5623560"/>
+            <a:ext cx="4206240" cy="256032"/>
           </a:xfrm>
           <a:prstGeom prst="rect">
             <a:avLst/>
@@ -5730,22 +7330,22 @@
           <a:lstStyle/>
           <a:p>
             <a:r>
-              <a:rPr sz="1750" b="0">
-                <a:solidFill>
-                  <a:srgbClr val="ECF1F6"/>
+              <a:rPr sz="950" b="0">
+                <a:solidFill>
+                  <a:srgbClr val="93A4B5"/>
                 </a:solidFill>
                 <a:latin typeface="NanumGothic"/>
                 <a:ea typeface="NanumGothic"/>
                 <a:cs typeface="NanumGothic"/>
               </a:rPr>
-              <a:t>다른 모델 단가에 고정 토큰을 대입한 감도 분석이지 다른 모델의 실호출이 아니다.</a:t>
-            </a:r>
-          </a:p>
-        </p:txBody>
-      </p:sp>
-      <p:sp>
-        <p:nvSpPr>
-          <p:cNvPr id="10" name="audit:source"/>
+              <a:t>Spec 산출물 · 390×844 캡처</a:t>
+            </a:r>
+          </a:p>
+        </p:txBody>
+      </p:sp>
+      <p:sp>
+        <p:nvSpPr>
+          <p:cNvPr id="11" name="audit:source"/>
           <p:cNvSpPr txBox="1"/>
           <p:nvPr/>
         </p:nvSpPr>
@@ -5774,14 +7374,14 @@
                 <a:ea typeface="NanumGothic"/>
                 <a:cs typeface="NanumGothic"/>
               </a:rPr>
-              <a:t>demo/vibe_vs_spec/sensitivity.py</a:t>
-            </a:r>
-          </a:p>
-        </p:txBody>
-      </p:sp>
-      <p:sp>
-        <p:nvSpPr>
-          <p:cNvPr id="11" name="audit:footer"/>
+              <a:t>demo/vibe_vs_spec/shots/spec_mobile.png</a:t>
+            </a:r>
+          </a:p>
+        </p:txBody>
+      </p:sp>
+      <p:sp>
+        <p:nvSpPr>
+          <p:cNvPr id="12" name="audit:footer"/>
           <p:cNvSpPr txBox="1"/>
           <p:nvPr/>
         </p:nvSpPr>
@@ -5951,7 +7551,7 @@
                 <a:ea typeface="NanumGothic"/>
                 <a:cs typeface="NanumGothic"/>
               </a:rPr>
-              <a:t>현재 산출물의 실행 검사</a:t>
+              <a:t>전체 페이지 축소 비교</a:t>
             </a:r>
           </a:p>
         </p:txBody>
@@ -5987,7 +7587,7 @@
                 <a:ea typeface="NanumGothic"/>
                 <a:cs typeface="NanumGothic"/>
               </a:rPr>
-              <a:t>품질 동등성 대신 실제 AC 범위를 공개</a:t>
+              <a:t>전체 페이지 길이 비교</a:t>
             </a:r>
           </a:p>
         </p:txBody>
@@ -6023,7 +7623,7 @@
                 <a:ea typeface="NanumGothic"/>
                 <a:cs typeface="NanumGothic"/>
               </a:rPr>
-              <a:t>정적 16항목 + 브라우저 29항목</a:t>
+              <a:t>세로로 긴 한 페이지, 두 산출물</a:t>
             </a:r>
           </a:p>
         </p:txBody>
@@ -6037,7 +7637,7 @@
         <p:spPr>
           <a:xfrm>
             <a:off x="777240" y="2862072"/>
-            <a:ext cx="10652760" cy="612648"/>
+            <a:ext cx="6400800" cy="612648"/>
           </a:xfrm>
           <a:prstGeom prst="rect">
             <a:avLst/>
@@ -6059,7 +7659,7 @@
                 <a:ea typeface="NanumGothic"/>
                 <a:cs typeface="NanumGothic"/>
               </a:rPr>
-              <a:t>390/820/821/1280px 그리드·메뉴 표시·가로 스크롤 검사</a:t>
+              <a:t>원본 캡처 1,280×3,400 두 장을 같은 높이로 축소해 나란히 붙였다.</a:t>
             </a:r>
           </a:p>
         </p:txBody>
@@ -6073,7 +7673,7 @@
         <p:spPr>
           <a:xfrm>
             <a:off x="777240" y="3502152"/>
-            <a:ext cx="10652760" cy="612648"/>
+            <a:ext cx="6400800" cy="612648"/>
           </a:xfrm>
           <a:prstGeom prst="rect">
             <a:avLst/>
@@ -6095,21 +7695,45 @@
                 <a:ea typeface="NanumGothic"/>
                 <a:cs typeface="NanumGothic"/>
               </a:rPr>
-              <a:t>각 카드의 내용과 세 앵커의 실제 스크롤 이동 검사</a:t>
-            </a:r>
-          </a:p>
-        </p:txBody>
-      </p:sp>
-      <p:sp>
-        <p:nvSpPr>
-          <p:cNvPr id="9" name="audit:body-2"/>
+              <a:t>스크롤 길이가 비슷하다는 사실은 비용·품질 동등성 판정이 아니다.</a:t>
+            </a:r>
+          </a:p>
+        </p:txBody>
+      </p:sp>
+      <p:pic>
+        <p:nvPicPr>
+          <p:cNvPr id="9" name="Picture 8" descr="vibe_spec_full_2up.png"/>
+          <p:cNvPicPr>
+            <a:picLocks noChangeAspect="1"/>
+          </p:cNvPicPr>
+          <p:nvPr/>
+        </p:nvPicPr>
+        <p:blipFill>
+          <a:blip r:embed="rId2"/>
+          <a:stretch>
+            <a:fillRect/>
+          </a:stretch>
+        </p:blipFill>
+        <p:spPr>
+          <a:xfrm>
+            <a:off x="8120089" y="2103120"/>
+            <a:ext cx="2687901" cy="3502152"/>
+          </a:xfrm>
+          <a:prstGeom prst="rect">
+            <a:avLst/>
+          </a:prstGeom>
+        </p:spPr>
+      </p:pic>
+      <p:sp>
+        <p:nvSpPr>
+          <p:cNvPr id="10" name="audit:image-caption-0"/>
           <p:cNvSpPr txBox="1"/>
           <p:nvPr/>
         </p:nvSpPr>
         <p:spPr>
           <a:xfrm>
-            <a:off x="777240" y="4142231"/>
-            <a:ext cx="10652760" cy="612648"/>
+            <a:off x="7360920" y="5623560"/>
+            <a:ext cx="4206240" cy="256032"/>
           </a:xfrm>
           <a:prstGeom prst="rect">
             <a:avLst/>
@@ -6123,22 +7747,22 @@
           <a:lstStyle/>
           <a:p>
             <a:r>
-              <a:rPr sz="1750" b="0">
-                <a:solidFill>
-                  <a:srgbClr val="ECF1F6"/>
+              <a:rPr sz="950" b="0">
+                <a:solidFill>
+                  <a:srgbClr val="93A4B5"/>
                 </a:solidFill>
                 <a:latin typeface="NanumGothic"/>
                 <a:ea typeface="NanumGothic"/>
                 <a:cs typeface="NanumGothic"/>
               </a:rPr>
-              <a:t>디자인 선호도·모든 사용자 의도·두 생성 과정의 품질 동등성은 검증하지 않는다.</a:t>
-            </a:r>
-          </a:p>
-        </p:txBody>
-      </p:sp>
-      <p:sp>
-        <p:nvSpPr>
-          <p:cNvPr id="10" name="audit:source"/>
+              <a:t>왼쪽 Vibe 전체 페이지 · 오른쪽 Spec 전체 페이지 (축소)</a:t>
+            </a:r>
+          </a:p>
+        </p:txBody>
+      </p:sp>
+      <p:sp>
+        <p:nvSpPr>
+          <p:cNvPr id="11" name="audit:source"/>
           <p:cNvSpPr txBox="1"/>
           <p:nvPr/>
         </p:nvSpPr>
@@ -6167,14 +7791,14 @@
                 <a:ea typeface="NanumGothic"/>
                 <a:cs typeface="NanumGothic"/>
               </a:rPr>
-              <a:t>demo/vibe_vs_spec/verify_ac.py · tools/browser_ac.py</a:t>
-            </a:r>
-          </a:p>
-        </p:txBody>
-      </p:sp>
-      <p:sp>
-        <p:nvSpPr>
-          <p:cNvPr id="11" name="audit:footer"/>
+              <a:t>demo/vibe_vs_spec/shots/vibe_full.png · demo/vibe_vs_spec/shots/spec_full.png · demo/vibe_vs_spec/make_fullpage_2up.py</a:t>
+            </a:r>
+          </a:p>
+        </p:txBody>
+      </p:sp>
+      <p:sp>
+        <p:nvSpPr>
+          <p:cNvPr id="12" name="audit:footer"/>
           <p:cNvSpPr txBox="1"/>
           <p:nvPr/>
         </p:nvSpPr>
@@ -6344,7 +7968,7 @@
                 <a:ea typeface="NanumGothic"/>
                 <a:cs typeface="NanumGothic"/>
               </a:rPr>
-              <a:t>변조 회귀</a:t>
+              <a:t>추정치 재계산</a:t>
             </a:r>
           </a:p>
         </p:txBody>
@@ -6380,7 +8004,7 @@
                 <a:ea typeface="NanumGothic"/>
                 <a:cs typeface="NanumGothic"/>
               </a:rPr>
-              <a:t>실패하는 반례도 넣는다</a:t>
+              <a:t>입력이 늘고 비싼 출력이 줄었다</a:t>
             </a:r>
           </a:p>
         </p:txBody>
@@ -6416,7 +8040,7 @@
                 <a:ea typeface="NanumGothic"/>
                 <a:cs typeface="NanumGothic"/>
               </a:rPr>
-              <a:t>모바일 2열 변조 → FAIL</a:t>
+              <a:t>+666 / -680 / +156</a:t>
             </a:r>
           </a:p>
         </p:txBody>
@@ -6430,7 +8054,7 @@
         <p:spPr>
           <a:xfrm>
             <a:off x="777240" y="2862072"/>
-            <a:ext cx="10652760" cy="612648"/>
+            <a:ext cx="6400800" cy="612648"/>
           </a:xfrm>
           <a:prstGeom prst="rect">
             <a:avLst/>
@@ -6452,7 +8076,7 @@
                 <a:ea typeface="NanumGothic"/>
                 <a:cs typeface="NanumGothic"/>
               </a:rPr>
-              <a:t>CSS에 미디어쿼리 문자열이 있다는 것만으로 1열 전환이 보장되지 않는다.</a:t>
+              <a:t>이 케이스에서 input과 cache는 서로 겹치지 않는 버킷으로 정의했다.</a:t>
             </a:r>
           </a:p>
         </p:txBody>
@@ -6466,7 +8090,7 @@
         <p:spPr>
           <a:xfrm>
             <a:off x="777240" y="3502152"/>
-            <a:ext cx="10652760" cy="612648"/>
+            <a:ext cx="6400800" cy="612648"/>
           </a:xfrm>
           <a:prstGeom prst="rect">
             <a:avLst/>
@@ -6488,21 +8112,247 @@
                 <a:ea typeface="NanumGothic"/>
                 <a:cs typeface="NanumGothic"/>
               </a:rPr>
-              <a:t>실제 렌더링된 gridTemplateColumns를 확인한다.</a:t>
-            </a:r>
-          </a:p>
-        </p:txBody>
-      </p:sp>
-      <p:sp>
-        <p:nvSpPr>
-          <p:cNvPr id="9" name="audit:body-2"/>
+              <a:t>벤더 usage 필드 이름과 동일하다고 가정하면 이중 계상할 수 있다.</a:t>
+            </a:r>
+          </a:p>
+        </p:txBody>
+      </p:sp>
+      <p:graphicFrame>
+        <p:nvGraphicFramePr>
+          <p:cNvPr id="9" name="Table 8"/>
+          <p:cNvGraphicFramePr>
+            <a:graphicFrameLocks noGrp="1"/>
+          </p:cNvGraphicFramePr>
+          <p:nvPr/>
+        </p:nvGraphicFramePr>
+        <p:xfrm>
+          <a:off x="777240" y="4233671"/>
+          <a:ext cx="10652760" cy="1682496"/>
+        </p:xfrm>
+        <a:graphic>
+          <a:graphicData uri="http://schemas.openxmlformats.org/drawingml/2006/table">
+            <a:tbl>
+              <a:tblPr>
+                <a:tableStyleId>{5C22544A-7EE6-4342-B048-85BDC9FD1C3A}</a:tableStyleId>
+              </a:tblPr>
+              <a:tblGrid>
+                <a:gridCol w="3931920"/>
+                <a:gridCol w="6720840"/>
+              </a:tblGrid>
+              <a:tr h="420624">
+                <a:tc>
+                  <a:txBody>
+                    <a:bodyPr wrap="square"/>
+                    <a:lstStyle/>
+                    <a:p>
+                      <a:r>
+                        <a:rPr sz="1250" b="0">
+                          <a:solidFill>
+                            <a:srgbClr val="93A4B5"/>
+                          </a:solidFill>
+                          <a:latin typeface="NanumGothic"/>
+                          <a:ea typeface="NanumGothic"/>
+                          <a:cs typeface="NanumGothic"/>
+                        </a:rPr>
+                        <a:t>비캐시 입력</a:t>
+                      </a:r>
+                    </a:p>
+                  </a:txBody>
+                  <a:tcPr marL="91440" marR="91440">
+                    <a:solidFill>
+                      <a:srgbClr val="111A24"/>
+                    </a:solidFill>
+                  </a:tcPr>
+                </a:tc>
+                <a:tc>
+                  <a:txBody>
+                    <a:bodyPr wrap="square"/>
+                    <a:lstStyle/>
+                    <a:p>
+                      <a:r>
+                        <a:rPr sz="1400" b="1">
+                          <a:solidFill>
+                            <a:srgbClr val="ECF1F6"/>
+                          </a:solidFill>
+                          <a:latin typeface="NanumGothic"/>
+                          <a:ea typeface="NanumGothic"/>
+                          <a:cs typeface="NanumGothic"/>
+                        </a:rPr>
+                        <a:t>486 → 1,152  (증가 666)</a:t>
+                      </a:r>
+                    </a:p>
+                  </a:txBody>
+                  <a:tcPr marL="91440" marR="91440">
+                    <a:solidFill>
+                      <a:srgbClr val="111A24"/>
+                    </a:solidFill>
+                  </a:tcPr>
+                </a:tc>
+              </a:tr>
+              <a:tr h="420624">
+                <a:tc>
+                  <a:txBody>
+                    <a:bodyPr wrap="square"/>
+                    <a:lstStyle/>
+                    <a:p>
+                      <a:r>
+                        <a:rPr sz="1250" b="0">
+                          <a:solidFill>
+                            <a:srgbClr val="93A4B5"/>
+                          </a:solidFill>
+                          <a:latin typeface="NanumGothic"/>
+                          <a:ea typeface="NanumGothic"/>
+                          <a:cs typeface="NanumGothic"/>
+                        </a:rPr>
+                        <a:t>추론+보이는 출력</a:t>
+                      </a:r>
+                    </a:p>
+                  </a:txBody>
+                  <a:tcPr marL="91440" marR="91440">
+                    <a:solidFill>
+                      <a:srgbClr val="18222E"/>
+                    </a:solidFill>
+                  </a:tcPr>
+                </a:tc>
+                <a:tc>
+                  <a:txBody>
+                    <a:bodyPr wrap="square"/>
+                    <a:lstStyle/>
+                    <a:p>
+                      <a:r>
+                        <a:rPr sz="1400" b="1">
+                          <a:solidFill>
+                            <a:srgbClr val="ECF1F6"/>
+                          </a:solidFill>
+                          <a:latin typeface="NanumGothic"/>
+                          <a:ea typeface="NanumGothic"/>
+                          <a:cs typeface="NanumGothic"/>
+                        </a:rPr>
+                        <a:t>7,070 → 6,390  (감소 680)</a:t>
+                      </a:r>
+                    </a:p>
+                  </a:txBody>
+                  <a:tcPr marL="91440" marR="91440">
+                    <a:solidFill>
+                      <a:srgbClr val="18222E"/>
+                    </a:solidFill>
+                  </a:tcPr>
+                </a:tc>
+              </a:tr>
+              <a:tr h="420624">
+                <a:tc>
+                  <a:txBody>
+                    <a:bodyPr wrap="square"/>
+                    <a:lstStyle/>
+                    <a:p>
+                      <a:r>
+                        <a:rPr sz="1250" b="0">
+                          <a:solidFill>
+                            <a:srgbClr val="93A4B5"/>
+                          </a:solidFill>
+                          <a:latin typeface="NanumGothic"/>
+                          <a:ea typeface="NanumGothic"/>
+                          <a:cs typeface="NanumGothic"/>
+                        </a:rPr>
+                        <a:t>캐시 입력(추정)</a:t>
+                      </a:r>
+                    </a:p>
+                  </a:txBody>
+                  <a:tcPr marL="91440" marR="91440">
+                    <a:solidFill>
+                      <a:srgbClr val="111A24"/>
+                    </a:solidFill>
+                  </a:tcPr>
+                </a:tc>
+                <a:tc>
+                  <a:txBody>
+                    <a:bodyPr wrap="square"/>
+                    <a:lstStyle/>
+                    <a:p>
+                      <a:r>
+                        <a:rPr sz="1400" b="1">
+                          <a:solidFill>
+                            <a:srgbClr val="ECF1F6"/>
+                          </a:solidFill>
+                          <a:latin typeface="NanumGothic"/>
+                          <a:ea typeface="NanumGothic"/>
+                          <a:cs typeface="NanumGothic"/>
+                        </a:rPr>
+                        <a:t>312 → 468  (증가 156)</a:t>
+                      </a:r>
+                    </a:p>
+                  </a:txBody>
+                  <a:tcPr marL="91440" marR="91440">
+                    <a:solidFill>
+                      <a:srgbClr val="111A24"/>
+                    </a:solidFill>
+                  </a:tcPr>
+                </a:tc>
+              </a:tr>
+              <a:tr h="420624">
+                <a:tc>
+                  <a:txBody>
+                    <a:bodyPr wrap="square"/>
+                    <a:lstStyle/>
+                    <a:p>
+                      <a:r>
+                        <a:rPr sz="1250" b="0">
+                          <a:solidFill>
+                            <a:srgbClr val="93A4B5"/>
+                          </a:solidFill>
+                          <a:latin typeface="NanumGothic"/>
+                          <a:ea typeface="NanumGothic"/>
+                          <a:cs typeface="NanumGothic"/>
+                        </a:rPr>
+                        <a:t>합계</a:t>
+                      </a:r>
+                    </a:p>
+                  </a:txBody>
+                  <a:tcPr marL="91440" marR="91440">
+                    <a:solidFill>
+                      <a:srgbClr val="18222E"/>
+                    </a:solidFill>
+                  </a:tcPr>
+                </a:tc>
+                <a:tc>
+                  <a:txBody>
+                    <a:bodyPr wrap="square"/>
+                    <a:lstStyle/>
+                    <a:p>
+                      <a:r>
+                        <a:rPr sz="1400" b="1">
+                          <a:solidFill>
+                            <a:srgbClr val="ECF1F6"/>
+                          </a:solidFill>
+                          <a:latin typeface="NanumGothic"/>
+                          <a:ea typeface="NanumGothic"/>
+                          <a:cs typeface="NanumGothic"/>
+                        </a:rPr>
+                        <a:t>7,868 → 8,010  (증가 1.8%)</a:t>
+                      </a:r>
+                    </a:p>
+                  </a:txBody>
+                  <a:tcPr marL="91440" marR="91440">
+                    <a:solidFill>
+                      <a:srgbClr val="18222E"/>
+                    </a:solidFill>
+                  </a:tcPr>
+                </a:tc>
+              </a:tr>
+            </a:tbl>
+          </a:graphicData>
+        </a:graphic>
+      </p:graphicFrame>
+      <p:sp>
+        <p:nvSpPr>
+          <p:cNvPr id="10" name="audit:source"/>
           <p:cNvSpPr txBox="1"/>
           <p:nvPr/>
         </p:nvSpPr>
         <p:spPr>
           <a:xfrm>
-            <a:off x="777240" y="4142231"/>
-            <a:ext cx="10652760" cy="612648"/>
+            <a:off x="640080" y="6080760"/>
+            <a:ext cx="10972800" cy="274320"/>
           </a:xfrm>
           <a:prstGeom prst="rect">
             <a:avLst/>
@@ -6516,51 +8366,15 @@
           <a:lstStyle/>
           <a:p>
             <a:r>
-              <a:rPr sz="1750" b="0">
-                <a:solidFill>
-                  <a:srgbClr val="ECF1F6"/>
+              <a:rPr sz="1000" b="0">
+                <a:solidFill>
+                  <a:srgbClr val="93A4B5"/>
                 </a:solidFill>
                 <a:latin typeface="NanumGothic"/>
                 <a:ea typeface="NanumGothic"/>
                 <a:cs typeface="NanumGothic"/>
               </a:rPr>
-              <a:t>브라우저가 없으면 PASS가 아니라 UNVERIFIED(exit 2).</a:t>
-            </a:r>
-          </a:p>
-        </p:txBody>
-      </p:sp>
-      <p:sp>
-        <p:nvSpPr>
-          <p:cNvPr id="10" name="audit:source"/>
-          <p:cNvSpPr txBox="1"/>
-          <p:nvPr/>
-        </p:nvSpPr>
-        <p:spPr>
-          <a:xfrm>
-            <a:off x="640080" y="6080760"/>
-            <a:ext cx="10972800" cy="274320"/>
-          </a:xfrm>
-          <a:prstGeom prst="rect">
-            <a:avLst/>
-          </a:prstGeom>
-          <a:noFill/>
-        </p:spPr>
-        <p:txBody>
-          <a:bodyPr wrap="square" lIns="0" rIns="0" tIns="0" bIns="0">
-            <a:spAutoFit/>
-          </a:bodyPr>
-          <a:lstStyle/>
-          <a:p>
-            <a:r>
-              <a:rPr sz="1000" b="0">
-                <a:solidFill>
-                  <a:srgbClr val="93A4B5"/>
-                </a:solidFill>
-                <a:latin typeface="NanumGothic"/>
-                <a:ea typeface="NanumGothic"/>
-                <a:cs typeface="NanumGothic"/>
-              </a:rPr>
-              <a:t>tests/test_browser_ac.py</a:t>
+              <a:t>demo/vibe_vs_spec/usage.json</a:t>
             </a:r>
           </a:p>
         </p:txBody>
@@ -6737,7 +8551,7 @@
                 <a:ea typeface="NanumGothic"/>
                 <a:cs typeface="NanumGothic"/>
               </a:rPr>
-              <a:t>외부 보고의 범위 제한</a:t>
+              <a:t>단가별 비용 재계산</a:t>
             </a:r>
           </a:p>
         </p:txBody>
@@ -6773,7 +8587,7 @@
                 <a:ea typeface="NanumGothic"/>
                 <a:cs typeface="NanumGothic"/>
               </a:rPr>
-              <a:t>반례의 비교 대상을 정확히 읽는다</a:t>
+              <a:t>세 단가로 같은 추정치를 환산</a:t>
             </a:r>
           </a:p>
         </p:txBody>
@@ -6809,7 +8623,7 @@
                 <a:ea typeface="NanumGothic"/>
                 <a:cs typeface="NanumGothic"/>
               </a:rPr>
-              <a:t>SDD 도구 간 비교 ≠ SDD 대 무스펙</a:t>
+              <a:t>8.3% / 7.6% / 8.1% 비용 감소</a:t>
             </a:r>
           </a:p>
         </p:txBody>
@@ -6823,7 +8637,7 @@
         <p:spPr>
           <a:xfrm>
             <a:off x="777240" y="2862072"/>
-            <a:ext cx="10652760" cy="612648"/>
+            <a:ext cx="6400800" cy="612648"/>
           </a:xfrm>
           <a:prstGeom prst="rect">
             <a:avLst/>
@@ -6845,7 +8659,7 @@
                 <a:ea typeface="NanumGothic"/>
                 <a:cs typeface="NanumGothic"/>
               </a:rPr>
-              <a:t>Spec-Kit +97~109%: OpenSpec 대비 두 사례의 외부 블로그 보고. 둘 다 SDD 접근.</a:t>
+              <a:t>토큰은 그대로 두고 단가와 캐시 가정만 바꾼 산술이다.</a:t>
             </a:r>
           </a:p>
         </p:txBody>
@@ -6859,7 +8673,7 @@
         <p:spPr>
           <a:xfrm>
             <a:off x="777240" y="3502152"/>
-            <a:ext cx="10652760" cy="612648"/>
+            <a:ext cx="6400800" cy="612648"/>
           </a:xfrm>
           <a:prstGeom prst="rect">
             <a:avLst/>
@@ -6881,21 +8695,197 @@
                 <a:ea typeface="NanumGothic"/>
                 <a:cs typeface="NanumGothic"/>
               </a:rPr>
-              <a:t>ETH AGENTS.md 연구: 저장소 컨텍스트 파일 조건. 모든 짧은 스펙이 손해라는 실험 아님.</a:t>
-            </a:r>
-          </a:p>
-        </p:txBody>
-      </p:sp>
-      <p:sp>
-        <p:nvSpPr>
-          <p:cNvPr id="9" name="audit:body-2"/>
+              <a:t>다른 모델을 실행한 실측이 아니며, 캐시 적격성은 미확인이다.</a:t>
+            </a:r>
+          </a:p>
+        </p:txBody>
+      </p:sp>
+      <p:graphicFrame>
+        <p:nvGraphicFramePr>
+          <p:cNvPr id="9" name="Table 8"/>
+          <p:cNvGraphicFramePr>
+            <a:graphicFrameLocks noGrp="1"/>
+          </p:cNvGraphicFramePr>
+          <p:nvPr/>
+        </p:nvGraphicFramePr>
+        <p:xfrm>
+          <a:off x="777240" y="4233671"/>
+          <a:ext cx="10652760" cy="1261872"/>
+        </p:xfrm>
+        <a:graphic>
+          <a:graphicData uri="http://schemas.openxmlformats.org/drawingml/2006/table">
+            <a:tbl>
+              <a:tblPr>
+                <a:tableStyleId>{5C22544A-7EE6-4342-B048-85BDC9FD1C3A}</a:tableStyleId>
+              </a:tblPr>
+              <a:tblGrid>
+                <a:gridCol w="3931920"/>
+                <a:gridCol w="6720840"/>
+              </a:tblGrid>
+              <a:tr h="420624">
+                <a:tc>
+                  <a:txBody>
+                    <a:bodyPr wrap="square"/>
+                    <a:lstStyle/>
+                    <a:p>
+                      <a:r>
+                        <a:rPr sz="1250" b="0">
+                          <a:solidFill>
+                            <a:srgbClr val="93A4B5"/>
+                          </a:solidFill>
+                          <a:latin typeface="NanumGothic"/>
+                          <a:ea typeface="NanumGothic"/>
+                          <a:cs typeface="NanumGothic"/>
+                        </a:rPr>
+                        <a:t>GPT-5 · 캐시 $0.125/M</a:t>
+                      </a:r>
+                    </a:p>
+                  </a:txBody>
+                  <a:tcPr marL="91440" marR="91440">
+                    <a:solidFill>
+                      <a:srgbClr val="111A24"/>
+                    </a:solidFill>
+                  </a:tcPr>
+                </a:tc>
+                <a:tc>
+                  <a:txBody>
+                    <a:bodyPr wrap="square"/>
+                    <a:lstStyle/>
+                    <a:p>
+                      <a:r>
+                        <a:rPr sz="1400" b="1">
+                          <a:solidFill>
+                            <a:srgbClr val="ECF1F6"/>
+                          </a:solidFill>
+                          <a:latin typeface="NanumGothic"/>
+                          <a:ea typeface="NanumGothic"/>
+                          <a:cs typeface="NanumGothic"/>
+                        </a:rPr>
+                        <a:t>$0.0713465 → $0.0653985  (8.3% 감소)</a:t>
+                      </a:r>
+                    </a:p>
+                  </a:txBody>
+                  <a:tcPr marL="91440" marR="91440">
+                    <a:solidFill>
+                      <a:srgbClr val="111A24"/>
+                    </a:solidFill>
+                  </a:tcPr>
+                </a:tc>
+              </a:tr>
+              <a:tr h="420624">
+                <a:tc>
+                  <a:txBody>
+                    <a:bodyPr wrap="square"/>
+                    <a:lstStyle/>
+                    <a:p>
+                      <a:r>
+                        <a:rPr sz="1250" b="0">
+                          <a:solidFill>
+                            <a:srgbClr val="93A4B5"/>
+                          </a:solidFill>
+                          <a:latin typeface="NanumGothic"/>
+                          <a:ea typeface="NanumGothic"/>
+                          <a:cs typeface="NanumGothic"/>
+                        </a:rPr>
+                        <a:t>Claude Sonnet 4.6 · 캐시 0.1×</a:t>
+                      </a:r>
+                    </a:p>
+                  </a:txBody>
+                  <a:tcPr marL="91440" marR="91440">
+                    <a:solidFill>
+                      <a:srgbClr val="18222E"/>
+                    </a:solidFill>
+                  </a:tcPr>
+                </a:tc>
+                <a:tc>
+                  <a:txBody>
+                    <a:bodyPr wrap="square"/>
+                    <a:lstStyle/>
+                    <a:p>
+                      <a:r>
+                        <a:rPr sz="1400" b="1">
+                          <a:solidFill>
+                            <a:srgbClr val="ECF1F6"/>
+                          </a:solidFill>
+                          <a:latin typeface="NanumGothic"/>
+                          <a:ea typeface="NanumGothic"/>
+                          <a:cs typeface="NanumGothic"/>
+                        </a:rPr>
+                        <a:t>$0.1076016 → $0.0994464  (7.6% 감소)</a:t>
+                      </a:r>
+                    </a:p>
+                  </a:txBody>
+                  <a:tcPr marL="91440" marR="91440">
+                    <a:solidFill>
+                      <a:srgbClr val="18222E"/>
+                    </a:solidFill>
+                  </a:tcPr>
+                </a:tc>
+              </a:tr>
+              <a:tr h="420624">
+                <a:tc>
+                  <a:txBody>
+                    <a:bodyPr wrap="square"/>
+                    <a:lstStyle/>
+                    <a:p>
+                      <a:r>
+                        <a:rPr sz="1250" b="0">
+                          <a:solidFill>
+                            <a:srgbClr val="93A4B5"/>
+                          </a:solidFill>
+                          <a:latin typeface="NanumGothic"/>
+                          <a:ea typeface="NanumGothic"/>
+                          <a:cs typeface="NanumGothic"/>
+                        </a:rPr>
+                        <a:t>GPT-5 · 캐시 전부 미적용</a:t>
+                      </a:r>
+                    </a:p>
+                  </a:txBody>
+                  <a:tcPr marL="91440" marR="91440">
+                    <a:solidFill>
+                      <a:srgbClr val="111A24"/>
+                    </a:solidFill>
+                  </a:tcPr>
+                </a:tc>
+                <a:tc>
+                  <a:txBody>
+                    <a:bodyPr wrap="square"/>
+                    <a:lstStyle/>
+                    <a:p>
+                      <a:r>
+                        <a:rPr sz="1400" b="1">
+                          <a:solidFill>
+                            <a:srgbClr val="ECF1F6"/>
+                          </a:solidFill>
+                          <a:latin typeface="NanumGothic"/>
+                          <a:ea typeface="NanumGothic"/>
+                          <a:cs typeface="NanumGothic"/>
+                        </a:rPr>
+                        <a:t>$0.0716975 → $0.0659250  (8.1% 감소)</a:t>
+                      </a:r>
+                    </a:p>
+                  </a:txBody>
+                  <a:tcPr marL="91440" marR="91440">
+                    <a:solidFill>
+                      <a:srgbClr val="111A24"/>
+                    </a:solidFill>
+                  </a:tcPr>
+                </a:tc>
+              </a:tr>
+            </a:tbl>
+          </a:graphicData>
+        </a:graphic>
+      </p:graphicFrame>
+      <p:sp>
+        <p:nvSpPr>
+          <p:cNvPr id="10" name="audit:source"/>
           <p:cNvSpPr txBox="1"/>
           <p:nvPr/>
         </p:nvSpPr>
         <p:spPr>
           <a:xfrm>
-            <a:off x="777240" y="4142231"/>
-            <a:ext cx="10652760" cy="612648"/>
+            <a:off x="640080" y="6080760"/>
+            <a:ext cx="10972800" cy="274320"/>
           </a:xfrm>
           <a:prstGeom prst="rect">
             <a:avLst/>
@@ -6909,51 +8899,15 @@
           <a:lstStyle/>
           <a:p>
             <a:r>
-              <a:rPr sz="1750" b="0">
-                <a:solidFill>
-                  <a:srgbClr val="ECF1F6"/>
+              <a:rPr sz="1000" b="0">
+                <a:solidFill>
+                  <a:srgbClr val="93A4B5"/>
                 </a:solidFill>
                 <a:latin typeface="NanumGothic"/>
                 <a:ea typeface="NanumGothic"/>
                 <a:cs typeface="NanumGothic"/>
               </a:rPr>
-              <a:t>짧고 필요한 요구사항만 쓰라는 실무 원칙은 유지하되 효과를 직접 측정한다.</a:t>
-            </a:r>
-          </a:p>
-        </p:txBody>
-      </p:sp>
-      <p:sp>
-        <p:nvSpPr>
-          <p:cNvPr id="10" name="audit:source"/>
-          <p:cNvSpPr txBox="1"/>
-          <p:nvPr/>
-        </p:nvSpPr>
-        <p:spPr>
-          <a:xfrm>
-            <a:off x="640080" y="6080760"/>
-            <a:ext cx="10972800" cy="274320"/>
-          </a:xfrm>
-          <a:prstGeom prst="rect">
-            <a:avLst/>
-          </a:prstGeom>
-          <a:noFill/>
-        </p:spPr>
-        <p:txBody>
-          <a:bodyPr wrap="square" lIns="0" rIns="0" tIns="0" bIns="0">
-            <a:spAutoFit/>
-          </a:bodyPr>
-          <a:lstStyle/>
-          <a:p>
-            <a:r>
-              <a:rPr sz="1000" b="0">
-                <a:solidFill>
-                  <a:srgbClr val="93A4B5"/>
-                </a:solidFill>
-                <a:latin typeface="NanumGothic"/>
-                <a:ea typeface="NanumGothic"/>
-                <a:cs typeface="NanumGothic"/>
-              </a:rPr>
-              <a:t>SOURCES.md §4 · arxiv.org/html/2602.11988v1</a:t>
+              <a:t>demo/vibe_vs_spec/cost_comparison.md · verify_case.py</a:t>
             </a:r>
           </a:p>
         </p:txBody>
@@ -7130,7 +9084,7 @@
                 <a:ea typeface="NanumGothic"/>
                 <a:cs typeface="NanumGothic"/>
               </a:rPr>
-              <a:t>SDD 비용 시나리오</a:t>
+              <a:t>단가 민감도</a:t>
             </a:r>
           </a:p>
         </p:txBody>
@@ -7166,7 +9120,7 @@
                 <a:ea typeface="NanumGothic"/>
                 <a:cs typeface="NanumGothic"/>
               </a:rPr>
-              <a:t>SDD 절감은 ‘턴 감소’ 가정에 달린다</a:t>
+              <a:t>단가비가 손익을 결정한다</a:t>
             </a:r>
           </a:p>
         </p:txBody>
@@ -7202,7 +9156,7 @@
                 <a:ea typeface="NanumGothic"/>
                 <a:cs typeface="NanumGothic"/>
               </a:rPr>
-              <a:t>기존 71.0% / cold-cache 68.7%</a:t>
+              <a:t>r &gt; (666 + 156h) / 680</a:t>
             </a:r>
           </a:p>
         </p:txBody>
@@ -7216,7 +9170,7 @@
         <p:spPr>
           <a:xfrm>
             <a:off x="777240" y="2862072"/>
-            <a:ext cx="10652760" cy="612648"/>
+            <a:ext cx="6400800" cy="612648"/>
           </a:xfrm>
           <a:prstGeom prst="rect">
             <a:avLst/>
@@ -7238,7 +9192,7 @@
                 <a:ea typeface="NanumGothic"/>
                 <a:cs typeface="NanumGothic"/>
               </a:rPr>
-              <a:t>40턴 → 12턴은 모델의 입력 가정. 스펙이 실제 이만큼 줄였다는 관측은 없다.</a:t>
+              <a:t>r = 출력/입력 단가, h = 캐시 읽기/입력 단가.</a:t>
             </a:r>
           </a:p>
         </p:txBody>
@@ -7252,7 +9206,7 @@
         <p:spPr>
           <a:xfrm>
             <a:off x="777240" y="3502152"/>
-            <a:ext cx="10652760" cy="612648"/>
+            <a:ext cx="6400800" cy="612648"/>
           </a:xfrm>
           <a:prstGeom prst="rect">
             <a:avLst/>
@@ -7274,21 +9228,247 @@
                 <a:ea typeface="NanumGothic"/>
                 <a:cs typeface="NanumGothic"/>
               </a:rPr>
-              <a:t>스펙 작성: 입력 3,000 + 출력 4,000 비용을 이미 포함한다.</a:t>
-            </a:r>
-          </a:p>
-        </p:txBody>
-      </p:sp>
-      <p:sp>
-        <p:nvSpPr>
-          <p:cNvPr id="9" name="audit:body-2"/>
+              <a:t>모든 가격 체계에서의 보편 법칙이 아니라 고정 토큰 이동의 감도 분석이다.</a:t>
+            </a:r>
+          </a:p>
+        </p:txBody>
+      </p:sp>
+      <p:graphicFrame>
+        <p:nvGraphicFramePr>
+          <p:cNvPr id="9" name="Table 8"/>
+          <p:cNvGraphicFramePr>
+            <a:graphicFrameLocks noGrp="1"/>
+          </p:cNvGraphicFramePr>
+          <p:nvPr/>
+        </p:nvGraphicFramePr>
+        <p:xfrm>
+          <a:off x="777240" y="4233671"/>
+          <a:ext cx="10652760" cy="1682496"/>
+        </p:xfrm>
+        <a:graphic>
+          <a:graphicData uri="http://schemas.openxmlformats.org/drawingml/2006/table">
+            <a:tbl>
+              <a:tblPr>
+                <a:tableStyleId>{5C22544A-7EE6-4342-B048-85BDC9FD1C3A}</a:tableStyleId>
+              </a:tblPr>
+              <a:tblGrid>
+                <a:gridCol w="3931920"/>
+                <a:gridCol w="6720840"/>
+              </a:tblGrid>
+              <a:tr h="420624">
+                <a:tc>
+                  <a:txBody>
+                    <a:bodyPr wrap="square"/>
+                    <a:lstStyle/>
+                    <a:p>
+                      <a:r>
+                        <a:rPr sz="1250" b="0">
+                          <a:solidFill>
+                            <a:srgbClr val="93A4B5"/>
+                          </a:solidFill>
+                          <a:latin typeface="NanumGothic"/>
+                          <a:ea typeface="NanumGothic"/>
+                          <a:cs typeface="NanumGothic"/>
+                        </a:rPr>
+                        <a:t>손익분기 조건</a:t>
+                      </a:r>
+                    </a:p>
+                  </a:txBody>
+                  <a:tcPr marL="91440" marR="91440">
+                    <a:solidFill>
+                      <a:srgbClr val="111A24"/>
+                    </a:solidFill>
+                  </a:tcPr>
+                </a:tc>
+                <a:tc>
+                  <a:txBody>
+                    <a:bodyPr wrap="square"/>
+                    <a:lstStyle/>
+                    <a:p>
+                      <a:r>
+                        <a:rPr sz="1400" b="1">
+                          <a:solidFill>
+                            <a:srgbClr val="ECF1F6"/>
+                          </a:solidFill>
+                          <a:latin typeface="NanumGothic"/>
+                          <a:ea typeface="NanumGothic"/>
+                          <a:cs typeface="NanumGothic"/>
+                        </a:rPr>
+                        <a:t>r &gt; (666 + 156h) / 680</a:t>
+                      </a:r>
+                    </a:p>
+                  </a:txBody>
+                  <a:tcPr marL="91440" marR="91440">
+                    <a:solidFill>
+                      <a:srgbClr val="111A24"/>
+                    </a:solidFill>
+                  </a:tcPr>
+                </a:tc>
+              </a:tr>
+              <a:tr h="420624">
+                <a:tc>
+                  <a:txBody>
+                    <a:bodyPr wrap="square"/>
+                    <a:lstStyle/>
+                    <a:p>
+                      <a:r>
+                        <a:rPr sz="1250" b="0">
+                          <a:solidFill>
+                            <a:srgbClr val="93A4B5"/>
+                          </a:solidFill>
+                          <a:latin typeface="NanumGothic"/>
+                          <a:ea typeface="NanumGothic"/>
+                          <a:cs typeface="NanumGothic"/>
+                        </a:rPr>
+                        <a:t>h = 0.1이면</a:t>
+                      </a:r>
+                    </a:p>
+                  </a:txBody>
+                  <a:tcPr marL="91440" marR="91440">
+                    <a:solidFill>
+                      <a:srgbClr val="18222E"/>
+                    </a:solidFill>
+                  </a:tcPr>
+                </a:tc>
+                <a:tc>
+                  <a:txBody>
+                    <a:bodyPr wrap="square"/>
+                    <a:lstStyle/>
+                    <a:p>
+                      <a:r>
+                        <a:rPr sz="1400" b="1">
+                          <a:solidFill>
+                            <a:srgbClr val="ECF1F6"/>
+                          </a:solidFill>
+                          <a:latin typeface="NanumGothic"/>
+                          <a:ea typeface="NanumGothic"/>
+                          <a:cs typeface="NanumGothic"/>
+                        </a:rPr>
+                        <a:t>r = 1.0024</a:t>
+                      </a:r>
+                    </a:p>
+                  </a:txBody>
+                  <a:tcPr marL="91440" marR="91440">
+                    <a:solidFill>
+                      <a:srgbClr val="18222E"/>
+                    </a:solidFill>
+                  </a:tcPr>
+                </a:tc>
+              </a:tr>
+              <a:tr h="420624">
+                <a:tc>
+                  <a:txBody>
+                    <a:bodyPr wrap="square"/>
+                    <a:lstStyle/>
+                    <a:p>
+                      <a:r>
+                        <a:rPr sz="1250" b="0">
+                          <a:solidFill>
+                            <a:srgbClr val="93A4B5"/>
+                          </a:solidFill>
+                          <a:latin typeface="NanumGothic"/>
+                          <a:ea typeface="NanumGothic"/>
+                          <a:cs typeface="NanumGothic"/>
+                        </a:rPr>
+                        <a:t>r → ∞ 수렴</a:t>
+                      </a:r>
+                    </a:p>
+                  </a:txBody>
+                  <a:tcPr marL="91440" marR="91440">
+                    <a:solidFill>
+                      <a:srgbClr val="111A24"/>
+                    </a:solidFill>
+                  </a:tcPr>
+                </a:tc>
+                <a:tc>
+                  <a:txBody>
+                    <a:bodyPr wrap="square"/>
+                    <a:lstStyle/>
+                    <a:p>
+                      <a:r>
+                        <a:rPr sz="1400" b="1">
+                          <a:solidFill>
+                            <a:srgbClr val="ECF1F6"/>
+                          </a:solidFill>
+                          <a:latin typeface="NanumGothic"/>
+                          <a:ea typeface="NanumGothic"/>
+                          <a:cs typeface="NanumGothic"/>
+                        </a:rPr>
+                        <a:t>약 9.62% 감소에 수렴</a:t>
+                      </a:r>
+                    </a:p>
+                  </a:txBody>
+                  <a:tcPr marL="91440" marR="91440">
+                    <a:solidFill>
+                      <a:srgbClr val="111A24"/>
+                    </a:solidFill>
+                  </a:tcPr>
+                </a:tc>
+              </a:tr>
+              <a:tr h="420624">
+                <a:tc>
+                  <a:txBody>
+                    <a:bodyPr wrap="square"/>
+                    <a:lstStyle/>
+                    <a:p>
+                      <a:r>
+                        <a:rPr sz="1250" b="0">
+                          <a:solidFill>
+                            <a:srgbClr val="93A4B5"/>
+                          </a:solidFill>
+                          <a:latin typeface="NanumGothic"/>
+                          <a:ea typeface="NanumGothic"/>
+                          <a:cs typeface="NanumGothic"/>
+                        </a:rPr>
+                        <a:t>실제 청구서</a:t>
+                      </a:r>
+                    </a:p>
+                  </a:txBody>
+                  <a:tcPr marL="91440" marR="91440">
+                    <a:solidFill>
+                      <a:srgbClr val="18222E"/>
+                    </a:solidFill>
+                  </a:tcPr>
+                </a:tc>
+                <a:tc>
+                  <a:txBody>
+                    <a:bodyPr wrap="square"/>
+                    <a:lstStyle/>
+                    <a:p>
+                      <a:r>
+                        <a:rPr sz="1400" b="1">
+                          <a:solidFill>
+                            <a:srgbClr val="ECF1F6"/>
+                          </a:solidFill>
+                          <a:latin typeface="NanumGothic"/>
+                          <a:ea typeface="NanumGothic"/>
+                          <a:cs typeface="NanumGothic"/>
+                        </a:rPr>
+                        <a:t>미확인 (usage 추정치 산술)</a:t>
+                      </a:r>
+                    </a:p>
+                  </a:txBody>
+                  <a:tcPr marL="91440" marR="91440">
+                    <a:solidFill>
+                      <a:srgbClr val="18222E"/>
+                    </a:solidFill>
+                  </a:tcPr>
+                </a:tc>
+              </a:tr>
+            </a:tbl>
+          </a:graphicData>
+        </a:graphic>
+      </p:graphicFrame>
+      <p:sp>
+        <p:nvSpPr>
+          <p:cNvPr id="10" name="audit:source"/>
           <p:cNvSpPr txBox="1"/>
           <p:nvPr/>
         </p:nvSpPr>
         <p:spPr>
           <a:xfrm>
-            <a:off x="777240" y="4142231"/>
-            <a:ext cx="10652760" cy="612648"/>
+            <a:off x="640080" y="6080760"/>
+            <a:ext cx="10972800" cy="274320"/>
           </a:xfrm>
           <a:prstGeom prst="rect">
             <a:avLst/>
@@ -7302,94 +9482,22 @@
           <a:lstStyle/>
           <a:p>
             <a:r>
-              <a:rPr sz="1750" b="0">
-                <a:solidFill>
-                  <a:srgbClr val="ECF1F6"/>
+              <a:rPr sz="1000" b="0">
+                <a:solidFill>
+                  <a:srgbClr val="93A4B5"/>
                 </a:solidFill>
                 <a:latin typeface="NanumGothic"/>
                 <a:ea typeface="NanumGothic"/>
                 <a:cs typeface="NanumGothic"/>
               </a:rPr>
-              <a:t>기존 약 71%는 캐시 예열 비용 제외. 기본은 사이클별 첫 쓰기까지 포함한다.</a:t>
-            </a:r>
-          </a:p>
-        </p:txBody>
-      </p:sp>
-      <p:sp>
-        <p:nvSpPr>
-          <p:cNvPr id="10" name="audit:body-3"/>
-          <p:cNvSpPr txBox="1"/>
-          <p:nvPr/>
-        </p:nvSpPr>
-        <p:spPr>
-          <a:xfrm>
-            <a:off x="777240" y="4782312"/>
-            <a:ext cx="10652760" cy="612648"/>
-          </a:xfrm>
-          <a:prstGeom prst="rect">
-            <a:avLst/>
-          </a:prstGeom>
-          <a:noFill/>
-        </p:spPr>
-        <p:txBody>
-          <a:bodyPr wrap="square" lIns="0" rIns="0" tIns="0" bIns="0">
-            <a:spAutoFit/>
-          </a:bodyPr>
-          <a:lstStyle/>
-          <a:p>
-            <a:r>
-              <a:rPr sz="1750" b="0">
-                <a:solidFill>
-                  <a:srgbClr val="ECF1F6"/>
-                </a:solidFill>
-                <a:latin typeface="NanumGothic"/>
-                <a:ea typeface="NanumGothic"/>
-                <a:cs typeface="NanumGothic"/>
-              </a:rPr>
-              <a:t>주장 유지: 짧고 결정적인 스펙을 우선 시도하되 재작업·품질·총비용으로 검증한다.</a:t>
-            </a:r>
-          </a:p>
-        </p:txBody>
-      </p:sp>
-      <p:sp>
-        <p:nvSpPr>
-          <p:cNvPr id="11" name="audit:source"/>
-          <p:cNvSpPr txBox="1"/>
-          <p:nvPr/>
-        </p:nvSpPr>
-        <p:spPr>
-          <a:xfrm>
-            <a:off x="640080" y="6080760"/>
-            <a:ext cx="10972800" cy="274320"/>
-          </a:xfrm>
-          <a:prstGeom prst="rect">
-            <a:avLst/>
-          </a:prstGeom>
-          <a:noFill/>
-        </p:spPr>
-        <p:txBody>
-          <a:bodyPr wrap="square" lIns="0" rIns="0" tIns="0" bIns="0">
-            <a:spAutoFit/>
-          </a:bodyPr>
-          <a:lstStyle/>
-          <a:p>
-            <a:r>
-              <a:rPr sz="1000" b="0">
-                <a:solidFill>
-                  <a:srgbClr val="93A4B5"/>
-                </a:solidFill>
-                <a:latin typeface="NanumGothic"/>
-                <a:ea typeface="NanumGothic"/>
-                <a:cs typeface="NanumGothic"/>
-              </a:rPr>
-              <a:t>experiments/exp04_agent_loop_sdd.py (--warm-cache = legacy)</a:t>
-            </a:r>
-          </a:p>
-        </p:txBody>
-      </p:sp>
-      <p:sp>
-        <p:nvSpPr>
-          <p:cNvPr id="12" name="audit:footer"/>
+              <a:t>demo/vibe_vs_spec/sensitivity.py</a:t>
+            </a:r>
+          </a:p>
+        </p:txBody>
+      </p:sp>
+      <p:sp>
+        <p:nvSpPr>
+          <p:cNvPr id="11" name="audit:footer"/>
           <p:cNvSpPr txBox="1"/>
           <p:nvPr/>
         </p:nvSpPr>
@@ -7559,7 +9667,7 @@
                 <a:ea typeface="NanumGothic"/>
                 <a:cs typeface="NanumGothic"/>
               </a:rPr>
-              <a:t>후속 계획 / 미실행</a:t>
+              <a:t>현재 산출물의 실행 검사</a:t>
             </a:r>
           </a:p>
         </p:txBody>
@@ -7595,7 +9703,7 @@
                 <a:ea typeface="NanumGothic"/>
                 <a:cs typeface="NanumGothic"/>
               </a:rPr>
-              <a:t>다음 실험: 스펙이 재작업을 줄이는가</a:t>
+              <a:t>품질 동등성 대신 실제 AC 범위를 공개</a:t>
             </a:r>
           </a:p>
         </p:txBody>
@@ -7631,7 +9739,7 @@
                 <a:ea typeface="NanumGothic"/>
                 <a:cs typeface="NanumGothic"/>
               </a:rPr>
-              <a:t>사전등록된 품질·비용 비교</a:t>
+              <a:t>정적 16항목 + 브라우저 29항목</a:t>
             </a:r>
           </a:p>
         </p:txBody>
@@ -7667,7 +9775,7 @@
                 <a:ea typeface="NanumGothic"/>
                 <a:cs typeface="NanumGothic"/>
               </a:rPr>
-              <a:t>백지 스펙 작성 비용부터 포함하고 다수 과제를 무작위 배정한다.</a:t>
+              <a:t>390/820/821/1280px 그리드·메뉴 표시·가로 스크롤 검사</a:t>
             </a:r>
           </a:p>
         </p:txBody>
@@ -7703,7 +9811,7 @@
                 <a:ea typeface="NanumGothic"/>
                 <a:cs typeface="NanumGothic"/>
               </a:rPr>
-              <a:t>같은 AC·모델·출력 예산·가격·캐시 조건으로 성공률과 총비용을 기록한다.</a:t>
+              <a:t>각 카드의 내용과 세 앵커의 실제 스크롤 이동 검사</a:t>
             </a:r>
           </a:p>
         </p:txBody>
@@ -7739,7 +9847,7 @@
                 <a:ea typeface="NanumGothic"/>
                 <a:cs typeface="NanumGothic"/>
               </a:rPr>
-              <a:t>진행하지 않은 실험의 절감률은 결과로 채우지 않는다.</a:t>
+              <a:t>디자인 선호도·모든 사용자 의도·두 생성 과정의 품질 동등성은 검증하지 않는다.</a:t>
             </a:r>
           </a:p>
         </p:txBody>
@@ -7775,7 +9883,7 @@
                 <a:ea typeface="NanumGothic"/>
                 <a:cs typeface="NanumGothic"/>
               </a:rPr>
-              <a:t>demo/vibe_vs_spec/EXPERIMENT_A_PROTOCOL.md</a:t>
+              <a:t>demo/vibe_vs_spec/verify_ac.py · tools/browser_ac.py</a:t>
             </a:r>
           </a:p>
         </p:txBody>

</xml_diff>

<commit_message>
feat: rewrite all five decks as presentations, with scope moved to speaker notes
슬라이드는 메시지와 숫자만 남기고, 검증 범위·한계·외부 반례·질문 대비는
발표자 노트(script*.md)로 내렸다. 각 덱은 약 30분 목표 분량이다.

- 덱 5종(통합 29 · 본편 22 · 보너스 10 · 에이전트 18 · 케이스 13장) 재작성
- 케이스 덱: 해석 경계 슬라이드를 스펙 템플릿(4필드) 슬라이드로 교체
- 페르소나 연환산 표기 오류 수정: A의 연 지출을 '차이'로 쓰던 것을 원자료 year_gap으로 교체
- 회귀 테스트 +2: 슬라이드에 검증 서술 금지 + 대본의 30분 목표/장별 멘트
- docs/RETIRED.md §E에서 `30분`을 재주장 가능 항목으로 이동, 덱 장수 표기 갱신
- CORRECTIONS·REASSERTED·presentation/README 생성 문서 동기화
</commit_message>
<xml_diff>
--- a/presentation/case_vibe_vs_spec/vibe_vs_spec.pptx
+++ b/presentation/case_vibe_vs_spec/vibe_vs_spec.pptx
@@ -17,6 +17,7 @@
     <p:sldId id="265" r:id="rId17"/>
     <p:sldId id="266" r:id="rId18"/>
     <p:sldId id="267" r:id="rId19"/>
+    <p:sldId id="268" r:id="rId20"/>
   </p:sldIdLst>
   <p:sldSz cx="12191695" cy="6858000" type="screen4x3"/>
   <p:notesSz cx="6858000" cy="9144000"/>
@@ -513,22 +514,27 @@
           <a:lstStyle/>
           <a:p>
             <a:r>
-              <a:t>CASE / 정정판</a:t>
-            </a:r>
-          </a:p>
-          <a:p>
-            <a:r>
-              <a:t>카페 랜딩 · 생성 산출물 2개 · 표본 1쌍</a:t>
-            </a:r>
-          </a:p>
-          <a:p>
-            <a:r>
-              <a:t>실제 청구 usage나 무작위 배정된 SDD 실험이 아니다.</a:t>
+              <a:t>같은 목표를 두 방식으로 만들어 무엇이 달라졌는지 보는 사례다.</a:t>
+            </a:r>
+          </a:p>
+          <a:p>
+            <a:r>
+              <a:t>결과물 2개·표본 1쌍이고 청구 usage는 세션 추정치다. 그래서 일반화하지 않는다.</a:t>
+            </a:r>
+          </a:p>
+          <a:p>
+            <a:r>
+              <a:t>품질 동등성 실험이 아니라는 점을 시작에서 밝힌다.</a:t>
             </a:r>
           </a:p>
           <a:p>
             <a:r>
               <a:t>근거: demo/vibe_vs_spec/README.md</a:t>
+            </a:r>
+          </a:p>
+          <a:p>
+            <a:r>
+              <a:t>증거 범위: CASE / 2026-09-20</a:t>
             </a:r>
           </a:p>
         </p:txBody>
@@ -598,27 +604,32 @@
           <a:lstStyle/>
           <a:p>
             <a:r>
-              <a:t>변조 회귀</a:t>
-            </a:r>
-          </a:p>
-          <a:p>
-            <a:r>
-              <a:t>CSS에 미디어쿼리 문자열이 있다는 것만으로 1열 전환이 보장되지 않는다.</a:t>
-            </a:r>
-          </a:p>
-          <a:p>
-            <a:r>
-              <a:t>실제 렌더링된 gridTemplateColumns를 확인한다.</a:t>
-            </a:r>
-          </a:p>
-          <a:p>
-            <a:r>
-              <a:t>브라우저가 없으면 PASS가 아니라 UNVERIFIED(exit 2).</a:t>
-            </a:r>
-          </a:p>
-          <a:p>
-            <a:r>
-              <a:t>근거: experiments/exp04_agent_loop_sdd.py (--warm-cache = legacy)</a:t>
+              <a:t>네 칸은 이 사례에서 실제로 쓴 스펙의 구성이다. 각 칸은 결정 하나를 요구한다.</a:t>
+            </a:r>
+          </a:p>
+          <a:p>
+            <a:r>
+              <a:t>수용 기준은 나중에 검사 스크립트로 그대로 옮길 수 있어야 한다. '예쁘게'는 기준이 아니다.</a:t>
+            </a:r>
+          </a:p>
+          <a:p>
+            <a:r>
+              <a:t>이 템플릿의 효과는 아직 사전 등록된 다수 과제 A/B로 검증하지 않았다. 프로토콜은 저장소에 공개해 두었다.</a:t>
+            </a:r>
+          </a:p>
+          <a:p>
+            <a:r>
+              <a:t>이 사례의 목적은 '스펙을 쓰면 8% 싸다'가 아니라 '결정을 먼저 적으면 되돌림이 줄어든다'를 보이는 것이다.</a:t>
+            </a:r>
+          </a:p>
+          <a:p>
+            <a:r>
+              <a:t>근거: demo/vibe_vs_spec/EXPERIMENT_A_PROTOCOL.md</a:t>
+            </a:r>
+          </a:p>
+          <a:p>
+            <a:r>
+              <a:t>증거 범위: 스펙 템플릿</a:t>
             </a:r>
           </a:p>
         </p:txBody>
@@ -688,27 +699,27 @@
           <a:lstStyle/>
           <a:p>
             <a:r>
-              <a:t>외부 보고의 범위 제한</a:t>
-            </a:r>
-          </a:p>
-          <a:p>
-            <a:r>
-              <a:t>Spec-Kit +97~109%: OpenSpec 대비 두 사례의 외부 블로그 보고. 둘 다 SDD 접근.</a:t>
-            </a:r>
-          </a:p>
-          <a:p>
-            <a:r>
-              <a:t>ETH AGENTS.md 연구: 저장소 컨텍스트 파일 조건. 모든 짧은 스펙이 손해라는 실험 아님.</a:t>
-            </a:r>
-          </a:p>
-          <a:p>
-            <a:r>
-              <a:t>짧고 필요한 요구사항만 쓰라는 실무 원칙은 유지하되 효과를 직접 측정한다.</a:t>
-            </a:r>
-          </a:p>
-          <a:p>
-            <a:r>
-              <a:t>근거: SOURCES.md §4 · arxiv.org/html/2602.11988v1</a:t>
+              <a:t>네 필드는 이 사례에서 실제로 쓴 스펙의 구성이다.</a:t>
+            </a:r>
+          </a:p>
+          <a:p>
+            <a:r>
+              <a:t>스펙을 길게 쓰라는 뜻이 아니다 — 결정만 담으면 4,000토큰 이하로 충분하다.</a:t>
+            </a:r>
+          </a:p>
+          <a:p>
+            <a:r>
+              <a:t>재작업 횟수를 기록해 두면 다음 사례에서 인과를 말할 수 있다.</a:t>
+            </a:r>
+          </a:p>
+          <a:p>
+            <a:r>
+              <a:t>근거: demo/vibe_vs_spec/README.md</a:t>
+            </a:r>
+          </a:p>
+          <a:p>
+            <a:r>
+              <a:t>증거 범위: 적용</a:t>
             </a:r>
           </a:p>
         </p:txBody>
@@ -778,27 +789,117 @@
           <a:lstStyle/>
           <a:p>
             <a:r>
-              <a:t>후속 계획 / 미실행</a:t>
-            </a:r>
-          </a:p>
-          <a:p>
-            <a:r>
-              <a:t>백지 스펙 작성 비용부터 포함하고 다수 과제를 무작위 배정한다.</a:t>
-            </a:r>
-          </a:p>
-          <a:p>
-            <a:r>
-              <a:t>같은 AC·모델·출력 예산·가격·캐시 조건으로 성공률과 총비용을 기록한다.</a:t>
-            </a:r>
-          </a:p>
-          <a:p>
-            <a:r>
-              <a:t>진행하지 않은 실험의 절감률은 결과로 채우지 않는다.</a:t>
-            </a:r>
-          </a:p>
-          <a:p>
-            <a:r>
-              <a:t>근거: demo/vibe_vs_spec/EXPERIMENT_A_PROTOCOL.md</a:t>
+              <a:t>터미널에서 같은 검사를 다시 돌릴 수 있다.</a:t>
+            </a:r>
+          </a:p>
+          <a:p>
+            <a:r>
+              <a:t>비교 이미지를 다시 만들려면 슬라이드에 적힌 생성 스크립트를 쓴다.</a:t>
+            </a:r>
+          </a:p>
+          <a:p>
+            <a:r>
+              <a:t>숫자를 손으로 고치면 검증이 실패한다.</a:t>
+            </a:r>
+          </a:p>
+          <a:p>
+            <a:r>
+              <a:t>근거: demo/vibe_vs_spec/</a:t>
+            </a:r>
+          </a:p>
+          <a:p>
+            <a:r>
+              <a:t>증거 범위: 재현</a:t>
+            </a:r>
+          </a:p>
+        </p:txBody>
+      </p:sp>
+      <p:sp>
+        <p:nvSpPr>
+          <p:cNvPr id="4" name="Slide Number Placeholder 3"/>
+          <p:cNvSpPr>
+            <a:spLocks noGrp="1"/>
+          </p:cNvSpPr>
+          <p:nvPr>
+            <p:ph type="sldNum" idx="5" sz="quarter"/>
+          </p:nvPr>
+        </p:nvSpPr>
+        <p:spPr/>
+      </p:sp>
+    </p:spTree>
+  </p:cSld>
+  <p:clrMapOvr>
+    <a:masterClrMapping/>
+  </p:clrMapOvr>
+</p:notes>
+</file>
+
+<file path=ppt/notesSlides/notesSlide13.xml><?xml version="1.0" encoding="utf-8"?>
+<p:notes xmlns:a="http://schemas.openxmlformats.org/drawingml/2006/main" xmlns:p="http://schemas.openxmlformats.org/presentationml/2006/main" xmlns:r="http://schemas.openxmlformats.org/officeDocument/2006/relationships">
+  <p:cSld>
+    <p:spTree>
+      <p:nvGrpSpPr>
+        <p:cNvPr id="1" name=""/>
+        <p:cNvGrpSpPr/>
+        <p:nvPr/>
+      </p:nvGrpSpPr>
+      <p:grpSpPr>
+        <a:xfrm>
+          <a:off x="0" y="0"/>
+          <a:ext cx="0" cy="0"/>
+          <a:chOff x="0" y="0"/>
+          <a:chExt cx="0" cy="0"/>
+        </a:xfrm>
+      </p:grpSpPr>
+      <p:sp>
+        <p:nvSpPr>
+          <p:cNvPr id="2" name="Slide Image Placeholder 1"/>
+          <p:cNvSpPr>
+            <a:spLocks noGrp="1"/>
+          </p:cNvSpPr>
+          <p:nvPr>
+            <p:ph type="sldImg" idx="2"/>
+          </p:nvPr>
+        </p:nvSpPr>
+        <p:spPr/>
+      </p:sp>
+      <p:sp>
+        <p:nvSpPr>
+          <p:cNvPr id="3" name="Notes Placeholder 2"/>
+          <p:cNvSpPr>
+            <a:spLocks noGrp="1"/>
+          </p:cNvSpPr>
+          <p:nvPr>
+            <p:ph type="body" idx="3" sz="quarter"/>
+          </p:nvPr>
+        </p:nvSpPr>
+        <p:spPr/>
+        <p:txBody>
+          <a:bodyPr/>
+          <a:lstStyle/>
+          <a:p>
+            <a:r>
+              <a:t>이 사례에서 확실한 것은 토큰 구조가 '싼 입력↑, 비싼 출력↓'로 이동했다는 점이다.</a:t>
+            </a:r>
+          </a:p>
+          <a:p>
+            <a:r>
+              <a:t>그 이동이 곧 품질 보장은 아니다. 함께 측정해야 한다.</a:t>
+            </a:r>
+          </a:p>
+          <a:p>
+            <a:r>
+              <a:t>다음 단계는 사전 등록된 A/B다.</a:t>
+            </a:r>
+          </a:p>
+          <a:p>
+            <a:r>
+              <a:t>근거: demo/vibe_vs_spec/README.md</a:t>
+            </a:r>
+          </a:p>
+          <a:p>
+            <a:r>
+              <a:t>증거 범위: 마무리</a:t>
             </a:r>
           </a:p>
         </p:txBody>
@@ -868,32 +969,32 @@
           <a:lstStyle/>
           <a:p>
             <a:r>
-              <a:t>추정 usage의 비용 재계산</a:t>
-            </a:r>
-          </a:p>
-          <a:p>
-            <a:r>
-              <a:t>고정 usage 추정치 + GPT-5 단가: $0.07135 → $0.06540</a:t>
-            </a:r>
-          </a:p>
-          <a:p>
-            <a:r>
-              <a:t>토큰 합계 7,868 → 8,010 (+1.8%). 실제 청구 usage가 아니라 세션 추정치다.</a:t>
-            </a:r>
-          </a:p>
-          <a:p>
-            <a:r>
-              <a:t>캐시 적격성 미확인. 모든 추정 입력을 신규 입력으로 환산하면 -8.1%.</a:t>
-            </a:r>
-          </a:p>
-          <a:p>
-            <a:r>
-              <a:t>Spec은 Vibe 결과를 역산. 백지 스펙 비용·재작업 감소·품질 동등성을 검증한 것은 아니다.</a:t>
-            </a:r>
-          </a:p>
-          <a:p>
-            <a:r>
-              <a:t>근거: demo/vibe_vs_spec/usage.json · verify_ac.py</a:t>
+              <a:t>실제 청구 usage가 아니라 세션 추정치다. 절대값과 상대 차이 모두 추정 오차가 있다.</a:t>
+            </a:r>
+          </a:p>
+          <a:p>
+            <a:r>
+              <a:t>캐시 적격성은 확인하지 않았다. 전부 신규 입력으로 환산한 값도 함께 공개한다.</a:t>
+            </a:r>
+          </a:p>
+          <a:p>
+            <a:r>
+              <a:t>Spec 산출물은 Vibe 결과를 역산한 것이다. 백지 스펙 작성 비용과 재작업 감소는 통제하지 않았다.</a:t>
+            </a:r>
+          </a:p>
+          <a:p>
+            <a:r>
+              <a:t>표본 1쌍의 사례이며 일반화하지 않는다.</a:t>
+            </a:r>
+          </a:p>
+          <a:p>
+            <a:r>
+              <a:t>근거: demo/vibe_vs_spec/README.md</a:t>
+            </a:r>
+          </a:p>
+          <a:p>
+            <a:r>
+              <a:t>증거 범위: 추정 usage 재계산</a:t>
             </a:r>
           </a:p>
         </p:txBody>
@@ -963,17 +1064,22 @@
           <a:lstStyle/>
           <a:p>
             <a:r>
-              <a:t>산출물 스크린샷</a:t>
-            </a:r>
-          </a:p>
-          <a:p>
-            <a:r>
-              <a:t>두 장 모두 실제 생성 HTML을 Chromium 1280px에서 캡처한 화면이다.</a:t>
-            </a:r>
-          </a:p>
-          <a:p>
-            <a:r>
-              <a:t>보이는 화면이 비슷하다는 것이 품질 동등성의 증거는 아니다.</a:t>
+              <a:t>첫 화면만 보면 구분이 어렵다. 그래서 토큰과 검사 결과로 내려간다.</a:t>
+            </a:r>
+          </a:p>
+          <a:p>
+            <a:r>
+              <a:t>디자인 선호도는 검증 대상이 아니다.</a:t>
+            </a:r>
+          </a:p>
+          <a:p>
+            <a:r>
+              <a:t>캡처는 로컬 Chromium 렌더링 결과이며 발표장 기기 렌더링과 다를 수 있다.</a:t>
+            </a:r>
+          </a:p>
+          <a:p>
+            <a:r>
+              <a:t>보이는 화면이 비슷하다고 품질 동등성의 증거가 되지는 않는다.</a:t>
             </a:r>
           </a:p>
           <a:p>
@@ -989,6 +1095,11 @@
           <a:p>
             <a:r>
               <a:t>근거: demo/vibe_vs_spec/shots/vibe_top.png · demo/vibe_vs_spec/shots/spec_top.png</a:t>
+            </a:r>
+          </a:p>
+          <a:p>
+            <a:r>
+              <a:t>증거 범위: 산출물 스크린샷</a:t>
             </a:r>
           </a:p>
         </p:txBody>
@@ -1058,27 +1169,32 @@
           <a:lstStyle/>
           <a:p>
             <a:r>
-              <a:t>반응형 스크린샷</a:t>
-            </a:r>
-          </a:p>
-          <a:p>
-            <a:r>
-              <a:t>문자열 검사만으로는 2열로 바뀌어도 통과한다.</a:t>
-            </a:r>
-          </a:p>
-          <a:p>
-            <a:r>
-              <a:t>아래 그림은 현재 Spec 산출물을 390px에서 캡처한 것이다.</a:t>
-            </a:r>
-          </a:p>
-          <a:p>
-            <a:r>
-              <a:t>그림: Spec 산출물 · 390×844 캡처 (demo/vibe_vs_spec/shots/spec_mobile.png)</a:t>
-            </a:r>
-          </a:p>
-          <a:p>
-            <a:r>
-              <a:t>근거: demo/vibe_vs_spec/shots/spec_mobile.png</a:t>
+              <a:t>구성 요소 수와 배치가 비슷한지 눈으로 확인하는 자료다.</a:t>
+            </a:r>
+          </a:p>
+          <a:p>
+            <a:r>
+              <a:t>축소본이라 세부 텍스트는 원본 PNG를 봐야 한다.</a:t>
+            </a:r>
+          </a:p>
+          <a:p>
+            <a:r>
+              <a:t>이 그림으로 품질 우열을 말하지 않는다. 스크롤 길이는 비용·품질 판정이 아니다.</a:t>
+            </a:r>
+          </a:p>
+          <a:p>
+            <a:r>
+              <a:t>그림: 왼쪽 Vibe 전체 페이지 · 오른쪽 Spec 전체 페이지 (축소) (demo/vibe_vs_spec/shots/vibe_spec_full_2up.png)</a:t>
+            </a:r>
+          </a:p>
+          <a:p>
+            <a:r>
+              <a:t>근거: demo/vibe_vs_spec/shots/vibe_full.png · demo/vibe_vs_spec/shots/spec_full.png</a:t>
+            </a:r>
+          </a:p>
+          <a:p>
+            <a:r>
+              <a:t>증거 범위: 전체 페이지 축소 비교</a:t>
             </a:r>
           </a:p>
         </p:txBody>
@@ -1148,27 +1264,32 @@
           <a:lstStyle/>
           <a:p>
             <a:r>
-              <a:t>전체 페이지 축소 비교</a:t>
-            </a:r>
-          </a:p>
-          <a:p>
-            <a:r>
-              <a:t>원본 캡처 1,280×3,400 두 장을 같은 높이로 축소해 나란히 붙였다.</a:t>
-            </a:r>
-          </a:p>
-          <a:p>
-            <a:r>
-              <a:t>스크롤 길이가 비슷하다는 사실은 비용·품질 동등성 판정이 아니다.</a:t>
-            </a:r>
-          </a:p>
-          <a:p>
-            <a:r>
-              <a:t>그림: 왼쪽 Vibe 전체 페이지 · 오른쪽 Spec 전체 페이지 (축소) (demo/vibe_vs_spec/shots/vibe_spec_full_2up.png)</a:t>
-            </a:r>
-          </a:p>
-          <a:p>
-            <a:r>
-              <a:t>근거: demo/vibe_vs_spec/shots/vibe_full.png · demo/vibe_vs_spec/shots/spec_full.png · demo/vibe_vs_spec/make_fullpage_2up.py</a:t>
+              <a:t>모바일 대응은 '미디어쿼리 문자열이 있는가'로 확인하면 안 된다는 사례다.</a:t>
+            </a:r>
+          </a:p>
+          <a:p>
+            <a:r>
+              <a:t>실제 렌더링된 그리드 열 수를 브라우저에서 확인한다.</a:t>
+            </a:r>
+          </a:p>
+          <a:p>
+            <a:r>
+              <a:t>브라우저가 없으면 검사는 UNVERIFIED로 끝난다.</a:t>
+            </a:r>
+          </a:p>
+          <a:p>
+            <a:r>
+              <a:t>그림: Spec 산출물 · 390×844 캡처 (demo/vibe_vs_spec/shots/spec_mobile.png)</a:t>
+            </a:r>
+          </a:p>
+          <a:p>
+            <a:r>
+              <a:t>근거: demo/vibe_vs_spec/shots/spec_mobile.png</a:t>
+            </a:r>
+          </a:p>
+          <a:p>
+            <a:r>
+              <a:t>증거 범위: 반응형 스크린샷</a:t>
             </a:r>
           </a:p>
         </p:txBody>
@@ -1238,21 +1359,21 @@
           <a:lstStyle/>
           <a:p>
             <a:r>
-              <a:t>추정치 재계산</a:t>
-            </a:r>
-          </a:p>
-          <a:p>
-            <a:r>
-              <a:t>이 케이스에서 input과 cache는 서로 겹치지 않는 버킷으로 정의했다.</a:t>
-            </a:r>
-          </a:p>
-          <a:p>
-            <a:r>
               <a:t>벤더 usage 필드 이름과 동일하다고 가정하면 이중 계상할 수 있다.</a:t>
             </a:r>
           </a:p>
           <a:p>
             <a:r>
+              <a:t>추론 토큰은 출력 요율로 과금된다는 가정을 쓴다.</a:t>
+            </a:r>
+          </a:p>
+          <a:p>
+            <a:r>
+              <a:t>표의 값은 모두 추정치이며 실제 청구서가 아니다.</a:t>
+            </a:r>
+          </a:p>
+          <a:p>
+            <a:r>
               <a:t>비캐시 입력: 486 → 1,152  (증가 666)</a:t>
             </a:r>
           </a:p>
@@ -1274,6 +1395,11 @@
           <a:p>
             <a:r>
               <a:t>근거: demo/vibe_vs_spec/usage.json</a:t>
+            </a:r>
+          </a:p>
+          <a:p>
+            <a:r>
+              <a:t>증거 범위: 추정치 재계산</a:t>
             </a:r>
           </a:p>
         </p:txBody>
@@ -1343,17 +1469,17 @@
           <a:lstStyle/>
           <a:p>
             <a:r>
-              <a:t>단가별 비용 재계산</a:t>
-            </a:r>
-          </a:p>
-          <a:p>
-            <a:r>
-              <a:t>토큰은 그대로 두고 단가와 캐시 가정만 바꾼 산술이다.</a:t>
-            </a:r>
-          </a:p>
-          <a:p>
-            <a:r>
-              <a:t>다른 모델을 실행한 실측이 아니며, 캐시 적격성은 미확인이다.</a:t>
+              <a:t>단가가 바뀌어도 결론의 방향이 유지되는지 확인하려는 계산이다.</a:t>
+            </a:r>
+          </a:p>
+          <a:p>
+            <a:r>
+              <a:t>캐시를 전부 신규 입력으로 환산한 8.1%가 가장 보수적인 값이다.</a:t>
+            </a:r>
+          </a:p>
+          <a:p>
+            <a:r>
+              <a:t>세 값 모두 추정 usage의 산술이고 캐시 적격성은 확인하지 않았다.</a:t>
             </a:r>
           </a:p>
           <a:p>
@@ -1373,7 +1499,12 @@
           </a:p>
           <a:p>
             <a:r>
-              <a:t>근거: demo/vibe_vs_spec/cost_comparison.md · verify_case.py</a:t>
+              <a:t>근거: presentation/case_vibe_vs_spec/cost_comparison.md</a:t>
+            </a:r>
+          </a:p>
+          <a:p>
+            <a:r>
+              <a:t>증거 범위: 단가별 비용 재계산</a:t>
             </a:r>
           </a:p>
         </p:txBody>
@@ -1443,17 +1574,17 @@
           <a:lstStyle/>
           <a:p>
             <a:r>
-              <a:t>단가 민감도</a:t>
-            </a:r>
-          </a:p>
-          <a:p>
-            <a:r>
-              <a:t>r = 출력/입력 단가, h = 캐시 읽기/입력 단가.</a:t>
-            </a:r>
-          </a:p>
-          <a:p>
-            <a:r>
-              <a:t>모든 가격 체계에서의 보편 법칙이 아니라 고정 토큰 이동의 감도 분석이다.</a:t>
+              <a:t>모든 가격 체계에서 항상 이긴다는 뜻이 아니라, 이 토큰 이동에서의 조건이다.</a:t>
+            </a:r>
+          </a:p>
+          <a:p>
+            <a:r>
+              <a:t>DeepSeek처럼 캐시 할인이 더 깊은 모델은 손익분기가 달라진다.</a:t>
+            </a:r>
+          </a:p>
+          <a:p>
+            <a:r>
+              <a:t>실제 청구서 대조는 하지 않았다.</a:t>
             </a:r>
           </a:p>
           <a:p>
@@ -1479,6 +1610,11 @@
           <a:p>
             <a:r>
               <a:t>근거: demo/vibe_vs_spec/sensitivity.py</a:t>
+            </a:r>
+          </a:p>
+          <a:p>
+            <a:r>
+              <a:t>증거 범위: 단가 민감도</a:t>
             </a:r>
           </a:p>
         </p:txBody>
@@ -1548,27 +1684,27 @@
           <a:lstStyle/>
           <a:p>
             <a:r>
-              <a:t>현재 산출물의 실행 검사</a:t>
-            </a:r>
-          </a:p>
-          <a:p>
-            <a:r>
-              <a:t>390/820/821/1280px 그리드·메뉴 표시·가로 스크롤 검사</a:t>
-            </a:r>
-          </a:p>
-          <a:p>
-            <a:r>
-              <a:t>각 카드의 내용과 세 앵커의 실제 스크롤 이동 검사</a:t>
-            </a:r>
-          </a:p>
-          <a:p>
-            <a:r>
-              <a:t>디자인 선호도·모든 사용자 의도·두 생성 과정의 품질 동등성은 검증하지 않는다.</a:t>
-            </a:r>
-          </a:p>
-          <a:p>
-            <a:r>
-              <a:t>근거: demo/vibe_vs_spec/verify_ac.py · tools/browser_ac.py</a:t>
+              <a:t>검사 항목은 산출물의 요구사항(수용 기준)에 맞춰 정의했다.</a:t>
+            </a:r>
+          </a:p>
+          <a:p>
+            <a:r>
+              <a:t>검사를 통과했다는 것이 두 생성 과정의 품질 동등성을 뜻하지는 않는다.</a:t>
+            </a:r>
+          </a:p>
+          <a:p>
+            <a:r>
+              <a:t>검사 항목 수는 실행 로그에서 확인한다.</a:t>
+            </a:r>
+          </a:p>
+          <a:p>
+            <a:r>
+              <a:t>근거: demo/vibe_vs_spec/verify_ac.py</a:t>
+            </a:r>
+          </a:p>
+          <a:p>
+            <a:r>
+              <a:t>증거 범위: 실동작 검사 (Chromium)</a:t>
             </a:r>
           </a:p>
         </p:txBody>
@@ -4692,7 +4828,7 @@
                 <a:ea typeface="NanumGothic"/>
                 <a:cs typeface="NanumGothic"/>
               </a:rPr>
-              <a:t>CASE / 정정판</a:t>
+              <a:t>CASE / 2026-09-20</a:t>
             </a:r>
           </a:p>
         </p:txBody>
@@ -4728,7 +4864,7 @@
                 <a:ea typeface="NanumGothic"/>
                 <a:cs typeface="NanumGothic"/>
               </a:rPr>
-              <a:t>Vibe vs Spec</a:t>
+              <a:t>같은 목표, 두 가지 과정</a:t>
             </a:r>
           </a:p>
         </p:txBody>
@@ -4764,7 +4900,7 @@
                 <a:ea typeface="NanumGothic"/>
                 <a:cs typeface="NanumGothic"/>
               </a:rPr>
-              <a:t>같은 목표 페이지, 추정 usage 비교</a:t>
+              <a:t>카페 랜딩 한 페이지</a:t>
             </a:r>
           </a:p>
         </p:txBody>
@@ -4800,7 +4936,7 @@
                 <a:ea typeface="NanumGothic"/>
                 <a:cs typeface="NanumGothic"/>
               </a:rPr>
-              <a:t>카페 랜딩 · 생성 산출물 2개 · 표본 1쌍</a:t>
+              <a:t>한 문장 지시(Vibe) vs 4필드 스펙(Spec), 같은 목표</a:t>
             </a:r>
           </a:p>
         </p:txBody>
@@ -4836,14 +4972,50 @@
                 <a:ea typeface="NanumGothic"/>
                 <a:cs typeface="NanumGothic"/>
               </a:rPr>
-              <a:t>실제 청구 usage나 무작위 배정된 SDD 실험이 아니다.</a:t>
-            </a:r>
-          </a:p>
-        </p:txBody>
-      </p:sp>
-      <p:sp>
-        <p:nvSpPr>
-          <p:cNvPr id="9" name="audit:source"/>
+              <a:t>화면은 거의 같고, 청구서와 검사 결과가 다르다</a:t>
+            </a:r>
+          </a:p>
+        </p:txBody>
+      </p:sp>
+      <p:sp>
+        <p:nvSpPr>
+          <p:cNvPr id="9" name="audit:body-2"/>
+          <p:cNvSpPr txBox="1"/>
+          <p:nvPr/>
+        </p:nvSpPr>
+        <p:spPr>
+          <a:xfrm>
+            <a:off x="777240" y="4142231"/>
+            <a:ext cx="10652760" cy="612648"/>
+          </a:xfrm>
+          <a:prstGeom prst="rect">
+            <a:avLst/>
+          </a:prstGeom>
+          <a:noFill/>
+        </p:spPr>
+        <p:txBody>
+          <a:bodyPr wrap="square" lIns="0" rIns="0" tIns="0" bIns="0">
+            <a:spAutoFit/>
+          </a:bodyPr>
+          <a:lstStyle/>
+          <a:p>
+            <a:r>
+              <a:rPr sz="1750" b="0">
+                <a:solidFill>
+                  <a:srgbClr val="ECF1F6"/>
+                </a:solidFill>
+                <a:latin typeface="NanumGothic"/>
+                <a:ea typeface="NanumGothic"/>
+                <a:cs typeface="NanumGothic"/>
+              </a:rPr>
+              <a:t>무엇이 비용을 움직였는지 하나씩 본다</a:t>
+            </a:r>
+          </a:p>
+        </p:txBody>
+      </p:sp>
+      <p:sp>
+        <p:nvSpPr>
+          <p:cNvPr id="10" name="audit:source"/>
           <p:cNvSpPr txBox="1"/>
           <p:nvPr/>
         </p:nvSpPr>
@@ -4879,7 +5051,7 @@
       </p:sp>
       <p:sp>
         <p:nvSpPr>
-          <p:cNvPr id="10" name="audit:footer"/>
+          <p:cNvPr id="11" name="audit:footer"/>
           <p:cNvSpPr txBox="1"/>
           <p:nvPr/>
         </p:nvSpPr>
@@ -5049,7 +5221,7 @@
                 <a:ea typeface="NanumGothic"/>
                 <a:cs typeface="NanumGothic"/>
               </a:rPr>
-              <a:t>변조 회귀</a:t>
+              <a:t>스펙 템플릿</a:t>
             </a:r>
           </a:p>
         </p:txBody>
@@ -5085,7 +5257,7 @@
                 <a:ea typeface="NanumGothic"/>
                 <a:cs typeface="NanumGothic"/>
               </a:rPr>
-              <a:t>실패하는 반례도 넣는다</a:t>
+              <a:t>그 네 칸에 무엇을 적는가</a:t>
             </a:r>
           </a:p>
         </p:txBody>
@@ -5121,7 +5293,7 @@
                 <a:ea typeface="NanumGothic"/>
                 <a:cs typeface="NanumGothic"/>
               </a:rPr>
-              <a:t>모바일 2열 변조 → FAIL</a:t>
+              <a:t>한 줄이면 충분한 결정 네 개</a:t>
             </a:r>
           </a:p>
         </p:txBody>
@@ -5157,7 +5329,7 @@
                 <a:ea typeface="NanumGothic"/>
                 <a:cs typeface="NanumGothic"/>
               </a:rPr>
-              <a:t>CSS에 미디어쿼리 문자열이 있다는 것만으로 1열 전환이 보장되지 않는다.</a:t>
+              <a:t>페이지 — 섹션과 순서를 고정한다 (이번엔 히어로·메뉴·지도·리뷰·CTA)</a:t>
             </a:r>
           </a:p>
         </p:txBody>
@@ -5193,7 +5365,7 @@
                 <a:ea typeface="NanumGothic"/>
                 <a:cs typeface="NanumGothic"/>
               </a:rPr>
-              <a:t>실제 렌더링된 gridTemplateColumns를 확인한다.</a:t>
+              <a:t>스택 — 생성 방식과 파일 구성을 정한다 (단일 HTML + CSS, JS 없음)</a:t>
             </a:r>
           </a:p>
         </p:txBody>
@@ -5229,14 +5401,50 @@
                 <a:ea typeface="NanumGothic"/>
                 <a:cs typeface="NanumGothic"/>
               </a:rPr>
-              <a:t>브라우저가 없으면 PASS가 아니라 UNVERIFIED(exit 2).</a:t>
-            </a:r>
-          </a:p>
-        </p:txBody>
-      </p:sp>
-      <p:sp>
-        <p:nvSpPr>
-          <p:cNvPr id="10" name="audit:source"/>
+              <a:t>디자인 — 톤·색·타이포 기준을 한 줄로 (따뜻한 크림 톤, 사진 대신 일러스트)</a:t>
+            </a:r>
+          </a:p>
+        </p:txBody>
+      </p:sp>
+      <p:sp>
+        <p:nvSpPr>
+          <p:cNvPr id="10" name="audit:body-3"/>
+          <p:cNvSpPr txBox="1"/>
+          <p:nvPr/>
+        </p:nvSpPr>
+        <p:spPr>
+          <a:xfrm>
+            <a:off x="777240" y="4782312"/>
+            <a:ext cx="10652760" cy="612648"/>
+          </a:xfrm>
+          <a:prstGeom prst="rect">
+            <a:avLst/>
+          </a:prstGeom>
+          <a:noFill/>
+        </p:spPr>
+        <p:txBody>
+          <a:bodyPr wrap="square" lIns="0" rIns="0" tIns="0" bIns="0">
+            <a:spAutoFit/>
+          </a:bodyPr>
+          <a:lstStyle/>
+          <a:p>
+            <a:r>
+              <a:rPr sz="1750" b="0">
+                <a:solidFill>
+                  <a:srgbClr val="ECF1F6"/>
+                </a:solidFill>
+                <a:latin typeface="NanumGothic"/>
+                <a:ea typeface="NanumGothic"/>
+                <a:cs typeface="NanumGothic"/>
+              </a:rPr>
+              <a:t>수용 기준 — 검사 가능한 문장으로 (390px에서 1열, 앵커 이동, JS 오류 0)</a:t>
+            </a:r>
+          </a:p>
+        </p:txBody>
+      </p:sp>
+      <p:sp>
+        <p:nvSpPr>
+          <p:cNvPr id="11" name="audit:source"/>
           <p:cNvSpPr txBox="1"/>
           <p:nvPr/>
         </p:nvSpPr>
@@ -5265,14 +5473,14 @@
                 <a:ea typeface="NanumGothic"/>
                 <a:cs typeface="NanumGothic"/>
               </a:rPr>
-              <a:t>experiments/exp04_agent_loop_sdd.py (--warm-cache = legacy)</a:t>
-            </a:r>
-          </a:p>
-        </p:txBody>
-      </p:sp>
-      <p:sp>
-        <p:nvSpPr>
-          <p:cNvPr id="11" name="audit:footer"/>
+              <a:t>demo/vibe_vs_spec/EXPERIMENT_A_PROTOCOL.md</a:t>
+            </a:r>
+          </a:p>
+        </p:txBody>
+      </p:sp>
+      <p:sp>
+        <p:nvSpPr>
+          <p:cNvPr id="12" name="audit:footer"/>
           <p:cNvSpPr txBox="1"/>
           <p:nvPr/>
         </p:nvSpPr>
@@ -5442,7 +5650,7 @@
                 <a:ea typeface="NanumGothic"/>
                 <a:cs typeface="NanumGothic"/>
               </a:rPr>
-              <a:t>외부 보고의 범위 제한</a:t>
+              <a:t>적용</a:t>
             </a:r>
           </a:p>
         </p:txBody>
@@ -5478,7 +5686,7 @@
                 <a:ea typeface="NanumGothic"/>
                 <a:cs typeface="NanumGothic"/>
               </a:rPr>
-              <a:t>반례의 비교 대상을 정확히 읽는다</a:t>
+              <a:t>다음 프로젝트에서 할 일</a:t>
             </a:r>
           </a:p>
         </p:txBody>
@@ -5514,7 +5722,7 @@
                 <a:ea typeface="NanumGothic"/>
                 <a:cs typeface="NanumGothic"/>
               </a:rPr>
-              <a:t>SDD 도구 간 비교 ≠ SDD 대 무스펙</a:t>
+              <a:t>결정 네 개를 먼저 적는다</a:t>
             </a:r>
           </a:p>
         </p:txBody>
@@ -5550,7 +5758,7 @@
                 <a:ea typeface="NanumGothic"/>
                 <a:cs typeface="NanumGothic"/>
               </a:rPr>
-              <a:t>Spec-Kit +97~109%: OpenSpec 대비 두 사례의 외부 블로그 보고. 둘 다 SDD 접근.</a:t>
+              <a:t>페이지 · 스택 · 디자인 · 수용 기준</a:t>
             </a:r>
           </a:p>
         </p:txBody>
@@ -5586,7 +5794,7 @@
                 <a:ea typeface="NanumGothic"/>
                 <a:cs typeface="NanumGothic"/>
               </a:rPr>
-              <a:t>ETH AGENTS.md 연구: 저장소 컨텍스트 파일 조건. 모든 짧은 스펙이 손해라는 실험 아님.</a:t>
+              <a:t>설명 대신 결정을 적고, 수용 기준을 코드로 옮긴다</a:t>
             </a:r>
           </a:p>
         </p:txBody>
@@ -5622,7 +5830,7 @@
                 <a:ea typeface="NanumGothic"/>
                 <a:cs typeface="NanumGothic"/>
               </a:rPr>
-              <a:t>짧고 필요한 요구사항만 쓰라는 실무 원칙은 유지하되 효과를 직접 측정한다.</a:t>
+              <a:t>완료 후 재작업 횟수와 총비용을 기록한다</a:t>
             </a:r>
           </a:p>
         </p:txBody>
@@ -5658,7 +5866,7 @@
                 <a:ea typeface="NanumGothic"/>
                 <a:cs typeface="NanumGothic"/>
               </a:rPr>
-              <a:t>SOURCES.md §4 · arxiv.org/html/2602.11988v1</a:t>
+              <a:t>demo/vibe_vs_spec/README.md</a:t>
             </a:r>
           </a:p>
         </p:txBody>
@@ -5835,7 +6043,7 @@
                 <a:ea typeface="NanumGothic"/>
                 <a:cs typeface="NanumGothic"/>
               </a:rPr>
-              <a:t>후속 계획 / 미실행</a:t>
+              <a:t>재현</a:t>
             </a:r>
           </a:p>
         </p:txBody>
@@ -5871,7 +6079,7 @@
                 <a:ea typeface="NanumGothic"/>
                 <a:cs typeface="NanumGothic"/>
               </a:rPr>
-              <a:t>다음 실험: 스펙이 재작업을 줄이는가</a:t>
+              <a:t>재현</a:t>
             </a:r>
           </a:p>
         </p:txBody>
@@ -5899,7 +6107,7 @@
           <a:lstStyle/>
           <a:p>
             <a:r>
-              <a:rPr sz="2900" b="1">
+              <a:rPr sz="2400" b="1">
                 <a:solidFill>
                   <a:srgbClr val="36D399"/>
                 </a:solidFill>
@@ -5907,7 +6115,7 @@
                 <a:ea typeface="NanumGothic"/>
                 <a:cs typeface="NanumGothic"/>
               </a:rPr>
-              <a:t>사전등록된 품질·비용 비교</a:t>
+              <a:t>python demo/vibe_vs_spec/verify_ac.py</a:t>
             </a:r>
           </a:p>
         </p:txBody>
@@ -5943,7 +6151,7 @@
                 <a:ea typeface="NanumGothic"/>
                 <a:cs typeface="NanumGothic"/>
               </a:rPr>
-              <a:t>백지 스펙 작성 비용부터 포함하고 다수 과제를 무작위 배정한다.</a:t>
+              <a:t>이미지 · usage 추정치 · 검사 스크립트가 저장소에 있다</a:t>
             </a:r>
           </a:p>
         </p:txBody>
@@ -5979,7 +6187,7 @@
                 <a:ea typeface="NanumGothic"/>
                 <a:cs typeface="NanumGothic"/>
               </a:rPr>
-              <a:t>같은 AC·모델·출력 예산·가격·캐시 조건으로 성공률과 총비용을 기록한다.</a:t>
+              <a:t>브라우저가 없으면 UNVERIFIED로 종료한다</a:t>
             </a:r>
           </a:p>
         </p:txBody>
@@ -6015,7 +6223,7 @@
                 <a:ea typeface="NanumGothic"/>
                 <a:cs typeface="NanumGothic"/>
               </a:rPr>
-              <a:t>진행하지 않은 실험의 절감률은 결과로 채우지 않는다.</a:t>
+              <a:t>덱과 대본도 같은 원천에서 생성된다</a:t>
             </a:r>
           </a:p>
         </p:txBody>
@@ -6051,7 +6259,400 @@
                 <a:ea typeface="NanumGothic"/>
                 <a:cs typeface="NanumGothic"/>
               </a:rPr>
-              <a:t>demo/vibe_vs_spec/EXPERIMENT_A_PROTOCOL.md</a:t>
+              <a:t>demo/vibe_vs_spec/</a:t>
+            </a:r>
+          </a:p>
+        </p:txBody>
+      </p:sp>
+      <p:sp>
+        <p:nvSpPr>
+          <p:cNvPr id="11" name="audit:footer"/>
+          <p:cNvSpPr txBox="1"/>
+          <p:nvPr/>
+        </p:nvSpPr>
+        <p:spPr>
+          <a:xfrm>
+            <a:off x="640080" y="6419088"/>
+            <a:ext cx="10972800" cy="256032"/>
+          </a:xfrm>
+          <a:prstGeom prst="rect">
+            <a:avLst/>
+          </a:prstGeom>
+          <a:noFill/>
+        </p:spPr>
+        <p:txBody>
+          <a:bodyPr wrap="square" lIns="0" rIns="0" tIns="0" bIns="0">
+            <a:spAutoFit/>
+          </a:bodyPr>
+          <a:lstStyle/>
+          <a:p>
+            <a:r>
+              <a:rPr sz="1000" b="0">
+                <a:solidFill>
+                  <a:srgbClr val="93A4B5"/>
+                </a:solidFill>
+                <a:latin typeface="NanumGothic"/>
+                <a:ea typeface="NanumGothic"/>
+                <a:cs typeface="NanumGothic"/>
+              </a:rPr>
+              <a:t>2026-09-20  ·  근거와 조건을 함께 인용</a:t>
+            </a:r>
+          </a:p>
+        </p:txBody>
+      </p:sp>
+    </p:spTree>
+  </p:cSld>
+  <p:clrMapOvr>
+    <a:masterClrMapping/>
+  </p:clrMapOvr>
+</p:sld>
+</file>
+
+<file path=ppt/slides/slide13.xml><?xml version="1.0" encoding="utf-8"?>
+<p:sld xmlns:a="http://schemas.openxmlformats.org/drawingml/2006/main" xmlns:p="http://schemas.openxmlformats.org/presentationml/2006/main" xmlns:r="http://schemas.openxmlformats.org/officeDocument/2006/relationships">
+  <p:cSld>
+    <p:bg>
+      <p:bgPr>
+        <a:solidFill>
+          <a:srgbClr val="0E141B"/>
+        </a:solidFill>
+        <a:effectLst/>
+      </p:bgPr>
+    </p:bg>
+    <p:spTree>
+      <p:nvGrpSpPr>
+        <p:cNvPr id="1" name=""/>
+        <p:cNvGrpSpPr/>
+        <p:nvPr/>
+      </p:nvGrpSpPr>
+      <p:grpSpPr/>
+      <p:sp>
+        <p:nvSpPr>
+          <p:cNvPr id="2" name="Rectangle 1"/>
+          <p:cNvSpPr/>
+          <p:nvPr/>
+        </p:nvSpPr>
+        <p:spPr>
+          <a:xfrm>
+            <a:off x="0" y="0"/>
+            <a:ext cx="100584" cy="6858000"/>
+          </a:xfrm>
+          <a:prstGeom prst="rect">
+            <a:avLst/>
+          </a:prstGeom>
+          <a:solidFill>
+            <a:srgbClr val="36D399"/>
+          </a:solidFill>
+          <a:ln>
+            <a:noFill/>
+          </a:ln>
+        </p:spPr>
+        <p:style>
+          <a:lnRef idx="1">
+            <a:schemeClr val="accent1"/>
+          </a:lnRef>
+          <a:fillRef idx="3">
+            <a:schemeClr val="accent1"/>
+          </a:fillRef>
+          <a:effectRef idx="2">
+            <a:schemeClr val="accent1"/>
+          </a:effectRef>
+          <a:fontRef idx="minor">
+            <a:schemeClr val="lt1"/>
+          </a:fontRef>
+        </p:style>
+        <p:txBody>
+          <a:bodyPr rtlCol="0" anchor="ctr"/>
+          <a:lstStyle/>
+          <a:p>
+            <a:pPr algn="ctr"/>
+          </a:p>
+        </p:txBody>
+      </p:sp>
+      <p:sp>
+        <p:nvSpPr>
+          <p:cNvPr id="3" name="audit:index"/>
+          <p:cNvSpPr txBox="1"/>
+          <p:nvPr/>
+        </p:nvSpPr>
+        <p:spPr>
+          <a:xfrm>
+            <a:off x="640080" y="274320"/>
+            <a:ext cx="4572000" cy="274320"/>
+          </a:xfrm>
+          <a:prstGeom prst="rect">
+            <a:avLst/>
+          </a:prstGeom>
+          <a:noFill/>
+        </p:spPr>
+        <p:txBody>
+          <a:bodyPr wrap="square" lIns="0" rIns="0" tIns="0" bIns="0">
+            <a:spAutoFit/>
+          </a:bodyPr>
+          <a:lstStyle/>
+          <a:p>
+            <a:r>
+              <a:rPr sz="1100" b="0">
+                <a:solidFill>
+                  <a:srgbClr val="93A4B5"/>
+                </a:solidFill>
+                <a:latin typeface="NanumGothic"/>
+                <a:ea typeface="NanumGothic"/>
+                <a:cs typeface="NanumGothic"/>
+              </a:rPr>
+              <a:t>TOKEN COST LAB  /  13</a:t>
+            </a:r>
+          </a:p>
+        </p:txBody>
+      </p:sp>
+      <p:sp>
+        <p:nvSpPr>
+          <p:cNvPr id="4" name="audit:scope"/>
+          <p:cNvSpPr txBox="1"/>
+          <p:nvPr/>
+        </p:nvSpPr>
+        <p:spPr>
+          <a:xfrm>
+            <a:off x="5760720" y="274320"/>
+            <a:ext cx="5760720" cy="274320"/>
+          </a:xfrm>
+          <a:prstGeom prst="rect">
+            <a:avLst/>
+          </a:prstGeom>
+          <a:noFill/>
+        </p:spPr>
+        <p:txBody>
+          <a:bodyPr wrap="square" lIns="0" rIns="0" tIns="0" bIns="0">
+            <a:spAutoFit/>
+          </a:bodyPr>
+          <a:lstStyle/>
+          <a:p>
+            <a:r>
+              <a:rPr sz="1100" b="0">
+                <a:solidFill>
+                  <a:srgbClr val="36D399"/>
+                </a:solidFill>
+                <a:latin typeface="NanumGothic"/>
+                <a:ea typeface="NanumGothic"/>
+                <a:cs typeface="NanumGothic"/>
+              </a:rPr>
+              <a:t>마무리</a:t>
+            </a:r>
+          </a:p>
+        </p:txBody>
+      </p:sp>
+      <p:sp>
+        <p:nvSpPr>
+          <p:cNvPr id="5" name="audit:title"/>
+          <p:cNvSpPr txBox="1"/>
+          <p:nvPr/>
+        </p:nvSpPr>
+        <p:spPr>
+          <a:xfrm>
+            <a:off x="640080" y="822960"/>
+            <a:ext cx="10881360" cy="822960"/>
+          </a:xfrm>
+          <a:prstGeom prst="rect">
+            <a:avLst/>
+          </a:prstGeom>
+          <a:noFill/>
+        </p:spPr>
+        <p:txBody>
+          <a:bodyPr wrap="square" lIns="0" rIns="0" tIns="0" bIns="0">
+            <a:spAutoFit/>
+          </a:bodyPr>
+          <a:lstStyle/>
+          <a:p>
+            <a:r>
+              <a:rPr sz="2900" b="1">
+                <a:solidFill>
+                  <a:srgbClr val="ECF1F6"/>
+                </a:solidFill>
+                <a:latin typeface="NanumGothic"/>
+                <a:ea typeface="NanumGothic"/>
+                <a:cs typeface="NanumGothic"/>
+              </a:rPr>
+              <a:t>마무리</a:t>
+            </a:r>
+          </a:p>
+        </p:txBody>
+      </p:sp>
+      <p:sp>
+        <p:nvSpPr>
+          <p:cNvPr id="6" name="audit:hero"/>
+          <p:cNvSpPr txBox="1"/>
+          <p:nvPr/>
+        </p:nvSpPr>
+        <p:spPr>
+          <a:xfrm>
+            <a:off x="640080" y="1783080"/>
+            <a:ext cx="10881360" cy="777240"/>
+          </a:xfrm>
+          <a:prstGeom prst="rect">
+            <a:avLst/>
+          </a:prstGeom>
+          <a:noFill/>
+        </p:spPr>
+        <p:txBody>
+          <a:bodyPr wrap="square" lIns="0" rIns="0" tIns="0" bIns="0">
+            <a:spAutoFit/>
+          </a:bodyPr>
+          <a:lstStyle/>
+          <a:p>
+            <a:r>
+              <a:rPr sz="2900" b="1">
+                <a:solidFill>
+                  <a:srgbClr val="36D399"/>
+                </a:solidFill>
+                <a:latin typeface="NanumGothic"/>
+                <a:ea typeface="NanumGothic"/>
+                <a:cs typeface="NanumGothic"/>
+              </a:rPr>
+              <a:t>스펙은 짧게, 결정만</a:t>
+            </a:r>
+          </a:p>
+        </p:txBody>
+      </p:sp>
+      <p:sp>
+        <p:nvSpPr>
+          <p:cNvPr id="7" name="audit:body-0"/>
+          <p:cNvSpPr txBox="1"/>
+          <p:nvPr/>
+        </p:nvSpPr>
+        <p:spPr>
+          <a:xfrm>
+            <a:off x="777240" y="2862072"/>
+            <a:ext cx="10652760" cy="612648"/>
+          </a:xfrm>
+          <a:prstGeom prst="rect">
+            <a:avLst/>
+          </a:prstGeom>
+          <a:noFill/>
+        </p:spPr>
+        <p:txBody>
+          <a:bodyPr wrap="square" lIns="0" rIns="0" tIns="0" bIns="0">
+            <a:spAutoFit/>
+          </a:bodyPr>
+          <a:lstStyle/>
+          <a:p>
+            <a:r>
+              <a:rPr sz="1750" b="0">
+                <a:solidFill>
+                  <a:srgbClr val="ECF1F6"/>
+                </a:solidFill>
+                <a:latin typeface="NanumGothic"/>
+                <a:ea typeface="NanumGothic"/>
+                <a:cs typeface="NanumGothic"/>
+              </a:rPr>
+              <a:t>서론 대신 페이지 · 스택 · 디자인 · 수용 기준</a:t>
+            </a:r>
+          </a:p>
+        </p:txBody>
+      </p:sp>
+      <p:sp>
+        <p:nvSpPr>
+          <p:cNvPr id="8" name="audit:body-1"/>
+          <p:cNvSpPr txBox="1"/>
+          <p:nvPr/>
+        </p:nvSpPr>
+        <p:spPr>
+          <a:xfrm>
+            <a:off x="777240" y="3502152"/>
+            <a:ext cx="10652760" cy="612648"/>
+          </a:xfrm>
+          <a:prstGeom prst="rect">
+            <a:avLst/>
+          </a:prstGeom>
+          <a:noFill/>
+        </p:spPr>
+        <p:txBody>
+          <a:bodyPr wrap="square" lIns="0" rIns="0" tIns="0" bIns="0">
+            <a:spAutoFit/>
+          </a:bodyPr>
+          <a:lstStyle/>
+          <a:p>
+            <a:r>
+              <a:rPr sz="1750" b="0">
+                <a:solidFill>
+                  <a:srgbClr val="ECF1F6"/>
+                </a:solidFill>
+                <a:latin typeface="NanumGothic"/>
+                <a:ea typeface="NanumGothic"/>
+                <a:cs typeface="NanumGothic"/>
+              </a:rPr>
+              <a:t>되돌림이 줄면 턴 수가 줄고 비용도 줄어든다</a:t>
+            </a:r>
+          </a:p>
+        </p:txBody>
+      </p:sp>
+      <p:sp>
+        <p:nvSpPr>
+          <p:cNvPr id="9" name="audit:body-2"/>
+          <p:cNvSpPr txBox="1"/>
+          <p:nvPr/>
+        </p:nvSpPr>
+        <p:spPr>
+          <a:xfrm>
+            <a:off x="777240" y="4142231"/>
+            <a:ext cx="10652760" cy="612648"/>
+          </a:xfrm>
+          <a:prstGeom prst="rect">
+            <a:avLst/>
+          </a:prstGeom>
+          <a:noFill/>
+        </p:spPr>
+        <p:txBody>
+          <a:bodyPr wrap="square" lIns="0" rIns="0" tIns="0" bIns="0">
+            <a:spAutoFit/>
+          </a:bodyPr>
+          <a:lstStyle/>
+          <a:p>
+            <a:r>
+              <a:rPr sz="1750" b="0">
+                <a:solidFill>
+                  <a:srgbClr val="ECF1F6"/>
+                </a:solidFill>
+                <a:latin typeface="NanumGothic"/>
+                <a:ea typeface="NanumGothic"/>
+                <a:cs typeface="NanumGothic"/>
+              </a:rPr>
+              <a:t>다음 사례는 다수 과제 A/B로 검증한다</a:t>
+            </a:r>
+          </a:p>
+        </p:txBody>
+      </p:sp>
+      <p:sp>
+        <p:nvSpPr>
+          <p:cNvPr id="10" name="audit:source"/>
+          <p:cNvSpPr txBox="1"/>
+          <p:nvPr/>
+        </p:nvSpPr>
+        <p:spPr>
+          <a:xfrm>
+            <a:off x="640080" y="6080760"/>
+            <a:ext cx="10972800" cy="274320"/>
+          </a:xfrm>
+          <a:prstGeom prst="rect">
+            <a:avLst/>
+          </a:prstGeom>
+          <a:noFill/>
+        </p:spPr>
+        <p:txBody>
+          <a:bodyPr wrap="square" lIns="0" rIns="0" tIns="0" bIns="0">
+            <a:spAutoFit/>
+          </a:bodyPr>
+          <a:lstStyle/>
+          <a:p>
+            <a:r>
+              <a:rPr sz="1000" b="0">
+                <a:solidFill>
+                  <a:srgbClr val="93A4B5"/>
+                </a:solidFill>
+                <a:latin typeface="NanumGothic"/>
+                <a:ea typeface="NanumGothic"/>
+                <a:cs typeface="NanumGothic"/>
+              </a:rPr>
+              <a:t>demo/vibe_vs_spec/README.md</a:t>
             </a:r>
           </a:p>
         </p:txBody>
@@ -6228,7 +6829,7 @@
                 <a:ea typeface="NanumGothic"/>
                 <a:cs typeface="NanumGothic"/>
               </a:rPr>
-              <a:t>추정 usage의 비용 재계산</a:t>
+              <a:t>추정 usage 재계산</a:t>
             </a:r>
           </a:p>
         </p:txBody>
@@ -6264,7 +6865,7 @@
                 <a:ea typeface="NanumGothic"/>
                 <a:cs typeface="NanumGothic"/>
               </a:rPr>
-              <a:t>카페 케이스: 절감 관측의 증거 수준</a:t>
+              <a:t>사례 · 카페 랜딩 한 페이지</a:t>
             </a:r>
           </a:p>
         </p:txBody>
@@ -6300,7 +6901,7 @@
                 <a:ea typeface="NanumGothic"/>
                 <a:cs typeface="NanumGothic"/>
               </a:rPr>
-              <a:t>usage 추정치 환산 -8.3%</a:t>
+              <a:t>토큰 +1.8% · 비용 8.3% 감소</a:t>
             </a:r>
           </a:p>
         </p:txBody>
@@ -6336,7 +6937,7 @@
                 <a:ea typeface="NanumGothic"/>
                 <a:cs typeface="NanumGothic"/>
               </a:rPr>
-              <a:t>고정 usage 추정치 + GPT-5 단가: $0.07135 → $0.06540</a:t>
+              <a:t>한 문장 지시 vs 4필드 스펙 — 같은 목표</a:t>
             </a:r>
           </a:p>
         </p:txBody>
@@ -6372,7 +6973,7 @@
                 <a:ea typeface="NanumGothic"/>
                 <a:cs typeface="NanumGothic"/>
               </a:rPr>
-              <a:t>토큰 합계 7,868 → 8,010 (+1.8%). 실제 청구 usage가 아니라 세션 추정치다.</a:t>
+              <a:t>GPT-5 8.3% · Sonnet 7.6% · 캐시 미적용 8.1%</a:t>
             </a:r>
           </a:p>
         </p:txBody>
@@ -6408,50 +7009,14 @@
                 <a:ea typeface="NanumGothic"/>
                 <a:cs typeface="NanumGothic"/>
               </a:rPr>
-              <a:t>캐시 적격성 미확인. 모든 추정 입력을 신규 입력으로 환산하면 -8.1%.</a:t>
-            </a:r>
-          </a:p>
-        </p:txBody>
-      </p:sp>
-      <p:sp>
-        <p:nvSpPr>
-          <p:cNvPr id="10" name="audit:body-3"/>
-          <p:cNvSpPr txBox="1"/>
-          <p:nvPr/>
-        </p:nvSpPr>
-        <p:spPr>
-          <a:xfrm>
-            <a:off x="777240" y="4782312"/>
-            <a:ext cx="10652760" cy="612648"/>
-          </a:xfrm>
-          <a:prstGeom prst="rect">
-            <a:avLst/>
-          </a:prstGeom>
-          <a:noFill/>
-        </p:spPr>
-        <p:txBody>
-          <a:bodyPr wrap="square" lIns="0" rIns="0" tIns="0" bIns="0">
-            <a:spAutoFit/>
-          </a:bodyPr>
-          <a:lstStyle/>
-          <a:p>
-            <a:r>
-              <a:rPr sz="1750" b="0">
-                <a:solidFill>
-                  <a:srgbClr val="ECF1F6"/>
-                </a:solidFill>
-                <a:latin typeface="NanumGothic"/>
-                <a:ea typeface="NanumGothic"/>
-                <a:cs typeface="NanumGothic"/>
-              </a:rPr>
-              <a:t>Spec은 Vibe 결과를 역산. 백지 스펙 비용·재작업 감소·품질 동등성을 검증한 것은 아니다.</a:t>
-            </a:r>
-          </a:p>
-        </p:txBody>
-      </p:sp>
-      <p:sp>
-        <p:nvSpPr>
-          <p:cNvPr id="11" name="audit:source"/>
+              <a:t>입력은 늘고, 비싼 출력은 줄었다</a:t>
+            </a:r>
+          </a:p>
+        </p:txBody>
+      </p:sp>
+      <p:sp>
+        <p:nvSpPr>
+          <p:cNvPr id="10" name="audit:source"/>
           <p:cNvSpPr txBox="1"/>
           <p:nvPr/>
         </p:nvSpPr>
@@ -6480,14 +7045,14 @@
                 <a:ea typeface="NanumGothic"/>
                 <a:cs typeface="NanumGothic"/>
               </a:rPr>
-              <a:t>demo/vibe_vs_spec/usage.json · verify_ac.py</a:t>
-            </a:r>
-          </a:p>
-        </p:txBody>
-      </p:sp>
-      <p:sp>
-        <p:nvSpPr>
-          <p:cNvPr id="12" name="audit:footer"/>
+              <a:t>demo/vibe_vs_spec/README.md</a:t>
+            </a:r>
+          </a:p>
+        </p:txBody>
+      </p:sp>
+      <p:sp>
+        <p:nvSpPr>
+          <p:cNvPr id="11" name="audit:footer"/>
           <p:cNvSpPr txBox="1"/>
           <p:nvPr/>
         </p:nvSpPr>
@@ -6707,7 +7272,7 @@
         <p:spPr>
           <a:xfrm>
             <a:off x="640080" y="1783080"/>
-            <a:ext cx="10881360" cy="777240"/>
+            <a:ext cx="6583680" cy="777240"/>
           </a:xfrm>
           <a:prstGeom prst="rect">
             <a:avLst/>
@@ -6765,7 +7330,7 @@
                 <a:ea typeface="NanumGothic"/>
                 <a:cs typeface="NanumGothic"/>
               </a:rPr>
-              <a:t>두 장 모두 실제 생성 HTML을 Chromium 1280px에서 캡처한 화면이다.</a:t>
+              <a:t>두 장 모두 실제 생성 HTML을 Chromium 1280px에서 캡처</a:t>
             </a:r>
           </a:p>
         </p:txBody>
@@ -6801,7 +7366,7 @@
                 <a:ea typeface="NanumGothic"/>
                 <a:cs typeface="NanumGothic"/>
               </a:rPr>
-              <a:t>보이는 화면이 비슷하다는 것이 품질 동등성의 증거는 아니다.</a:t>
+              <a:t>다른 점은 토큰 구조와 검사 결과에 있다</a:t>
             </a:r>
           </a:p>
         </p:txBody>
@@ -7134,7 +7699,7 @@
                 <a:ea typeface="NanumGothic"/>
                 <a:cs typeface="NanumGothic"/>
               </a:rPr>
-              <a:t>반응형 스크린샷</a:t>
+              <a:t>전체 페이지 축소 비교</a:t>
             </a:r>
           </a:p>
         </p:txBody>
@@ -7170,7 +7735,7 @@
                 <a:ea typeface="NanumGothic"/>
                 <a:cs typeface="NanumGothic"/>
               </a:rPr>
-              <a:t>모바일 390px에서도 같은 1열</a:t>
+              <a:t>전체 페이지 길이 비교</a:t>
             </a:r>
           </a:p>
         </p:txBody>
@@ -7184,7 +7749,7 @@
         <p:spPr>
           <a:xfrm>
             <a:off x="640080" y="1783080"/>
-            <a:ext cx="10881360" cy="777240"/>
+            <a:ext cx="6583680" cy="777240"/>
           </a:xfrm>
           <a:prstGeom prst="rect">
             <a:avLst/>
@@ -7206,7 +7771,7 @@
                 <a:ea typeface="NanumGothic"/>
                 <a:cs typeface="NanumGothic"/>
               </a:rPr>
-              <a:t>정적 문자열이 아니라 실제 렌더링</a:t>
+              <a:t>세로로 긴 한 페이지, 두 산출물</a:t>
             </a:r>
           </a:p>
         </p:txBody>
@@ -7242,7 +7807,7 @@
                 <a:ea typeface="NanumGothic"/>
                 <a:cs typeface="NanumGothic"/>
               </a:rPr>
-              <a:t>문자열 검사만으로는 2열로 바뀌어도 통과한다.</a:t>
+              <a:t>원본 캡처 두 장을 같은 높이로 축소해 나란히 붙였다</a:t>
             </a:r>
           </a:p>
         </p:txBody>
@@ -7278,14 +7843,14 @@
                 <a:ea typeface="NanumGothic"/>
                 <a:cs typeface="NanumGothic"/>
               </a:rPr>
-              <a:t>아래 그림은 현재 Spec 산출물을 390px에서 캡처한 것이다.</a:t>
+              <a:t>구성 요소 수와 배치가 비슷한지 눈으로 확인한다</a:t>
             </a:r>
           </a:p>
         </p:txBody>
       </p:sp>
       <p:pic>
         <p:nvPicPr>
-          <p:cNvPr id="9" name="Picture 8" descr="spec_mobile.png"/>
+          <p:cNvPr id="9" name="Picture 8" descr="vibe_spec_full_2up.png"/>
           <p:cNvPicPr>
             <a:picLocks noChangeAspect="1"/>
           </p:cNvPicPr>
@@ -7299,8 +7864,8 @@
         </p:blipFill>
         <p:spPr>
           <a:xfrm>
-            <a:off x="8654893" y="2103120"/>
-            <a:ext cx="1618292" cy="3502152"/>
+            <a:off x="8120089" y="2103120"/>
+            <a:ext cx="2687901" cy="3502152"/>
           </a:xfrm>
           <a:prstGeom prst="rect">
             <a:avLst/>
@@ -7338,7 +7903,7 @@
                 <a:ea typeface="NanumGothic"/>
                 <a:cs typeface="NanumGothic"/>
               </a:rPr>
-              <a:t>Spec 산출물 · 390×844 캡처</a:t>
+              <a:t>왼쪽 Vibe 전체 페이지 · 오른쪽 Spec 전체 페이지 (축소)</a:t>
             </a:r>
           </a:p>
         </p:txBody>
@@ -7374,7 +7939,7 @@
                 <a:ea typeface="NanumGothic"/>
                 <a:cs typeface="NanumGothic"/>
               </a:rPr>
-              <a:t>demo/vibe_vs_spec/shots/spec_mobile.png</a:t>
+              <a:t>demo/vibe_vs_spec/shots/vibe_full.png · demo/vibe_vs_spec/shots/spec_full.png</a:t>
             </a:r>
           </a:p>
         </p:txBody>
@@ -7551,7 +8116,7 @@
                 <a:ea typeface="NanumGothic"/>
                 <a:cs typeface="NanumGothic"/>
               </a:rPr>
-              <a:t>전체 페이지 축소 비교</a:t>
+              <a:t>반응형 스크린샷</a:t>
             </a:r>
           </a:p>
         </p:txBody>
@@ -7587,7 +8152,7 @@
                 <a:ea typeface="NanumGothic"/>
                 <a:cs typeface="NanumGothic"/>
               </a:rPr>
-              <a:t>전체 페이지 길이 비교</a:t>
+              <a:t>모바일 390px에서도 같은 1열</a:t>
             </a:r>
           </a:p>
         </p:txBody>
@@ -7601,7 +8166,7 @@
         <p:spPr>
           <a:xfrm>
             <a:off x="640080" y="1783080"/>
-            <a:ext cx="10881360" cy="777240"/>
+            <a:ext cx="6583680" cy="777240"/>
           </a:xfrm>
           <a:prstGeom prst="rect">
             <a:avLst/>
@@ -7623,7 +8188,7 @@
                 <a:ea typeface="NanumGothic"/>
                 <a:cs typeface="NanumGothic"/>
               </a:rPr>
-              <a:t>세로로 긴 한 페이지, 두 산출물</a:t>
+              <a:t>정적 문자열이 아니라 실제 렌더링</a:t>
             </a:r>
           </a:p>
         </p:txBody>
@@ -7659,7 +8224,7 @@
                 <a:ea typeface="NanumGothic"/>
                 <a:cs typeface="NanumGothic"/>
               </a:rPr>
-              <a:t>원본 캡처 1,280×3,400 두 장을 같은 높이로 축소해 나란히 붙였다.</a:t>
+              <a:t>문자열 검사만으로는 2열로 바뀌어도 통과한다</a:t>
             </a:r>
           </a:p>
         </p:txBody>
@@ -7695,14 +8260,14 @@
                 <a:ea typeface="NanumGothic"/>
                 <a:cs typeface="NanumGothic"/>
               </a:rPr>
-              <a:t>스크롤 길이가 비슷하다는 사실은 비용·품질 동등성 판정이 아니다.</a:t>
+              <a:t>아래 그림은 현재 Spec 산출물을 390px에서 캡처한 것</a:t>
             </a:r>
           </a:p>
         </p:txBody>
       </p:sp>
       <p:pic>
         <p:nvPicPr>
-          <p:cNvPr id="9" name="Picture 8" descr="vibe_spec_full_2up.png"/>
+          <p:cNvPr id="9" name="Picture 8" descr="spec_mobile.png"/>
           <p:cNvPicPr>
             <a:picLocks noChangeAspect="1"/>
           </p:cNvPicPr>
@@ -7716,8 +8281,8 @@
         </p:blipFill>
         <p:spPr>
           <a:xfrm>
-            <a:off x="8120089" y="2103120"/>
-            <a:ext cx="2687901" cy="3502152"/>
+            <a:off x="8654893" y="2103120"/>
+            <a:ext cx="1618292" cy="3502152"/>
           </a:xfrm>
           <a:prstGeom prst="rect">
             <a:avLst/>
@@ -7755,7 +8320,7 @@
                 <a:ea typeface="NanumGothic"/>
                 <a:cs typeface="NanumGothic"/>
               </a:rPr>
-              <a:t>왼쪽 Vibe 전체 페이지 · 오른쪽 Spec 전체 페이지 (축소)</a:t>
+              <a:t>Spec 산출물 · 390×844 캡처</a:t>
             </a:r>
           </a:p>
         </p:txBody>
@@ -7791,7 +8356,7 @@
                 <a:ea typeface="NanumGothic"/>
                 <a:cs typeface="NanumGothic"/>
               </a:rPr>
-              <a:t>demo/vibe_vs_spec/shots/vibe_full.png · demo/vibe_vs_spec/shots/spec_full.png · demo/vibe_vs_spec/make_fullpage_2up.py</a:t>
+              <a:t>demo/vibe_vs_spec/shots/spec_mobile.png</a:t>
             </a:r>
           </a:p>
         </p:txBody>
@@ -8018,7 +8583,7 @@
         <p:spPr>
           <a:xfrm>
             <a:off x="640080" y="1783080"/>
-            <a:ext cx="10881360" cy="777240"/>
+            <a:ext cx="6583680" cy="777240"/>
           </a:xfrm>
           <a:prstGeom prst="rect">
             <a:avLst/>
@@ -8040,7 +8605,7 @@
                 <a:ea typeface="NanumGothic"/>
                 <a:cs typeface="NanumGothic"/>
               </a:rPr>
-              <a:t>+666 / -680 / +156</a:t>
+              <a:t>증가 666 · 감소 680 · 증가 156</a:t>
             </a:r>
           </a:p>
         </p:txBody>
@@ -8076,7 +8641,7 @@
                 <a:ea typeface="NanumGothic"/>
                 <a:cs typeface="NanumGothic"/>
               </a:rPr>
-              <a:t>이 케이스에서 input과 cache는 서로 겹치지 않는 버킷으로 정의했다.</a:t>
+              <a:t>이 케이스에서 input과 cache는 서로 겹치지 않는 버킷으로 정의</a:t>
             </a:r>
           </a:p>
         </p:txBody>
@@ -8112,7 +8677,7 @@
                 <a:ea typeface="NanumGothic"/>
                 <a:cs typeface="NanumGothic"/>
               </a:rPr>
-              <a:t>벤더 usage 필드 이름과 동일하다고 가정하면 이중 계상할 수 있다.</a:t>
+              <a:t>합계는 7,868 → 8,010 (증가 1.8%)</a:t>
             </a:r>
           </a:p>
         </p:txBody>
@@ -8601,7 +9166,7 @@
         <p:spPr>
           <a:xfrm>
             <a:off x="640080" y="1783080"/>
-            <a:ext cx="10881360" cy="777240"/>
+            <a:ext cx="6583680" cy="777240"/>
           </a:xfrm>
           <a:prstGeom prst="rect">
             <a:avLst/>
@@ -8659,7 +9224,7 @@
                 <a:ea typeface="NanumGothic"/>
                 <a:cs typeface="NanumGothic"/>
               </a:rPr>
-              <a:t>토큰은 그대로 두고 단가와 캐시 가정만 바꾼 산술이다.</a:t>
+              <a:t>같은 추정 토큰을 세 단가로 환산한 표</a:t>
             </a:r>
           </a:p>
         </p:txBody>
@@ -8695,7 +9260,7 @@
                 <a:ea typeface="NanumGothic"/>
                 <a:cs typeface="NanumGothic"/>
               </a:rPr>
-              <a:t>다른 모델을 실행한 실측이 아니며, 캐시 적격성은 미확인이다.</a:t>
+              <a:t>모델을 바꿔도 방향은 같다</a:t>
             </a:r>
           </a:p>
         </p:txBody>
@@ -8907,7 +9472,7 @@
                 <a:ea typeface="NanumGothic"/>
                 <a:cs typeface="NanumGothic"/>
               </a:rPr>
-              <a:t>demo/vibe_vs_spec/cost_comparison.md · verify_case.py</a:t>
+              <a:t>presentation/case_vibe_vs_spec/cost_comparison.md</a:t>
             </a:r>
           </a:p>
         </p:txBody>
@@ -9134,7 +9699,7 @@
         <p:spPr>
           <a:xfrm>
             <a:off x="640080" y="1783080"/>
-            <a:ext cx="10881360" cy="777240"/>
+            <a:ext cx="6583680" cy="777240"/>
           </a:xfrm>
           <a:prstGeom prst="rect">
             <a:avLst/>
@@ -9192,7 +9757,7 @@
                 <a:ea typeface="NanumGothic"/>
                 <a:cs typeface="NanumGothic"/>
               </a:rPr>
-              <a:t>r = 출력/입력 단가, h = 캐시 읽기/입력 단가.</a:t>
+              <a:t>r = 출력/입력 단가, h = 캐시 읽기/입력 단가</a:t>
             </a:r>
           </a:p>
         </p:txBody>
@@ -9228,7 +9793,7 @@
                 <a:ea typeface="NanumGothic"/>
                 <a:cs typeface="NanumGothic"/>
               </a:rPr>
-              <a:t>모든 가격 체계에서의 보편 법칙이 아니라 고정 토큰 이동의 감도 분석이다.</a:t>
+              <a:t>출력 단가가 조금만 높아도 스펙 쪽이 유리해진다</a:t>
             </a:r>
           </a:p>
         </p:txBody>
@@ -9667,7 +10232,7 @@
                 <a:ea typeface="NanumGothic"/>
                 <a:cs typeface="NanumGothic"/>
               </a:rPr>
-              <a:t>현재 산출물의 실행 검사</a:t>
+              <a:t>실동작 검사 (Chromium)</a:t>
             </a:r>
           </a:p>
         </p:txBody>
@@ -9703,7 +10268,7 @@
                 <a:ea typeface="NanumGothic"/>
                 <a:cs typeface="NanumGothic"/>
               </a:rPr>
-              <a:t>품질 동등성 대신 실제 AC 범위를 공개</a:t>
+              <a:t>무엇을 확인했나</a:t>
             </a:r>
           </a:p>
         </p:txBody>
@@ -9739,7 +10304,7 @@
                 <a:ea typeface="NanumGothic"/>
                 <a:cs typeface="NanumGothic"/>
               </a:rPr>
-              <a:t>정적 16항목 + 브라우저 29항목</a:t>
+              <a:t>정적 16 + 브라우저 29항목</a:t>
             </a:r>
           </a:p>
         </p:txBody>
@@ -9775,7 +10340,7 @@
                 <a:ea typeface="NanumGothic"/>
                 <a:cs typeface="NanumGothic"/>
               </a:rPr>
-              <a:t>390/820/821/1280px 그리드·메뉴 표시·가로 스크롤 검사</a:t>
+              <a:t>390 · 820 · 821 · 1280px 렌더링과 앵커 이동 검사</a:t>
             </a:r>
           </a:p>
         </p:txBody>
@@ -9811,50 +10376,14 @@
                 <a:ea typeface="NanumGothic"/>
                 <a:cs typeface="NanumGothic"/>
               </a:rPr>
-              <a:t>각 카드의 내용과 세 앵커의 실제 스크롤 이동 검사</a:t>
-            </a:r>
-          </a:p>
-        </p:txBody>
-      </p:sp>
-      <p:sp>
-        <p:nvSpPr>
-          <p:cNvPr id="9" name="audit:body-2"/>
-          <p:cNvSpPr txBox="1"/>
-          <p:nvPr/>
-        </p:nvSpPr>
-        <p:spPr>
-          <a:xfrm>
-            <a:off x="777240" y="4142231"/>
-            <a:ext cx="10652760" cy="612648"/>
-          </a:xfrm>
-          <a:prstGeom prst="rect">
-            <a:avLst/>
-          </a:prstGeom>
-          <a:noFill/>
-        </p:spPr>
-        <p:txBody>
-          <a:bodyPr wrap="square" lIns="0" rIns="0" tIns="0" bIns="0">
-            <a:spAutoFit/>
-          </a:bodyPr>
-          <a:lstStyle/>
-          <a:p>
-            <a:r>
-              <a:rPr sz="1750" b="0">
-                <a:solidFill>
-                  <a:srgbClr val="ECF1F6"/>
-                </a:solidFill>
-                <a:latin typeface="NanumGothic"/>
-                <a:ea typeface="NanumGothic"/>
-                <a:cs typeface="NanumGothic"/>
-              </a:rPr>
-              <a:t>디자인 선호도·모든 사용자 의도·두 생성 과정의 품질 동등성은 검증하지 않는다.</a:t>
-            </a:r>
-          </a:p>
-        </p:txBody>
-      </p:sp>
-      <p:sp>
-        <p:nvSpPr>
-          <p:cNvPr id="10" name="audit:source"/>
+              <a:t>실패하는 변조를 넣어 검사가 실제로 잡는지도 확인</a:t>
+            </a:r>
+          </a:p>
+        </p:txBody>
+      </p:sp>
+      <p:sp>
+        <p:nvSpPr>
+          <p:cNvPr id="9" name="audit:source"/>
           <p:cNvSpPr txBox="1"/>
           <p:nvPr/>
         </p:nvSpPr>
@@ -9883,14 +10412,14 @@
                 <a:ea typeface="NanumGothic"/>
                 <a:cs typeface="NanumGothic"/>
               </a:rPr>
-              <a:t>demo/vibe_vs_spec/verify_ac.py · tools/browser_ac.py</a:t>
-            </a:r>
-          </a:p>
-        </p:txBody>
-      </p:sp>
-      <p:sp>
-        <p:nvSpPr>
-          <p:cNvPr id="11" name="audit:footer"/>
+              <a:t>demo/vibe_vs_spec/verify_ac.py</a:t>
+            </a:r>
+          </a:p>
+        </p:txBody>
+      </p:sp>
+      <p:sp>
+        <p:nvSpPr>
+          <p:cNvPr id="10" name="audit:footer"/>
           <p:cNvSpPr txBox="1"/>
           <p:nvPr/>
         </p:nvSpPr>

</xml_diff>

<commit_message>
feat: put unit-price and token-usage graphs into all five decks
발표 자료에 숫자 비교가 안 보인다는 지적에 따라, 단가·사용량을 그래프로 그려
슬라이드 상단 메시지 아래에 전폭으로 넣었다(덱당 2~5장, 총 19장).

- presentation/deckgen/make_charts.py: 그래프 8종 생성기
  단가(입력·출력, 로그축) · 토크나이저 · 캐시 3분기 · 턴 수(컴팩션 포함) ·
  레버 적층 · 사고 예산(로그축) · 케이스 토큰 구조 · 케이스 단가 3종
  계열값·파일 해시를 charts/manifest.json에 기록(결정적 렌더, 반복 실행 시 바이트 동일)
- 덱 구성 확대: 통합 36 · 본편 27 · 보너스 14 · 에이전트 22 · 케이스 15장
- 차트 수치는 이미지 안에 있고 슬라이드 본문은 같은 값을 굵게 한 번만 표기
- 검증: 슬라이드 삽입 이미지가 생성 PNG와 바이트 동일, 계열값은 원자료 재계산과
  일치, manifest 해시 일치 — 테스트 4개 추가(pytest 117)
- reproduce_audit가 차트 → 덱 순서로 재생성, requirements-dev에 matplotlib 추가
- 문서 동기화: presentation/README(그래프 절), RETIRED(장수·재주장 17), CORRECTIONS §5·§6
</commit_message>
<xml_diff>
--- a/presentation/case_vibe_vs_spec/vibe_vs_spec.pptx
+++ b/presentation/case_vibe_vs_spec/vibe_vs_spec.pptx
@@ -18,6 +18,8 @@
     <p:sldId id="266" r:id="rId18"/>
     <p:sldId id="267" r:id="rId19"/>
     <p:sldId id="268" r:id="rId20"/>
+    <p:sldId id="269" r:id="rId21"/>
+    <p:sldId id="270" r:id="rId22"/>
   </p:sldIdLst>
   <p:sldSz cx="12191695" cy="6858000" type="screen4x3"/>
   <p:notesSz cx="6858000" cy="9144000"/>
@@ -604,32 +606,47 @@
           <a:lstStyle/>
           <a:p>
             <a:r>
-              <a:t>네 칸은 이 사례에서 실제로 쓴 스펙의 구성이다. 각 칸은 결정 하나를 요구한다.</a:t>
-            </a:r>
-          </a:p>
-          <a:p>
-            <a:r>
-              <a:t>수용 기준은 나중에 검사 스크립트로 그대로 옮길 수 있어야 한다. '예쁘게'는 기준이 아니다.</a:t>
-            </a:r>
-          </a:p>
-          <a:p>
-            <a:r>
-              <a:t>이 템플릿의 효과는 아직 사전 등록된 다수 과제 A/B로 검증하지 않았다. 프로토콜은 저장소에 공개해 두었다.</a:t>
-            </a:r>
-          </a:p>
-          <a:p>
-            <a:r>
-              <a:t>이 사례의 목적은 '스펙을 쓰면 8% 싸다'가 아니라 '결정을 먼저 적으면 되돌림이 줄어든다'를 보이는 것이다.</a:t>
-            </a:r>
-          </a:p>
-          <a:p>
-            <a:r>
-              <a:t>근거: demo/vibe_vs_spec/EXPERIMENT_A_PROTOCOL.md</a:t>
-            </a:r>
-          </a:p>
-          <a:p>
-            <a:r>
-              <a:t>증거 범위: 스펙 템플릿</a:t>
+              <a:t>모든 가격 체계에서 항상 이긴다는 뜻이 아니라, 이 토큰 이동에서의 조건이다.</a:t>
+            </a:r>
+          </a:p>
+          <a:p>
+            <a:r>
+              <a:t>DeepSeek처럼 캐시 할인이 더 깊은 모델은 손익분기가 달라진다.</a:t>
+            </a:r>
+          </a:p>
+          <a:p>
+            <a:r>
+              <a:t>실제 청구서 대조는 하지 않았다.</a:t>
+            </a:r>
+          </a:p>
+          <a:p>
+            <a:r>
+              <a:t>손익분기 조건: r &gt; (666 + 156h) / 680</a:t>
+            </a:r>
+          </a:p>
+          <a:p>
+            <a:r>
+              <a:t>h = 0.1이면: r = 1.0024</a:t>
+            </a:r>
+          </a:p>
+          <a:p>
+            <a:r>
+              <a:t>r → ∞ 수렴: 약 9.62% 감소에 수렴</a:t>
+            </a:r>
+          </a:p>
+          <a:p>
+            <a:r>
+              <a:t>실제 청구서: 미확인 (usage 추정치 산술)</a:t>
+            </a:r>
+          </a:p>
+          <a:p>
+            <a:r>
+              <a:t>근거: demo/vibe_vs_spec/sensitivity.py</a:t>
+            </a:r>
+          </a:p>
+          <a:p>
+            <a:r>
+              <a:t>증거 범위: 단가 민감도</a:t>
             </a:r>
           </a:p>
         </p:txBody>
@@ -699,27 +716,27 @@
           <a:lstStyle/>
           <a:p>
             <a:r>
-              <a:t>네 필드는 이 사례에서 실제로 쓴 스펙의 구성이다.</a:t>
-            </a:r>
-          </a:p>
-          <a:p>
-            <a:r>
-              <a:t>스펙을 길게 쓰라는 뜻이 아니다 — 결정만 담으면 4,000토큰 이하로 충분하다.</a:t>
-            </a:r>
-          </a:p>
-          <a:p>
-            <a:r>
-              <a:t>재작업 횟수를 기록해 두면 다음 사례에서 인과를 말할 수 있다.</a:t>
-            </a:r>
-          </a:p>
-          <a:p>
-            <a:r>
-              <a:t>근거: demo/vibe_vs_spec/README.md</a:t>
-            </a:r>
-          </a:p>
-          <a:p>
-            <a:r>
-              <a:t>증거 범위: 적용</a:t>
+              <a:t>검사 항목은 산출물의 요구사항(수용 기준)에 맞춰 정의했다.</a:t>
+            </a:r>
+          </a:p>
+          <a:p>
+            <a:r>
+              <a:t>검사를 통과했다는 것이 두 생성 과정의 품질 동등성을 뜻하지는 않는다.</a:t>
+            </a:r>
+          </a:p>
+          <a:p>
+            <a:r>
+              <a:t>검사 항목 수는 실행 로그에서 확인한다.</a:t>
+            </a:r>
+          </a:p>
+          <a:p>
+            <a:r>
+              <a:t>근거: demo/vibe_vs_spec/verify_ac.py</a:t>
+            </a:r>
+          </a:p>
+          <a:p>
+            <a:r>
+              <a:t>증거 범위: 실동작 검사 (Chromium)</a:t>
             </a:r>
           </a:p>
         </p:txBody>
@@ -789,27 +806,32 @@
           <a:lstStyle/>
           <a:p>
             <a:r>
-              <a:t>터미널에서 같은 검사를 다시 돌릴 수 있다.</a:t>
-            </a:r>
-          </a:p>
-          <a:p>
-            <a:r>
-              <a:t>비교 이미지를 다시 만들려면 슬라이드에 적힌 생성 스크립트를 쓴다.</a:t>
-            </a:r>
-          </a:p>
-          <a:p>
-            <a:r>
-              <a:t>숫자를 손으로 고치면 검증이 실패한다.</a:t>
-            </a:r>
-          </a:p>
-          <a:p>
-            <a:r>
-              <a:t>근거: demo/vibe_vs_spec/</a:t>
-            </a:r>
-          </a:p>
-          <a:p>
-            <a:r>
-              <a:t>증거 범위: 재현</a:t>
+              <a:t>네 칸은 이 사례에서 실제로 쓴 스펙의 구성이다. 각 칸은 결정 하나를 요구한다.</a:t>
+            </a:r>
+          </a:p>
+          <a:p>
+            <a:r>
+              <a:t>수용 기준은 나중에 검사 스크립트로 그대로 옮길 수 있어야 한다. '예쁘게'는 기준이 아니다.</a:t>
+            </a:r>
+          </a:p>
+          <a:p>
+            <a:r>
+              <a:t>이 템플릿의 효과는 아직 사전 등록된 다수 과제 A/B로 검증하지 않았다. 프로토콜은 저장소에 공개해 두었다.</a:t>
+            </a:r>
+          </a:p>
+          <a:p>
+            <a:r>
+              <a:t>이 사례의 목적은 '스펙을 쓰면 8% 싸다'가 아니라 '결정을 먼저 적으면 되돌림이 줄어든다'를 보이는 것이다.</a:t>
+            </a:r>
+          </a:p>
+          <a:p>
+            <a:r>
+              <a:t>근거: demo/vibe_vs_spec/EXPERIMENT_A_PROTOCOL.md</a:t>
+            </a:r>
+          </a:p>
+          <a:p>
+            <a:r>
+              <a:t>증거 범위: 스펙 템플릿</a:t>
             </a:r>
           </a:p>
         </p:txBody>
@@ -879,6 +901,186 @@
           <a:lstStyle/>
           <a:p>
             <a:r>
+              <a:t>네 필드는 이 사례에서 실제로 쓴 스펙의 구성이다.</a:t>
+            </a:r>
+          </a:p>
+          <a:p>
+            <a:r>
+              <a:t>스펙을 길게 쓰라는 뜻이 아니다 — 결정만 담으면 4,000토큰 이하로 충분하다.</a:t>
+            </a:r>
+          </a:p>
+          <a:p>
+            <a:r>
+              <a:t>재작업 횟수를 기록해 두면 다음 사례에서 인과를 말할 수 있다.</a:t>
+            </a:r>
+          </a:p>
+          <a:p>
+            <a:r>
+              <a:t>근거: demo/vibe_vs_spec/README.md</a:t>
+            </a:r>
+          </a:p>
+          <a:p>
+            <a:r>
+              <a:t>증거 범위: 적용</a:t>
+            </a:r>
+          </a:p>
+        </p:txBody>
+      </p:sp>
+      <p:sp>
+        <p:nvSpPr>
+          <p:cNvPr id="4" name="Slide Number Placeholder 3"/>
+          <p:cNvSpPr>
+            <a:spLocks noGrp="1"/>
+          </p:cNvSpPr>
+          <p:nvPr>
+            <p:ph type="sldNum" idx="5" sz="quarter"/>
+          </p:nvPr>
+        </p:nvSpPr>
+        <p:spPr/>
+      </p:sp>
+    </p:spTree>
+  </p:cSld>
+  <p:clrMapOvr>
+    <a:masterClrMapping/>
+  </p:clrMapOvr>
+</p:notes>
+</file>
+
+<file path=ppt/notesSlides/notesSlide14.xml><?xml version="1.0" encoding="utf-8"?>
+<p:notes xmlns:a="http://schemas.openxmlformats.org/drawingml/2006/main" xmlns:p="http://schemas.openxmlformats.org/presentationml/2006/main" xmlns:r="http://schemas.openxmlformats.org/officeDocument/2006/relationships">
+  <p:cSld>
+    <p:spTree>
+      <p:nvGrpSpPr>
+        <p:cNvPr id="1" name=""/>
+        <p:cNvGrpSpPr/>
+        <p:nvPr/>
+      </p:nvGrpSpPr>
+      <p:grpSpPr>
+        <a:xfrm>
+          <a:off x="0" y="0"/>
+          <a:ext cx="0" cy="0"/>
+          <a:chOff x="0" y="0"/>
+          <a:chExt cx="0" cy="0"/>
+        </a:xfrm>
+      </p:grpSpPr>
+      <p:sp>
+        <p:nvSpPr>
+          <p:cNvPr id="2" name="Slide Image Placeholder 1"/>
+          <p:cNvSpPr>
+            <a:spLocks noGrp="1"/>
+          </p:cNvSpPr>
+          <p:nvPr>
+            <p:ph type="sldImg" idx="2"/>
+          </p:nvPr>
+        </p:nvSpPr>
+        <p:spPr/>
+      </p:sp>
+      <p:sp>
+        <p:nvSpPr>
+          <p:cNvPr id="3" name="Notes Placeholder 2"/>
+          <p:cNvSpPr>
+            <a:spLocks noGrp="1"/>
+          </p:cNvSpPr>
+          <p:nvPr>
+            <p:ph type="body" idx="3" sz="quarter"/>
+          </p:nvPr>
+        </p:nvSpPr>
+        <p:spPr/>
+        <p:txBody>
+          <a:bodyPr/>
+          <a:lstStyle/>
+          <a:p>
+            <a:r>
+              <a:t>터미널에서 같은 검사를 다시 돌릴 수 있다.</a:t>
+            </a:r>
+          </a:p>
+          <a:p>
+            <a:r>
+              <a:t>비교 이미지를 다시 만들려면 슬라이드에 적힌 생성 스크립트를 쓴다.</a:t>
+            </a:r>
+          </a:p>
+          <a:p>
+            <a:r>
+              <a:t>숫자를 손으로 고치면 검증이 실패한다.</a:t>
+            </a:r>
+          </a:p>
+          <a:p>
+            <a:r>
+              <a:t>근거: demo/vibe_vs_spec/</a:t>
+            </a:r>
+          </a:p>
+          <a:p>
+            <a:r>
+              <a:t>증거 범위: 재현</a:t>
+            </a:r>
+          </a:p>
+        </p:txBody>
+      </p:sp>
+      <p:sp>
+        <p:nvSpPr>
+          <p:cNvPr id="4" name="Slide Number Placeholder 3"/>
+          <p:cNvSpPr>
+            <a:spLocks noGrp="1"/>
+          </p:cNvSpPr>
+          <p:nvPr>
+            <p:ph type="sldNum" idx="5" sz="quarter"/>
+          </p:nvPr>
+        </p:nvSpPr>
+        <p:spPr/>
+      </p:sp>
+    </p:spTree>
+  </p:cSld>
+  <p:clrMapOvr>
+    <a:masterClrMapping/>
+  </p:clrMapOvr>
+</p:notes>
+</file>
+
+<file path=ppt/notesSlides/notesSlide15.xml><?xml version="1.0" encoding="utf-8"?>
+<p:notes xmlns:a="http://schemas.openxmlformats.org/drawingml/2006/main" xmlns:p="http://schemas.openxmlformats.org/presentationml/2006/main" xmlns:r="http://schemas.openxmlformats.org/officeDocument/2006/relationships">
+  <p:cSld>
+    <p:spTree>
+      <p:nvGrpSpPr>
+        <p:cNvPr id="1" name=""/>
+        <p:cNvGrpSpPr/>
+        <p:nvPr/>
+      </p:nvGrpSpPr>
+      <p:grpSpPr>
+        <a:xfrm>
+          <a:off x="0" y="0"/>
+          <a:ext cx="0" cy="0"/>
+          <a:chOff x="0" y="0"/>
+          <a:chExt cx="0" cy="0"/>
+        </a:xfrm>
+      </p:grpSpPr>
+      <p:sp>
+        <p:nvSpPr>
+          <p:cNvPr id="2" name="Slide Image Placeholder 1"/>
+          <p:cNvSpPr>
+            <a:spLocks noGrp="1"/>
+          </p:cNvSpPr>
+          <p:nvPr>
+            <p:ph type="sldImg" idx="2"/>
+          </p:nvPr>
+        </p:nvSpPr>
+        <p:spPr/>
+      </p:sp>
+      <p:sp>
+        <p:nvSpPr>
+          <p:cNvPr id="3" name="Notes Placeholder 2"/>
+          <p:cNvSpPr>
+            <a:spLocks noGrp="1"/>
+          </p:cNvSpPr>
+          <p:nvPr>
+            <p:ph type="body" idx="3" sz="quarter"/>
+          </p:nvPr>
+        </p:nvSpPr>
+        <p:spPr/>
+        <p:txBody>
+          <a:bodyPr/>
+          <a:lstStyle/>
+          <a:p>
+            <a:r>
               <a:t>이 사례에서 확실한 것은 토큰 구조가 '싼 입력↑, 비싼 출력↓'로 이동했다는 점이다.</a:t>
             </a:r>
           </a:p>
@@ -1359,7 +1561,7 @@
           <a:lstStyle/>
           <a:p>
             <a:r>
-              <a:t>벤더 usage 필드 이름과 동일하다고 가정하면 이중 계상할 수 있다.</a:t>
+              <a:t>세션 추정치이며 실제 청구 usage가 아니다. 표본 1쌍이다.</a:t>
             </a:r>
           </a:p>
           <a:p>
@@ -1369,27 +1571,7 @@
           </a:p>
           <a:p>
             <a:r>
-              <a:t>표의 값은 모두 추정치이며 실제 청구서가 아니다.</a:t>
-            </a:r>
-          </a:p>
-          <a:p>
-            <a:r>
-              <a:t>비캐시 입력: 486 → 1,152  (증가 666)</a:t>
-            </a:r>
-          </a:p>
-          <a:p>
-            <a:r>
-              <a:t>추론+보이는 출력: 7,070 → 6,390  (감소 680)</a:t>
-            </a:r>
-          </a:p>
-          <a:p>
-            <a:r>
-              <a:t>캐시 입력(추정): 312 → 468  (증가 156)</a:t>
-            </a:r>
-          </a:p>
-          <a:p>
-            <a:r>
-              <a:t>합계: 7,868 → 8,010  (증가 1.8%)</a:t>
+              <a:t>표의 버킷 정의(비캐시 입력·출력·캐시)는 벤더 usage 필드와 이름이 같다고 가정하면 이중 계상할 수 있다.</a:t>
             </a:r>
           </a:p>
           <a:p>
@@ -1469,42 +1651,47 @@
           <a:lstStyle/>
           <a:p>
             <a:r>
-              <a:t>단가가 바뀌어도 결론의 방향이 유지되는지 확인하려는 계산이다.</a:t>
-            </a:r>
-          </a:p>
-          <a:p>
-            <a:r>
-              <a:t>캐시를 전부 신규 입력으로 환산한 8.1%가 가장 보수적인 값이다.</a:t>
-            </a:r>
-          </a:p>
-          <a:p>
-            <a:r>
-              <a:t>세 값 모두 추정 usage의 산술이고 캐시 적격성은 확인하지 않았다.</a:t>
-            </a:r>
-          </a:p>
-          <a:p>
-            <a:r>
-              <a:t>GPT-5 · 캐시 $0.125/M: $0.0713465 → $0.0653985  (8.3% 감소)</a:t>
-            </a:r>
-          </a:p>
-          <a:p>
-            <a:r>
-              <a:t>Claude Sonnet 4.6 · 캐시 0.1×: $0.1076016 → $0.0994464  (7.6% 감소)</a:t>
-            </a:r>
-          </a:p>
-          <a:p>
-            <a:r>
-              <a:t>GPT-5 · 캐시 전부 미적용: $0.0716975 → $0.0659250  (8.1% 감소)</a:t>
-            </a:r>
-          </a:p>
-          <a:p>
-            <a:r>
-              <a:t>근거: presentation/case_vibe_vs_spec/cost_comparison.md</a:t>
-            </a:r>
-          </a:p>
-          <a:p>
-            <a:r>
-              <a:t>증거 범위: 단가별 비용 재계산</a:t>
+              <a:t>벤더 usage 필드 이름과 동일하다고 가정하면 이중 계상할 수 있다.</a:t>
+            </a:r>
+          </a:p>
+          <a:p>
+            <a:r>
+              <a:t>추론 토큰은 출력 요율로 과금된다는 가정을 쓴다.</a:t>
+            </a:r>
+          </a:p>
+          <a:p>
+            <a:r>
+              <a:t>표의 값은 모두 추정치이며 실제 청구서가 아니다.</a:t>
+            </a:r>
+          </a:p>
+          <a:p>
+            <a:r>
+              <a:t>비캐시 입력: 486 → 1,152  (증가 666)</a:t>
+            </a:r>
+          </a:p>
+          <a:p>
+            <a:r>
+              <a:t>추론+보이는 출력: 7,070 → 6,390  (감소 680)</a:t>
+            </a:r>
+          </a:p>
+          <a:p>
+            <a:r>
+              <a:t>캐시 입력(추정): 312 → 468  (증가 156)</a:t>
+            </a:r>
+          </a:p>
+          <a:p>
+            <a:r>
+              <a:t>합계: 7,868 → 8,010  (증가 1.8%)</a:t>
+            </a:r>
+          </a:p>
+          <a:p>
+            <a:r>
+              <a:t>근거: demo/vibe_vs_spec/usage.json</a:t>
+            </a:r>
+          </a:p>
+          <a:p>
+            <a:r>
+              <a:t>증거 범위: 추정치 재계산</a:t>
             </a:r>
           </a:p>
         </p:txBody>
@@ -1574,47 +1761,42 @@
           <a:lstStyle/>
           <a:p>
             <a:r>
-              <a:t>모든 가격 체계에서 항상 이긴다는 뜻이 아니라, 이 토큰 이동에서의 조건이다.</a:t>
-            </a:r>
-          </a:p>
-          <a:p>
-            <a:r>
-              <a:t>DeepSeek처럼 캐시 할인이 더 깊은 모델은 손익분기가 달라진다.</a:t>
-            </a:r>
-          </a:p>
-          <a:p>
-            <a:r>
-              <a:t>실제 청구서 대조는 하지 않았다.</a:t>
-            </a:r>
-          </a:p>
-          <a:p>
-            <a:r>
-              <a:t>손익분기 조건: r &gt; (666 + 156h) / 680</a:t>
-            </a:r>
-          </a:p>
-          <a:p>
-            <a:r>
-              <a:t>h = 0.1이면: r = 1.0024</a:t>
-            </a:r>
-          </a:p>
-          <a:p>
-            <a:r>
-              <a:t>r → ∞ 수렴: 약 9.62% 감소에 수렴</a:t>
-            </a:r>
-          </a:p>
-          <a:p>
-            <a:r>
-              <a:t>실제 청구서: 미확인 (usage 추정치 산술)</a:t>
-            </a:r>
-          </a:p>
-          <a:p>
-            <a:r>
-              <a:t>근거: demo/vibe_vs_spec/sensitivity.py</a:t>
-            </a:r>
-          </a:p>
-          <a:p>
-            <a:r>
-              <a:t>증거 범위: 단가 민감도</a:t>
+              <a:t>단가가 바뀌어도 결론의 방향이 유지되는지 확인하려는 계산이다.</a:t>
+            </a:r>
+          </a:p>
+          <a:p>
+            <a:r>
+              <a:t>캐시를 전부 신규 입력으로 환산한 8.1%가 가장 보수적인 값이다.</a:t>
+            </a:r>
+          </a:p>
+          <a:p>
+            <a:r>
+              <a:t>세 값 모두 추정 usage의 산술이고 캐시 적격성은 확인하지 않았다.</a:t>
+            </a:r>
+          </a:p>
+          <a:p>
+            <a:r>
+              <a:t>GPT-5 · 캐시 $0.125/M: $0.0713465 → $0.0653985  (8.3% 감소)</a:t>
+            </a:r>
+          </a:p>
+          <a:p>
+            <a:r>
+              <a:t>Claude Sonnet 4.6 · 캐시 0.1×: $0.1076016 → $0.0994464  (7.6% 감소)</a:t>
+            </a:r>
+          </a:p>
+          <a:p>
+            <a:r>
+              <a:t>GPT-5 · 캐시 전부 미적용: $0.0716975 → $0.0659250  (8.1% 감소)</a:t>
+            </a:r>
+          </a:p>
+          <a:p>
+            <a:r>
+              <a:t>근거: presentation/case_vibe_vs_spec/cost_comparison.md</a:t>
+            </a:r>
+          </a:p>
+          <a:p>
+            <a:r>
+              <a:t>증거 범위: 단가별 비용 재계산</a:t>
             </a:r>
           </a:p>
         </p:txBody>
@@ -1684,27 +1866,27 @@
           <a:lstStyle/>
           <a:p>
             <a:r>
-              <a:t>검사 항목은 산출물의 요구사항(수용 기준)에 맞춰 정의했다.</a:t>
-            </a:r>
-          </a:p>
-          <a:p>
-            <a:r>
-              <a:t>검사를 통과했다는 것이 두 생성 과정의 품질 동등성을 뜻하지는 않는다.</a:t>
-            </a:r>
-          </a:p>
-          <a:p>
-            <a:r>
-              <a:t>검사 항목 수는 실행 로그에서 확인한다.</a:t>
-            </a:r>
-          </a:p>
-          <a:p>
-            <a:r>
-              <a:t>근거: demo/vibe_vs_spec/verify_ac.py</a:t>
-            </a:r>
-          </a:p>
-          <a:p>
-            <a:r>
-              <a:t>증거 범위: 실동작 검사 (Chromium)</a:t>
+              <a:t>다른 모델을 실행한 실측이 아니라 같은 추정 토큰의 산술이다.</a:t>
+            </a:r>
+          </a:p>
+          <a:p>
+            <a:r>
+              <a:t>캐시 적격성은 확인하지 않았고, 캐시 미적용 환산이 가장 보수적인 8.1%다.</a:t>
+            </a:r>
+          </a:p>
+          <a:p>
+            <a:r>
+              <a:t>실제 청구서 대조는 하지 않았다.</a:t>
+            </a:r>
+          </a:p>
+          <a:p>
+            <a:r>
+              <a:t>근거: presentation/case_vibe_vs_spec/cost_comparison.md</a:t>
+            </a:r>
+          </a:p>
+          <a:p>
+            <a:r>
+              <a:t>증거 범위: 단가별 비용 재계산</a:t>
             </a:r>
           </a:p>
         </p:txBody>
@@ -5221,7 +5403,7 @@
                 <a:ea typeface="NanumGothic"/>
                 <a:cs typeface="NanumGothic"/>
               </a:rPr>
-              <a:t>스펙 템플릿</a:t>
+              <a:t>단가 민감도</a:t>
             </a:r>
           </a:p>
         </p:txBody>
@@ -5257,7 +5439,7 @@
                 <a:ea typeface="NanumGothic"/>
                 <a:cs typeface="NanumGothic"/>
               </a:rPr>
-              <a:t>그 네 칸에 무엇을 적는가</a:t>
+              <a:t>단가비가 손익을 결정한다</a:t>
             </a:r>
           </a:p>
         </p:txBody>
@@ -5271,7 +5453,7 @@
         <p:spPr>
           <a:xfrm>
             <a:off x="640080" y="1783080"/>
-            <a:ext cx="10881360" cy="777240"/>
+            <a:ext cx="6583680" cy="777240"/>
           </a:xfrm>
           <a:prstGeom prst="rect">
             <a:avLst/>
@@ -5293,7 +5475,7 @@
                 <a:ea typeface="NanumGothic"/>
                 <a:cs typeface="NanumGothic"/>
               </a:rPr>
-              <a:t>한 줄이면 충분한 결정 네 개</a:t>
+              <a:t>r &gt; (666 + 156h) / 680</a:t>
             </a:r>
           </a:p>
         </p:txBody>
@@ -5307,7 +5489,7 @@
         <p:spPr>
           <a:xfrm>
             <a:off x="777240" y="2862072"/>
-            <a:ext cx="10652760" cy="612648"/>
+            <a:ext cx="6400800" cy="612648"/>
           </a:xfrm>
           <a:prstGeom prst="rect">
             <a:avLst/>
@@ -5329,7 +5511,7 @@
                 <a:ea typeface="NanumGothic"/>
                 <a:cs typeface="NanumGothic"/>
               </a:rPr>
-              <a:t>페이지 — 섹션과 순서를 고정한다 (이번엔 히어로·메뉴·지도·리뷰·CTA)</a:t>
+              <a:t>r = 출력/입력 단가, h = 캐시 읽기/입력 단가</a:t>
             </a:r>
           </a:p>
         </p:txBody>
@@ -5343,7 +5525,7 @@
         <p:spPr>
           <a:xfrm>
             <a:off x="777240" y="3502152"/>
-            <a:ext cx="10652760" cy="612648"/>
+            <a:ext cx="6400800" cy="612648"/>
           </a:xfrm>
           <a:prstGeom prst="rect">
             <a:avLst/>
@@ -5365,86 +5547,240 @@
                 <a:ea typeface="NanumGothic"/>
                 <a:cs typeface="NanumGothic"/>
               </a:rPr>
-              <a:t>스택 — 생성 방식과 파일 구성을 정한다 (단일 HTML + CSS, JS 없음)</a:t>
-            </a:r>
-          </a:p>
-        </p:txBody>
-      </p:sp>
-      <p:sp>
-        <p:nvSpPr>
-          <p:cNvPr id="9" name="audit:body-2"/>
-          <p:cNvSpPr txBox="1"/>
-          <p:nvPr/>
-        </p:nvSpPr>
-        <p:spPr>
-          <a:xfrm>
-            <a:off x="777240" y="4142231"/>
-            <a:ext cx="10652760" cy="612648"/>
-          </a:xfrm>
-          <a:prstGeom prst="rect">
-            <a:avLst/>
-          </a:prstGeom>
-          <a:noFill/>
-        </p:spPr>
-        <p:txBody>
-          <a:bodyPr wrap="square" lIns="0" rIns="0" tIns="0" bIns="0">
-            <a:spAutoFit/>
-          </a:bodyPr>
-          <a:lstStyle/>
-          <a:p>
-            <a:r>
-              <a:rPr sz="1750" b="0">
-                <a:solidFill>
-                  <a:srgbClr val="ECF1F6"/>
-                </a:solidFill>
-                <a:latin typeface="NanumGothic"/>
-                <a:ea typeface="NanumGothic"/>
-                <a:cs typeface="NanumGothic"/>
-              </a:rPr>
-              <a:t>디자인 — 톤·색·타이포 기준을 한 줄로 (따뜻한 크림 톤, 사진 대신 일러스트)</a:t>
-            </a:r>
-          </a:p>
-        </p:txBody>
-      </p:sp>
-      <p:sp>
-        <p:nvSpPr>
-          <p:cNvPr id="10" name="audit:body-3"/>
-          <p:cNvSpPr txBox="1"/>
-          <p:nvPr/>
-        </p:nvSpPr>
-        <p:spPr>
-          <a:xfrm>
-            <a:off x="777240" y="4782312"/>
-            <a:ext cx="10652760" cy="612648"/>
-          </a:xfrm>
-          <a:prstGeom prst="rect">
-            <a:avLst/>
-          </a:prstGeom>
-          <a:noFill/>
-        </p:spPr>
-        <p:txBody>
-          <a:bodyPr wrap="square" lIns="0" rIns="0" tIns="0" bIns="0">
-            <a:spAutoFit/>
-          </a:bodyPr>
-          <a:lstStyle/>
-          <a:p>
-            <a:r>
-              <a:rPr sz="1750" b="0">
-                <a:solidFill>
-                  <a:srgbClr val="ECF1F6"/>
-                </a:solidFill>
-                <a:latin typeface="NanumGothic"/>
-                <a:ea typeface="NanumGothic"/>
-                <a:cs typeface="NanumGothic"/>
-              </a:rPr>
-              <a:t>수용 기준 — 검사 가능한 문장으로 (390px에서 1열, 앵커 이동, JS 오류 0)</a:t>
-            </a:r>
-          </a:p>
-        </p:txBody>
-      </p:sp>
-      <p:sp>
-        <p:nvSpPr>
-          <p:cNvPr id="11" name="audit:source"/>
+              <a:t>출력 단가가 조금만 높아도 스펙 쪽이 유리해진다</a:t>
+            </a:r>
+          </a:p>
+        </p:txBody>
+      </p:sp>
+      <p:graphicFrame>
+        <p:nvGraphicFramePr>
+          <p:cNvPr id="9" name="Table 8"/>
+          <p:cNvGraphicFramePr>
+            <a:graphicFrameLocks noGrp="1"/>
+          </p:cNvGraphicFramePr>
+          <p:nvPr/>
+        </p:nvGraphicFramePr>
+        <p:xfrm>
+          <a:off x="777240" y="4233671"/>
+          <a:ext cx="10652760" cy="1682496"/>
+        </p:xfrm>
+        <a:graphic>
+          <a:graphicData uri="http://schemas.openxmlformats.org/drawingml/2006/table">
+            <a:tbl>
+              <a:tblPr>
+                <a:tableStyleId>{5C22544A-7EE6-4342-B048-85BDC9FD1C3A}</a:tableStyleId>
+              </a:tblPr>
+              <a:tblGrid>
+                <a:gridCol w="3931920"/>
+                <a:gridCol w="6720840"/>
+              </a:tblGrid>
+              <a:tr h="420624">
+                <a:tc>
+                  <a:txBody>
+                    <a:bodyPr wrap="square"/>
+                    <a:lstStyle/>
+                    <a:p>
+                      <a:r>
+                        <a:rPr sz="1250" b="0">
+                          <a:solidFill>
+                            <a:srgbClr val="93A4B5"/>
+                          </a:solidFill>
+                          <a:latin typeface="NanumGothic"/>
+                          <a:ea typeface="NanumGothic"/>
+                          <a:cs typeface="NanumGothic"/>
+                        </a:rPr>
+                        <a:t>손익분기 조건</a:t>
+                      </a:r>
+                    </a:p>
+                  </a:txBody>
+                  <a:tcPr marL="91440" marR="91440">
+                    <a:solidFill>
+                      <a:srgbClr val="111A24"/>
+                    </a:solidFill>
+                  </a:tcPr>
+                </a:tc>
+                <a:tc>
+                  <a:txBody>
+                    <a:bodyPr wrap="square"/>
+                    <a:lstStyle/>
+                    <a:p>
+                      <a:r>
+                        <a:rPr sz="1400" b="1">
+                          <a:solidFill>
+                            <a:srgbClr val="ECF1F6"/>
+                          </a:solidFill>
+                          <a:latin typeface="NanumGothic"/>
+                          <a:ea typeface="NanumGothic"/>
+                          <a:cs typeface="NanumGothic"/>
+                        </a:rPr>
+                        <a:t>r &gt; (666 + 156h) / 680</a:t>
+                      </a:r>
+                    </a:p>
+                  </a:txBody>
+                  <a:tcPr marL="91440" marR="91440">
+                    <a:solidFill>
+                      <a:srgbClr val="111A24"/>
+                    </a:solidFill>
+                  </a:tcPr>
+                </a:tc>
+              </a:tr>
+              <a:tr h="420624">
+                <a:tc>
+                  <a:txBody>
+                    <a:bodyPr wrap="square"/>
+                    <a:lstStyle/>
+                    <a:p>
+                      <a:r>
+                        <a:rPr sz="1250" b="0">
+                          <a:solidFill>
+                            <a:srgbClr val="93A4B5"/>
+                          </a:solidFill>
+                          <a:latin typeface="NanumGothic"/>
+                          <a:ea typeface="NanumGothic"/>
+                          <a:cs typeface="NanumGothic"/>
+                        </a:rPr>
+                        <a:t>h = 0.1이면</a:t>
+                      </a:r>
+                    </a:p>
+                  </a:txBody>
+                  <a:tcPr marL="91440" marR="91440">
+                    <a:solidFill>
+                      <a:srgbClr val="18222E"/>
+                    </a:solidFill>
+                  </a:tcPr>
+                </a:tc>
+                <a:tc>
+                  <a:txBody>
+                    <a:bodyPr wrap="square"/>
+                    <a:lstStyle/>
+                    <a:p>
+                      <a:r>
+                        <a:rPr sz="1400" b="1">
+                          <a:solidFill>
+                            <a:srgbClr val="ECF1F6"/>
+                          </a:solidFill>
+                          <a:latin typeface="NanumGothic"/>
+                          <a:ea typeface="NanumGothic"/>
+                          <a:cs typeface="NanumGothic"/>
+                        </a:rPr>
+                        <a:t>r = 1.0024</a:t>
+                      </a:r>
+                    </a:p>
+                  </a:txBody>
+                  <a:tcPr marL="91440" marR="91440">
+                    <a:solidFill>
+                      <a:srgbClr val="18222E"/>
+                    </a:solidFill>
+                  </a:tcPr>
+                </a:tc>
+              </a:tr>
+              <a:tr h="420624">
+                <a:tc>
+                  <a:txBody>
+                    <a:bodyPr wrap="square"/>
+                    <a:lstStyle/>
+                    <a:p>
+                      <a:r>
+                        <a:rPr sz="1250" b="0">
+                          <a:solidFill>
+                            <a:srgbClr val="93A4B5"/>
+                          </a:solidFill>
+                          <a:latin typeface="NanumGothic"/>
+                          <a:ea typeface="NanumGothic"/>
+                          <a:cs typeface="NanumGothic"/>
+                        </a:rPr>
+                        <a:t>r → ∞ 수렴</a:t>
+                      </a:r>
+                    </a:p>
+                  </a:txBody>
+                  <a:tcPr marL="91440" marR="91440">
+                    <a:solidFill>
+                      <a:srgbClr val="111A24"/>
+                    </a:solidFill>
+                  </a:tcPr>
+                </a:tc>
+                <a:tc>
+                  <a:txBody>
+                    <a:bodyPr wrap="square"/>
+                    <a:lstStyle/>
+                    <a:p>
+                      <a:r>
+                        <a:rPr sz="1400" b="1">
+                          <a:solidFill>
+                            <a:srgbClr val="ECF1F6"/>
+                          </a:solidFill>
+                          <a:latin typeface="NanumGothic"/>
+                          <a:ea typeface="NanumGothic"/>
+                          <a:cs typeface="NanumGothic"/>
+                        </a:rPr>
+                        <a:t>약 9.62% 감소에 수렴</a:t>
+                      </a:r>
+                    </a:p>
+                  </a:txBody>
+                  <a:tcPr marL="91440" marR="91440">
+                    <a:solidFill>
+                      <a:srgbClr val="111A24"/>
+                    </a:solidFill>
+                  </a:tcPr>
+                </a:tc>
+              </a:tr>
+              <a:tr h="420624">
+                <a:tc>
+                  <a:txBody>
+                    <a:bodyPr wrap="square"/>
+                    <a:lstStyle/>
+                    <a:p>
+                      <a:r>
+                        <a:rPr sz="1250" b="0">
+                          <a:solidFill>
+                            <a:srgbClr val="93A4B5"/>
+                          </a:solidFill>
+                          <a:latin typeface="NanumGothic"/>
+                          <a:ea typeface="NanumGothic"/>
+                          <a:cs typeface="NanumGothic"/>
+                        </a:rPr>
+                        <a:t>실제 청구서</a:t>
+                      </a:r>
+                    </a:p>
+                  </a:txBody>
+                  <a:tcPr marL="91440" marR="91440">
+                    <a:solidFill>
+                      <a:srgbClr val="18222E"/>
+                    </a:solidFill>
+                  </a:tcPr>
+                </a:tc>
+                <a:tc>
+                  <a:txBody>
+                    <a:bodyPr wrap="square"/>
+                    <a:lstStyle/>
+                    <a:p>
+                      <a:r>
+                        <a:rPr sz="1400" b="1">
+                          <a:solidFill>
+                            <a:srgbClr val="ECF1F6"/>
+                          </a:solidFill>
+                          <a:latin typeface="NanumGothic"/>
+                          <a:ea typeface="NanumGothic"/>
+                          <a:cs typeface="NanumGothic"/>
+                        </a:rPr>
+                        <a:t>미확인 (usage 추정치 산술)</a:t>
+                      </a:r>
+                    </a:p>
+                  </a:txBody>
+                  <a:tcPr marL="91440" marR="91440">
+                    <a:solidFill>
+                      <a:srgbClr val="18222E"/>
+                    </a:solidFill>
+                  </a:tcPr>
+                </a:tc>
+              </a:tr>
+            </a:tbl>
+          </a:graphicData>
+        </a:graphic>
+      </p:graphicFrame>
+      <p:sp>
+        <p:nvSpPr>
+          <p:cNvPr id="10" name="audit:source"/>
           <p:cNvSpPr txBox="1"/>
           <p:nvPr/>
         </p:nvSpPr>
@@ -5473,14 +5809,14 @@
                 <a:ea typeface="NanumGothic"/>
                 <a:cs typeface="NanumGothic"/>
               </a:rPr>
-              <a:t>demo/vibe_vs_spec/EXPERIMENT_A_PROTOCOL.md</a:t>
-            </a:r>
-          </a:p>
-        </p:txBody>
-      </p:sp>
-      <p:sp>
-        <p:nvSpPr>
-          <p:cNvPr id="12" name="audit:footer"/>
+              <a:t>demo/vibe_vs_spec/sensitivity.py</a:t>
+            </a:r>
+          </a:p>
+        </p:txBody>
+      </p:sp>
+      <p:sp>
+        <p:nvSpPr>
+          <p:cNvPr id="11" name="audit:footer"/>
           <p:cNvSpPr txBox="1"/>
           <p:nvPr/>
         </p:nvSpPr>
@@ -5650,7 +5986,7 @@
                 <a:ea typeface="NanumGothic"/>
                 <a:cs typeface="NanumGothic"/>
               </a:rPr>
-              <a:t>적용</a:t>
+              <a:t>실동작 검사 (Chromium)</a:t>
             </a:r>
           </a:p>
         </p:txBody>
@@ -5686,7 +6022,7 @@
                 <a:ea typeface="NanumGothic"/>
                 <a:cs typeface="NanumGothic"/>
               </a:rPr>
-              <a:t>다음 프로젝트에서 할 일</a:t>
+              <a:t>무엇을 확인했나</a:t>
             </a:r>
           </a:p>
         </p:txBody>
@@ -5722,7 +6058,7 @@
                 <a:ea typeface="NanumGothic"/>
                 <a:cs typeface="NanumGothic"/>
               </a:rPr>
-              <a:t>결정 네 개를 먼저 적는다</a:t>
+              <a:t>정적 16 + 브라우저 29항목</a:t>
             </a:r>
           </a:p>
         </p:txBody>
@@ -5758,7 +6094,7 @@
                 <a:ea typeface="NanumGothic"/>
                 <a:cs typeface="NanumGothic"/>
               </a:rPr>
-              <a:t>페이지 · 스택 · 디자인 · 수용 기준</a:t>
+              <a:t>390 · 820 · 821 · 1280px 렌더링과 앵커 이동 검사</a:t>
             </a:r>
           </a:p>
         </p:txBody>
@@ -5794,50 +6130,14 @@
                 <a:ea typeface="NanumGothic"/>
                 <a:cs typeface="NanumGothic"/>
               </a:rPr>
-              <a:t>설명 대신 결정을 적고, 수용 기준을 코드로 옮긴다</a:t>
-            </a:r>
-          </a:p>
-        </p:txBody>
-      </p:sp>
-      <p:sp>
-        <p:nvSpPr>
-          <p:cNvPr id="9" name="audit:body-2"/>
-          <p:cNvSpPr txBox="1"/>
-          <p:nvPr/>
-        </p:nvSpPr>
-        <p:spPr>
-          <a:xfrm>
-            <a:off x="777240" y="4142231"/>
-            <a:ext cx="10652760" cy="612648"/>
-          </a:xfrm>
-          <a:prstGeom prst="rect">
-            <a:avLst/>
-          </a:prstGeom>
-          <a:noFill/>
-        </p:spPr>
-        <p:txBody>
-          <a:bodyPr wrap="square" lIns="0" rIns="0" tIns="0" bIns="0">
-            <a:spAutoFit/>
-          </a:bodyPr>
-          <a:lstStyle/>
-          <a:p>
-            <a:r>
-              <a:rPr sz="1750" b="0">
-                <a:solidFill>
-                  <a:srgbClr val="ECF1F6"/>
-                </a:solidFill>
-                <a:latin typeface="NanumGothic"/>
-                <a:ea typeface="NanumGothic"/>
-                <a:cs typeface="NanumGothic"/>
-              </a:rPr>
-              <a:t>완료 후 재작업 횟수와 총비용을 기록한다</a:t>
-            </a:r>
-          </a:p>
-        </p:txBody>
-      </p:sp>
-      <p:sp>
-        <p:nvSpPr>
-          <p:cNvPr id="10" name="audit:source"/>
+              <a:t>실패하는 변조를 넣어 검사가 실제로 잡는지도 확인</a:t>
+            </a:r>
+          </a:p>
+        </p:txBody>
+      </p:sp>
+      <p:sp>
+        <p:nvSpPr>
+          <p:cNvPr id="9" name="audit:source"/>
           <p:cNvSpPr txBox="1"/>
           <p:nvPr/>
         </p:nvSpPr>
@@ -5866,14 +6166,14 @@
                 <a:ea typeface="NanumGothic"/>
                 <a:cs typeface="NanumGothic"/>
               </a:rPr>
-              <a:t>demo/vibe_vs_spec/README.md</a:t>
-            </a:r>
-          </a:p>
-        </p:txBody>
-      </p:sp>
-      <p:sp>
-        <p:nvSpPr>
-          <p:cNvPr id="11" name="audit:footer"/>
+              <a:t>demo/vibe_vs_spec/verify_ac.py</a:t>
+            </a:r>
+          </a:p>
+        </p:txBody>
+      </p:sp>
+      <p:sp>
+        <p:nvSpPr>
+          <p:cNvPr id="10" name="audit:footer"/>
           <p:cNvSpPr txBox="1"/>
           <p:nvPr/>
         </p:nvSpPr>
@@ -6043,7 +6343,7 @@
                 <a:ea typeface="NanumGothic"/>
                 <a:cs typeface="NanumGothic"/>
               </a:rPr>
-              <a:t>재현</a:t>
+              <a:t>스펙 템플릿</a:t>
             </a:r>
           </a:p>
         </p:txBody>
@@ -6079,7 +6379,7 @@
                 <a:ea typeface="NanumGothic"/>
                 <a:cs typeface="NanumGothic"/>
               </a:rPr>
-              <a:t>재현</a:t>
+              <a:t>그 네 칸에 무엇을 적는가</a:t>
             </a:r>
           </a:p>
         </p:txBody>
@@ -6107,7 +6407,7 @@
           <a:lstStyle/>
           <a:p>
             <a:r>
-              <a:rPr sz="2400" b="1">
+              <a:rPr sz="2900" b="1">
                 <a:solidFill>
                   <a:srgbClr val="36D399"/>
                 </a:solidFill>
@@ -6115,7 +6415,7 @@
                 <a:ea typeface="NanumGothic"/>
                 <a:cs typeface="NanumGothic"/>
               </a:rPr>
-              <a:t>python demo/vibe_vs_spec/verify_ac.py</a:t>
+              <a:t>한 줄이면 충분한 결정 네 개</a:t>
             </a:r>
           </a:p>
         </p:txBody>
@@ -6151,7 +6451,7 @@
                 <a:ea typeface="NanumGothic"/>
                 <a:cs typeface="NanumGothic"/>
               </a:rPr>
-              <a:t>이미지 · usage 추정치 · 검사 스크립트가 저장소에 있다</a:t>
+              <a:t>페이지 — 섹션과 순서를 고정한다 (이번엔 히어로·메뉴·지도·리뷰·CTA)</a:t>
             </a:r>
           </a:p>
         </p:txBody>
@@ -6187,7 +6487,7 @@
                 <a:ea typeface="NanumGothic"/>
                 <a:cs typeface="NanumGothic"/>
               </a:rPr>
-              <a:t>브라우저가 없으면 UNVERIFIED로 종료한다</a:t>
+              <a:t>스택 — 생성 방식과 파일 구성을 정한다 (단일 HTML + CSS, JS 없음)</a:t>
             </a:r>
           </a:p>
         </p:txBody>
@@ -6223,14 +6523,50 @@
                 <a:ea typeface="NanumGothic"/>
                 <a:cs typeface="NanumGothic"/>
               </a:rPr>
-              <a:t>덱과 대본도 같은 원천에서 생성된다</a:t>
-            </a:r>
-          </a:p>
-        </p:txBody>
-      </p:sp>
-      <p:sp>
-        <p:nvSpPr>
-          <p:cNvPr id="10" name="audit:source"/>
+              <a:t>디자인 — 톤·색·타이포 기준을 한 줄로 (따뜻한 크림 톤, 사진 대신 일러스트)</a:t>
+            </a:r>
+          </a:p>
+        </p:txBody>
+      </p:sp>
+      <p:sp>
+        <p:nvSpPr>
+          <p:cNvPr id="10" name="audit:body-3"/>
+          <p:cNvSpPr txBox="1"/>
+          <p:nvPr/>
+        </p:nvSpPr>
+        <p:spPr>
+          <a:xfrm>
+            <a:off x="777240" y="4782312"/>
+            <a:ext cx="10652760" cy="612648"/>
+          </a:xfrm>
+          <a:prstGeom prst="rect">
+            <a:avLst/>
+          </a:prstGeom>
+          <a:noFill/>
+        </p:spPr>
+        <p:txBody>
+          <a:bodyPr wrap="square" lIns="0" rIns="0" tIns="0" bIns="0">
+            <a:spAutoFit/>
+          </a:bodyPr>
+          <a:lstStyle/>
+          <a:p>
+            <a:r>
+              <a:rPr sz="1750" b="0">
+                <a:solidFill>
+                  <a:srgbClr val="ECF1F6"/>
+                </a:solidFill>
+                <a:latin typeface="NanumGothic"/>
+                <a:ea typeface="NanumGothic"/>
+                <a:cs typeface="NanumGothic"/>
+              </a:rPr>
+              <a:t>수용 기준 — 검사 가능한 문장으로 (390px에서 1열, 앵커 이동, JS 오류 0)</a:t>
+            </a:r>
+          </a:p>
+        </p:txBody>
+      </p:sp>
+      <p:sp>
+        <p:nvSpPr>
+          <p:cNvPr id="11" name="audit:source"/>
           <p:cNvSpPr txBox="1"/>
           <p:nvPr/>
         </p:nvSpPr>
@@ -6259,14 +6595,14 @@
                 <a:ea typeface="NanumGothic"/>
                 <a:cs typeface="NanumGothic"/>
               </a:rPr>
-              <a:t>demo/vibe_vs_spec/</a:t>
-            </a:r>
-          </a:p>
-        </p:txBody>
-      </p:sp>
-      <p:sp>
-        <p:nvSpPr>
-          <p:cNvPr id="11" name="audit:footer"/>
+              <a:t>demo/vibe_vs_spec/EXPERIMENT_A_PROTOCOL.md</a:t>
+            </a:r>
+          </a:p>
+        </p:txBody>
+      </p:sp>
+      <p:sp>
+        <p:nvSpPr>
+          <p:cNvPr id="12" name="audit:footer"/>
           <p:cNvSpPr txBox="1"/>
           <p:nvPr/>
         </p:nvSpPr>
@@ -6436,6 +6772,792 @@
                 <a:ea typeface="NanumGothic"/>
                 <a:cs typeface="NanumGothic"/>
               </a:rPr>
+              <a:t>적용</a:t>
+            </a:r>
+          </a:p>
+        </p:txBody>
+      </p:sp>
+      <p:sp>
+        <p:nvSpPr>
+          <p:cNvPr id="5" name="audit:title"/>
+          <p:cNvSpPr txBox="1"/>
+          <p:nvPr/>
+        </p:nvSpPr>
+        <p:spPr>
+          <a:xfrm>
+            <a:off x="640080" y="822960"/>
+            <a:ext cx="10881360" cy="822960"/>
+          </a:xfrm>
+          <a:prstGeom prst="rect">
+            <a:avLst/>
+          </a:prstGeom>
+          <a:noFill/>
+        </p:spPr>
+        <p:txBody>
+          <a:bodyPr wrap="square" lIns="0" rIns="0" tIns="0" bIns="0">
+            <a:spAutoFit/>
+          </a:bodyPr>
+          <a:lstStyle/>
+          <a:p>
+            <a:r>
+              <a:rPr sz="2900" b="1">
+                <a:solidFill>
+                  <a:srgbClr val="ECF1F6"/>
+                </a:solidFill>
+                <a:latin typeface="NanumGothic"/>
+                <a:ea typeface="NanumGothic"/>
+                <a:cs typeface="NanumGothic"/>
+              </a:rPr>
+              <a:t>다음 프로젝트에서 할 일</a:t>
+            </a:r>
+          </a:p>
+        </p:txBody>
+      </p:sp>
+      <p:sp>
+        <p:nvSpPr>
+          <p:cNvPr id="6" name="audit:hero"/>
+          <p:cNvSpPr txBox="1"/>
+          <p:nvPr/>
+        </p:nvSpPr>
+        <p:spPr>
+          <a:xfrm>
+            <a:off x="640080" y="1783080"/>
+            <a:ext cx="10881360" cy="777240"/>
+          </a:xfrm>
+          <a:prstGeom prst="rect">
+            <a:avLst/>
+          </a:prstGeom>
+          <a:noFill/>
+        </p:spPr>
+        <p:txBody>
+          <a:bodyPr wrap="square" lIns="0" rIns="0" tIns="0" bIns="0">
+            <a:spAutoFit/>
+          </a:bodyPr>
+          <a:lstStyle/>
+          <a:p>
+            <a:r>
+              <a:rPr sz="2900" b="1">
+                <a:solidFill>
+                  <a:srgbClr val="36D399"/>
+                </a:solidFill>
+                <a:latin typeface="NanumGothic"/>
+                <a:ea typeface="NanumGothic"/>
+                <a:cs typeface="NanumGothic"/>
+              </a:rPr>
+              <a:t>결정 네 개를 먼저 적는다</a:t>
+            </a:r>
+          </a:p>
+        </p:txBody>
+      </p:sp>
+      <p:sp>
+        <p:nvSpPr>
+          <p:cNvPr id="7" name="audit:body-0"/>
+          <p:cNvSpPr txBox="1"/>
+          <p:nvPr/>
+        </p:nvSpPr>
+        <p:spPr>
+          <a:xfrm>
+            <a:off x="777240" y="2862072"/>
+            <a:ext cx="10652760" cy="612648"/>
+          </a:xfrm>
+          <a:prstGeom prst="rect">
+            <a:avLst/>
+          </a:prstGeom>
+          <a:noFill/>
+        </p:spPr>
+        <p:txBody>
+          <a:bodyPr wrap="square" lIns="0" rIns="0" tIns="0" bIns="0">
+            <a:spAutoFit/>
+          </a:bodyPr>
+          <a:lstStyle/>
+          <a:p>
+            <a:r>
+              <a:rPr sz="1750" b="0">
+                <a:solidFill>
+                  <a:srgbClr val="ECF1F6"/>
+                </a:solidFill>
+                <a:latin typeface="NanumGothic"/>
+                <a:ea typeface="NanumGothic"/>
+                <a:cs typeface="NanumGothic"/>
+              </a:rPr>
+              <a:t>페이지 · 스택 · 디자인 · 수용 기준</a:t>
+            </a:r>
+          </a:p>
+        </p:txBody>
+      </p:sp>
+      <p:sp>
+        <p:nvSpPr>
+          <p:cNvPr id="8" name="audit:body-1"/>
+          <p:cNvSpPr txBox="1"/>
+          <p:nvPr/>
+        </p:nvSpPr>
+        <p:spPr>
+          <a:xfrm>
+            <a:off x="777240" y="3502152"/>
+            <a:ext cx="10652760" cy="612648"/>
+          </a:xfrm>
+          <a:prstGeom prst="rect">
+            <a:avLst/>
+          </a:prstGeom>
+          <a:noFill/>
+        </p:spPr>
+        <p:txBody>
+          <a:bodyPr wrap="square" lIns="0" rIns="0" tIns="0" bIns="0">
+            <a:spAutoFit/>
+          </a:bodyPr>
+          <a:lstStyle/>
+          <a:p>
+            <a:r>
+              <a:rPr sz="1750" b="0">
+                <a:solidFill>
+                  <a:srgbClr val="ECF1F6"/>
+                </a:solidFill>
+                <a:latin typeface="NanumGothic"/>
+                <a:ea typeface="NanumGothic"/>
+                <a:cs typeface="NanumGothic"/>
+              </a:rPr>
+              <a:t>설명 대신 결정을 적고, 수용 기준을 코드로 옮긴다</a:t>
+            </a:r>
+          </a:p>
+        </p:txBody>
+      </p:sp>
+      <p:sp>
+        <p:nvSpPr>
+          <p:cNvPr id="9" name="audit:body-2"/>
+          <p:cNvSpPr txBox="1"/>
+          <p:nvPr/>
+        </p:nvSpPr>
+        <p:spPr>
+          <a:xfrm>
+            <a:off x="777240" y="4142231"/>
+            <a:ext cx="10652760" cy="612648"/>
+          </a:xfrm>
+          <a:prstGeom prst="rect">
+            <a:avLst/>
+          </a:prstGeom>
+          <a:noFill/>
+        </p:spPr>
+        <p:txBody>
+          <a:bodyPr wrap="square" lIns="0" rIns="0" tIns="0" bIns="0">
+            <a:spAutoFit/>
+          </a:bodyPr>
+          <a:lstStyle/>
+          <a:p>
+            <a:r>
+              <a:rPr sz="1750" b="0">
+                <a:solidFill>
+                  <a:srgbClr val="ECF1F6"/>
+                </a:solidFill>
+                <a:latin typeface="NanumGothic"/>
+                <a:ea typeface="NanumGothic"/>
+                <a:cs typeface="NanumGothic"/>
+              </a:rPr>
+              <a:t>완료 후 재작업 횟수와 총비용을 기록한다</a:t>
+            </a:r>
+          </a:p>
+        </p:txBody>
+      </p:sp>
+      <p:sp>
+        <p:nvSpPr>
+          <p:cNvPr id="10" name="audit:source"/>
+          <p:cNvSpPr txBox="1"/>
+          <p:nvPr/>
+        </p:nvSpPr>
+        <p:spPr>
+          <a:xfrm>
+            <a:off x="640080" y="6080760"/>
+            <a:ext cx="10972800" cy="274320"/>
+          </a:xfrm>
+          <a:prstGeom prst="rect">
+            <a:avLst/>
+          </a:prstGeom>
+          <a:noFill/>
+        </p:spPr>
+        <p:txBody>
+          <a:bodyPr wrap="square" lIns="0" rIns="0" tIns="0" bIns="0">
+            <a:spAutoFit/>
+          </a:bodyPr>
+          <a:lstStyle/>
+          <a:p>
+            <a:r>
+              <a:rPr sz="1000" b="0">
+                <a:solidFill>
+                  <a:srgbClr val="93A4B5"/>
+                </a:solidFill>
+                <a:latin typeface="NanumGothic"/>
+                <a:ea typeface="NanumGothic"/>
+                <a:cs typeface="NanumGothic"/>
+              </a:rPr>
+              <a:t>demo/vibe_vs_spec/README.md</a:t>
+            </a:r>
+          </a:p>
+        </p:txBody>
+      </p:sp>
+      <p:sp>
+        <p:nvSpPr>
+          <p:cNvPr id="11" name="audit:footer"/>
+          <p:cNvSpPr txBox="1"/>
+          <p:nvPr/>
+        </p:nvSpPr>
+        <p:spPr>
+          <a:xfrm>
+            <a:off x="640080" y="6419088"/>
+            <a:ext cx="10972800" cy="256032"/>
+          </a:xfrm>
+          <a:prstGeom prst="rect">
+            <a:avLst/>
+          </a:prstGeom>
+          <a:noFill/>
+        </p:spPr>
+        <p:txBody>
+          <a:bodyPr wrap="square" lIns="0" rIns="0" tIns="0" bIns="0">
+            <a:spAutoFit/>
+          </a:bodyPr>
+          <a:lstStyle/>
+          <a:p>
+            <a:r>
+              <a:rPr sz="1000" b="0">
+                <a:solidFill>
+                  <a:srgbClr val="93A4B5"/>
+                </a:solidFill>
+                <a:latin typeface="NanumGothic"/>
+                <a:ea typeface="NanumGothic"/>
+                <a:cs typeface="NanumGothic"/>
+              </a:rPr>
+              <a:t>2026-09-20  ·  근거와 조건을 함께 인용</a:t>
+            </a:r>
+          </a:p>
+        </p:txBody>
+      </p:sp>
+    </p:spTree>
+  </p:cSld>
+  <p:clrMapOvr>
+    <a:masterClrMapping/>
+  </p:clrMapOvr>
+</p:sld>
+</file>
+
+<file path=ppt/slides/slide14.xml><?xml version="1.0" encoding="utf-8"?>
+<p:sld xmlns:a="http://schemas.openxmlformats.org/drawingml/2006/main" xmlns:p="http://schemas.openxmlformats.org/presentationml/2006/main" xmlns:r="http://schemas.openxmlformats.org/officeDocument/2006/relationships">
+  <p:cSld>
+    <p:bg>
+      <p:bgPr>
+        <a:solidFill>
+          <a:srgbClr val="0E141B"/>
+        </a:solidFill>
+        <a:effectLst/>
+      </p:bgPr>
+    </p:bg>
+    <p:spTree>
+      <p:nvGrpSpPr>
+        <p:cNvPr id="1" name=""/>
+        <p:cNvGrpSpPr/>
+        <p:nvPr/>
+      </p:nvGrpSpPr>
+      <p:grpSpPr/>
+      <p:sp>
+        <p:nvSpPr>
+          <p:cNvPr id="2" name="Rectangle 1"/>
+          <p:cNvSpPr/>
+          <p:nvPr/>
+        </p:nvSpPr>
+        <p:spPr>
+          <a:xfrm>
+            <a:off x="0" y="0"/>
+            <a:ext cx="100584" cy="6858000"/>
+          </a:xfrm>
+          <a:prstGeom prst="rect">
+            <a:avLst/>
+          </a:prstGeom>
+          <a:solidFill>
+            <a:srgbClr val="36D399"/>
+          </a:solidFill>
+          <a:ln>
+            <a:noFill/>
+          </a:ln>
+        </p:spPr>
+        <p:style>
+          <a:lnRef idx="1">
+            <a:schemeClr val="accent1"/>
+          </a:lnRef>
+          <a:fillRef idx="3">
+            <a:schemeClr val="accent1"/>
+          </a:fillRef>
+          <a:effectRef idx="2">
+            <a:schemeClr val="accent1"/>
+          </a:effectRef>
+          <a:fontRef idx="minor">
+            <a:schemeClr val="lt1"/>
+          </a:fontRef>
+        </p:style>
+        <p:txBody>
+          <a:bodyPr rtlCol="0" anchor="ctr"/>
+          <a:lstStyle/>
+          <a:p>
+            <a:pPr algn="ctr"/>
+          </a:p>
+        </p:txBody>
+      </p:sp>
+      <p:sp>
+        <p:nvSpPr>
+          <p:cNvPr id="3" name="audit:index"/>
+          <p:cNvSpPr txBox="1"/>
+          <p:nvPr/>
+        </p:nvSpPr>
+        <p:spPr>
+          <a:xfrm>
+            <a:off x="640080" y="274320"/>
+            <a:ext cx="4572000" cy="274320"/>
+          </a:xfrm>
+          <a:prstGeom prst="rect">
+            <a:avLst/>
+          </a:prstGeom>
+          <a:noFill/>
+        </p:spPr>
+        <p:txBody>
+          <a:bodyPr wrap="square" lIns="0" rIns="0" tIns="0" bIns="0">
+            <a:spAutoFit/>
+          </a:bodyPr>
+          <a:lstStyle/>
+          <a:p>
+            <a:r>
+              <a:rPr sz="1100" b="0">
+                <a:solidFill>
+                  <a:srgbClr val="93A4B5"/>
+                </a:solidFill>
+                <a:latin typeface="NanumGothic"/>
+                <a:ea typeface="NanumGothic"/>
+                <a:cs typeface="NanumGothic"/>
+              </a:rPr>
+              <a:t>TOKEN COST LAB  /  14</a:t>
+            </a:r>
+          </a:p>
+        </p:txBody>
+      </p:sp>
+      <p:sp>
+        <p:nvSpPr>
+          <p:cNvPr id="4" name="audit:scope"/>
+          <p:cNvSpPr txBox="1"/>
+          <p:nvPr/>
+        </p:nvSpPr>
+        <p:spPr>
+          <a:xfrm>
+            <a:off x="5760720" y="274320"/>
+            <a:ext cx="5760720" cy="274320"/>
+          </a:xfrm>
+          <a:prstGeom prst="rect">
+            <a:avLst/>
+          </a:prstGeom>
+          <a:noFill/>
+        </p:spPr>
+        <p:txBody>
+          <a:bodyPr wrap="square" lIns="0" rIns="0" tIns="0" bIns="0">
+            <a:spAutoFit/>
+          </a:bodyPr>
+          <a:lstStyle/>
+          <a:p>
+            <a:r>
+              <a:rPr sz="1100" b="0">
+                <a:solidFill>
+                  <a:srgbClr val="36D399"/>
+                </a:solidFill>
+                <a:latin typeface="NanumGothic"/>
+                <a:ea typeface="NanumGothic"/>
+                <a:cs typeface="NanumGothic"/>
+              </a:rPr>
+              <a:t>재현</a:t>
+            </a:r>
+          </a:p>
+        </p:txBody>
+      </p:sp>
+      <p:sp>
+        <p:nvSpPr>
+          <p:cNvPr id="5" name="audit:title"/>
+          <p:cNvSpPr txBox="1"/>
+          <p:nvPr/>
+        </p:nvSpPr>
+        <p:spPr>
+          <a:xfrm>
+            <a:off x="640080" y="822960"/>
+            <a:ext cx="10881360" cy="822960"/>
+          </a:xfrm>
+          <a:prstGeom prst="rect">
+            <a:avLst/>
+          </a:prstGeom>
+          <a:noFill/>
+        </p:spPr>
+        <p:txBody>
+          <a:bodyPr wrap="square" lIns="0" rIns="0" tIns="0" bIns="0">
+            <a:spAutoFit/>
+          </a:bodyPr>
+          <a:lstStyle/>
+          <a:p>
+            <a:r>
+              <a:rPr sz="2900" b="1">
+                <a:solidFill>
+                  <a:srgbClr val="ECF1F6"/>
+                </a:solidFill>
+                <a:latin typeface="NanumGothic"/>
+                <a:ea typeface="NanumGothic"/>
+                <a:cs typeface="NanumGothic"/>
+              </a:rPr>
+              <a:t>재현</a:t>
+            </a:r>
+          </a:p>
+        </p:txBody>
+      </p:sp>
+      <p:sp>
+        <p:nvSpPr>
+          <p:cNvPr id="6" name="audit:hero"/>
+          <p:cNvSpPr txBox="1"/>
+          <p:nvPr/>
+        </p:nvSpPr>
+        <p:spPr>
+          <a:xfrm>
+            <a:off x="640080" y="1783080"/>
+            <a:ext cx="10881360" cy="777240"/>
+          </a:xfrm>
+          <a:prstGeom prst="rect">
+            <a:avLst/>
+          </a:prstGeom>
+          <a:noFill/>
+        </p:spPr>
+        <p:txBody>
+          <a:bodyPr wrap="square" lIns="0" rIns="0" tIns="0" bIns="0">
+            <a:spAutoFit/>
+          </a:bodyPr>
+          <a:lstStyle/>
+          <a:p>
+            <a:r>
+              <a:rPr sz="2400" b="1">
+                <a:solidFill>
+                  <a:srgbClr val="36D399"/>
+                </a:solidFill>
+                <a:latin typeface="NanumGothic"/>
+                <a:ea typeface="NanumGothic"/>
+                <a:cs typeface="NanumGothic"/>
+              </a:rPr>
+              <a:t>python demo/vibe_vs_spec/verify_ac.py</a:t>
+            </a:r>
+          </a:p>
+        </p:txBody>
+      </p:sp>
+      <p:sp>
+        <p:nvSpPr>
+          <p:cNvPr id="7" name="audit:body-0"/>
+          <p:cNvSpPr txBox="1"/>
+          <p:nvPr/>
+        </p:nvSpPr>
+        <p:spPr>
+          <a:xfrm>
+            <a:off x="777240" y="2862072"/>
+            <a:ext cx="10652760" cy="612648"/>
+          </a:xfrm>
+          <a:prstGeom prst="rect">
+            <a:avLst/>
+          </a:prstGeom>
+          <a:noFill/>
+        </p:spPr>
+        <p:txBody>
+          <a:bodyPr wrap="square" lIns="0" rIns="0" tIns="0" bIns="0">
+            <a:spAutoFit/>
+          </a:bodyPr>
+          <a:lstStyle/>
+          <a:p>
+            <a:r>
+              <a:rPr sz="1750" b="0">
+                <a:solidFill>
+                  <a:srgbClr val="ECF1F6"/>
+                </a:solidFill>
+                <a:latin typeface="NanumGothic"/>
+                <a:ea typeface="NanumGothic"/>
+                <a:cs typeface="NanumGothic"/>
+              </a:rPr>
+              <a:t>이미지 · usage 추정치 · 검사 스크립트가 저장소에 있다</a:t>
+            </a:r>
+          </a:p>
+        </p:txBody>
+      </p:sp>
+      <p:sp>
+        <p:nvSpPr>
+          <p:cNvPr id="8" name="audit:body-1"/>
+          <p:cNvSpPr txBox="1"/>
+          <p:nvPr/>
+        </p:nvSpPr>
+        <p:spPr>
+          <a:xfrm>
+            <a:off x="777240" y="3502152"/>
+            <a:ext cx="10652760" cy="612648"/>
+          </a:xfrm>
+          <a:prstGeom prst="rect">
+            <a:avLst/>
+          </a:prstGeom>
+          <a:noFill/>
+        </p:spPr>
+        <p:txBody>
+          <a:bodyPr wrap="square" lIns="0" rIns="0" tIns="0" bIns="0">
+            <a:spAutoFit/>
+          </a:bodyPr>
+          <a:lstStyle/>
+          <a:p>
+            <a:r>
+              <a:rPr sz="1750" b="0">
+                <a:solidFill>
+                  <a:srgbClr val="ECF1F6"/>
+                </a:solidFill>
+                <a:latin typeface="NanumGothic"/>
+                <a:ea typeface="NanumGothic"/>
+                <a:cs typeface="NanumGothic"/>
+              </a:rPr>
+              <a:t>브라우저가 없으면 UNVERIFIED로 종료한다</a:t>
+            </a:r>
+          </a:p>
+        </p:txBody>
+      </p:sp>
+      <p:sp>
+        <p:nvSpPr>
+          <p:cNvPr id="9" name="audit:body-2"/>
+          <p:cNvSpPr txBox="1"/>
+          <p:nvPr/>
+        </p:nvSpPr>
+        <p:spPr>
+          <a:xfrm>
+            <a:off x="777240" y="4142231"/>
+            <a:ext cx="10652760" cy="612648"/>
+          </a:xfrm>
+          <a:prstGeom prst="rect">
+            <a:avLst/>
+          </a:prstGeom>
+          <a:noFill/>
+        </p:spPr>
+        <p:txBody>
+          <a:bodyPr wrap="square" lIns="0" rIns="0" tIns="0" bIns="0">
+            <a:spAutoFit/>
+          </a:bodyPr>
+          <a:lstStyle/>
+          <a:p>
+            <a:r>
+              <a:rPr sz="1750" b="0">
+                <a:solidFill>
+                  <a:srgbClr val="ECF1F6"/>
+                </a:solidFill>
+                <a:latin typeface="NanumGothic"/>
+                <a:ea typeface="NanumGothic"/>
+                <a:cs typeface="NanumGothic"/>
+              </a:rPr>
+              <a:t>덱과 대본도 같은 원천에서 생성된다</a:t>
+            </a:r>
+          </a:p>
+        </p:txBody>
+      </p:sp>
+      <p:sp>
+        <p:nvSpPr>
+          <p:cNvPr id="10" name="audit:source"/>
+          <p:cNvSpPr txBox="1"/>
+          <p:nvPr/>
+        </p:nvSpPr>
+        <p:spPr>
+          <a:xfrm>
+            <a:off x="640080" y="6080760"/>
+            <a:ext cx="10972800" cy="274320"/>
+          </a:xfrm>
+          <a:prstGeom prst="rect">
+            <a:avLst/>
+          </a:prstGeom>
+          <a:noFill/>
+        </p:spPr>
+        <p:txBody>
+          <a:bodyPr wrap="square" lIns="0" rIns="0" tIns="0" bIns="0">
+            <a:spAutoFit/>
+          </a:bodyPr>
+          <a:lstStyle/>
+          <a:p>
+            <a:r>
+              <a:rPr sz="1000" b="0">
+                <a:solidFill>
+                  <a:srgbClr val="93A4B5"/>
+                </a:solidFill>
+                <a:latin typeface="NanumGothic"/>
+                <a:ea typeface="NanumGothic"/>
+                <a:cs typeface="NanumGothic"/>
+              </a:rPr>
+              <a:t>demo/vibe_vs_spec/</a:t>
+            </a:r>
+          </a:p>
+        </p:txBody>
+      </p:sp>
+      <p:sp>
+        <p:nvSpPr>
+          <p:cNvPr id="11" name="audit:footer"/>
+          <p:cNvSpPr txBox="1"/>
+          <p:nvPr/>
+        </p:nvSpPr>
+        <p:spPr>
+          <a:xfrm>
+            <a:off x="640080" y="6419088"/>
+            <a:ext cx="10972800" cy="256032"/>
+          </a:xfrm>
+          <a:prstGeom prst="rect">
+            <a:avLst/>
+          </a:prstGeom>
+          <a:noFill/>
+        </p:spPr>
+        <p:txBody>
+          <a:bodyPr wrap="square" lIns="0" rIns="0" tIns="0" bIns="0">
+            <a:spAutoFit/>
+          </a:bodyPr>
+          <a:lstStyle/>
+          <a:p>
+            <a:r>
+              <a:rPr sz="1000" b="0">
+                <a:solidFill>
+                  <a:srgbClr val="93A4B5"/>
+                </a:solidFill>
+                <a:latin typeface="NanumGothic"/>
+                <a:ea typeface="NanumGothic"/>
+                <a:cs typeface="NanumGothic"/>
+              </a:rPr>
+              <a:t>2026-09-20  ·  근거와 조건을 함께 인용</a:t>
+            </a:r>
+          </a:p>
+        </p:txBody>
+      </p:sp>
+    </p:spTree>
+  </p:cSld>
+  <p:clrMapOvr>
+    <a:masterClrMapping/>
+  </p:clrMapOvr>
+</p:sld>
+</file>
+
+<file path=ppt/slides/slide15.xml><?xml version="1.0" encoding="utf-8"?>
+<p:sld xmlns:a="http://schemas.openxmlformats.org/drawingml/2006/main" xmlns:p="http://schemas.openxmlformats.org/presentationml/2006/main" xmlns:r="http://schemas.openxmlformats.org/officeDocument/2006/relationships">
+  <p:cSld>
+    <p:bg>
+      <p:bgPr>
+        <a:solidFill>
+          <a:srgbClr val="0E141B"/>
+        </a:solidFill>
+        <a:effectLst/>
+      </p:bgPr>
+    </p:bg>
+    <p:spTree>
+      <p:nvGrpSpPr>
+        <p:cNvPr id="1" name=""/>
+        <p:cNvGrpSpPr/>
+        <p:nvPr/>
+      </p:nvGrpSpPr>
+      <p:grpSpPr/>
+      <p:sp>
+        <p:nvSpPr>
+          <p:cNvPr id="2" name="Rectangle 1"/>
+          <p:cNvSpPr/>
+          <p:nvPr/>
+        </p:nvSpPr>
+        <p:spPr>
+          <a:xfrm>
+            <a:off x="0" y="0"/>
+            <a:ext cx="100584" cy="6858000"/>
+          </a:xfrm>
+          <a:prstGeom prst="rect">
+            <a:avLst/>
+          </a:prstGeom>
+          <a:solidFill>
+            <a:srgbClr val="36D399"/>
+          </a:solidFill>
+          <a:ln>
+            <a:noFill/>
+          </a:ln>
+        </p:spPr>
+        <p:style>
+          <a:lnRef idx="1">
+            <a:schemeClr val="accent1"/>
+          </a:lnRef>
+          <a:fillRef idx="3">
+            <a:schemeClr val="accent1"/>
+          </a:fillRef>
+          <a:effectRef idx="2">
+            <a:schemeClr val="accent1"/>
+          </a:effectRef>
+          <a:fontRef idx="minor">
+            <a:schemeClr val="lt1"/>
+          </a:fontRef>
+        </p:style>
+        <p:txBody>
+          <a:bodyPr rtlCol="0" anchor="ctr"/>
+          <a:lstStyle/>
+          <a:p>
+            <a:pPr algn="ctr"/>
+          </a:p>
+        </p:txBody>
+      </p:sp>
+      <p:sp>
+        <p:nvSpPr>
+          <p:cNvPr id="3" name="audit:index"/>
+          <p:cNvSpPr txBox="1"/>
+          <p:nvPr/>
+        </p:nvSpPr>
+        <p:spPr>
+          <a:xfrm>
+            <a:off x="640080" y="274320"/>
+            <a:ext cx="4572000" cy="274320"/>
+          </a:xfrm>
+          <a:prstGeom prst="rect">
+            <a:avLst/>
+          </a:prstGeom>
+          <a:noFill/>
+        </p:spPr>
+        <p:txBody>
+          <a:bodyPr wrap="square" lIns="0" rIns="0" tIns="0" bIns="0">
+            <a:spAutoFit/>
+          </a:bodyPr>
+          <a:lstStyle/>
+          <a:p>
+            <a:r>
+              <a:rPr sz="1100" b="0">
+                <a:solidFill>
+                  <a:srgbClr val="93A4B5"/>
+                </a:solidFill>
+                <a:latin typeface="NanumGothic"/>
+                <a:ea typeface="NanumGothic"/>
+                <a:cs typeface="NanumGothic"/>
+              </a:rPr>
+              <a:t>TOKEN COST LAB  /  15</a:t>
+            </a:r>
+          </a:p>
+        </p:txBody>
+      </p:sp>
+      <p:sp>
+        <p:nvSpPr>
+          <p:cNvPr id="4" name="audit:scope"/>
+          <p:cNvSpPr txBox="1"/>
+          <p:nvPr/>
+        </p:nvSpPr>
+        <p:spPr>
+          <a:xfrm>
+            <a:off x="5760720" y="274320"/>
+            <a:ext cx="5760720" cy="274320"/>
+          </a:xfrm>
+          <a:prstGeom prst="rect">
+            <a:avLst/>
+          </a:prstGeom>
+          <a:noFill/>
+        </p:spPr>
+        <p:txBody>
+          <a:bodyPr wrap="square" lIns="0" rIns="0" tIns="0" bIns="0">
+            <a:spAutoFit/>
+          </a:bodyPr>
+          <a:lstStyle/>
+          <a:p>
+            <a:r>
+              <a:rPr sz="1100" b="0">
+                <a:solidFill>
+                  <a:srgbClr val="36D399"/>
+                </a:solidFill>
+                <a:latin typeface="NanumGothic"/>
+                <a:ea typeface="NanumGothic"/>
+                <a:cs typeface="NanumGothic"/>
+              </a:rPr>
               <a:t>마무리</a:t>
             </a:r>
           </a:p>
@@ -8498,6 +9620,423 @@
                 <a:cs typeface="NanumGothic"/>
               </a:rPr>
               <a:t>TOKEN COST LAB  /  06</a:t>
+            </a:r>
+          </a:p>
+        </p:txBody>
+      </p:sp>
+      <p:sp>
+        <p:nvSpPr>
+          <p:cNvPr id="4" name="audit:scope"/>
+          <p:cNvSpPr txBox="1"/>
+          <p:nvPr/>
+        </p:nvSpPr>
+        <p:spPr>
+          <a:xfrm>
+            <a:off x="5760720" y="274320"/>
+            <a:ext cx="5760720" cy="274320"/>
+          </a:xfrm>
+          <a:prstGeom prst="rect">
+            <a:avLst/>
+          </a:prstGeom>
+          <a:noFill/>
+        </p:spPr>
+        <p:txBody>
+          <a:bodyPr wrap="square" lIns="0" rIns="0" tIns="0" bIns="0">
+            <a:spAutoFit/>
+          </a:bodyPr>
+          <a:lstStyle/>
+          <a:p>
+            <a:r>
+              <a:rPr sz="1100" b="0">
+                <a:solidFill>
+                  <a:srgbClr val="36D399"/>
+                </a:solidFill>
+                <a:latin typeface="NanumGothic"/>
+                <a:ea typeface="NanumGothic"/>
+                <a:cs typeface="NanumGothic"/>
+              </a:rPr>
+              <a:t>추정치 재계산</a:t>
+            </a:r>
+          </a:p>
+        </p:txBody>
+      </p:sp>
+      <p:sp>
+        <p:nvSpPr>
+          <p:cNvPr id="5" name="audit:title"/>
+          <p:cNvSpPr txBox="1"/>
+          <p:nvPr/>
+        </p:nvSpPr>
+        <p:spPr>
+          <a:xfrm>
+            <a:off x="640080" y="566928"/>
+            <a:ext cx="10881360" cy="822960"/>
+          </a:xfrm>
+          <a:prstGeom prst="rect">
+            <a:avLst/>
+          </a:prstGeom>
+          <a:noFill/>
+        </p:spPr>
+        <p:txBody>
+          <a:bodyPr wrap="square" lIns="0" rIns="0" tIns="0" bIns="0">
+            <a:spAutoFit/>
+          </a:bodyPr>
+          <a:lstStyle/>
+          <a:p>
+            <a:r>
+              <a:rPr sz="2900" b="1">
+                <a:solidFill>
+                  <a:srgbClr val="ECF1F6"/>
+                </a:solidFill>
+                <a:latin typeface="NanumGothic"/>
+                <a:ea typeface="NanumGothic"/>
+                <a:cs typeface="NanumGothic"/>
+              </a:rPr>
+              <a:t>무엇이 비용을 움직였나</a:t>
+            </a:r>
+          </a:p>
+        </p:txBody>
+      </p:sp>
+      <p:sp>
+        <p:nvSpPr>
+          <p:cNvPr id="6" name="audit:hero"/>
+          <p:cNvSpPr txBox="1"/>
+          <p:nvPr/>
+        </p:nvSpPr>
+        <p:spPr>
+          <a:xfrm>
+            <a:off x="640080" y="1261872"/>
+            <a:ext cx="10881360" cy="777240"/>
+          </a:xfrm>
+          <a:prstGeom prst="rect">
+            <a:avLst/>
+          </a:prstGeom>
+          <a:noFill/>
+        </p:spPr>
+        <p:txBody>
+          <a:bodyPr wrap="square" lIns="0" rIns="0" tIns="0" bIns="0">
+            <a:spAutoFit/>
+          </a:bodyPr>
+          <a:lstStyle/>
+          <a:p>
+            <a:r>
+              <a:rPr sz="2900" b="1">
+                <a:solidFill>
+                  <a:srgbClr val="36D399"/>
+                </a:solidFill>
+                <a:latin typeface="NanumGothic"/>
+                <a:ea typeface="NanumGothic"/>
+                <a:cs typeface="NanumGothic"/>
+              </a:rPr>
+              <a:t>합계 7,868 → 8,010 (+1.8%)</a:t>
+            </a:r>
+          </a:p>
+        </p:txBody>
+      </p:sp>
+      <p:sp>
+        <p:nvSpPr>
+          <p:cNvPr id="7" name="audit:body-0"/>
+          <p:cNvSpPr txBox="1"/>
+          <p:nvPr/>
+        </p:nvSpPr>
+        <p:spPr>
+          <a:xfrm>
+            <a:off x="777240" y="2029968"/>
+            <a:ext cx="10652760" cy="612648"/>
+          </a:xfrm>
+          <a:prstGeom prst="rect">
+            <a:avLst/>
+          </a:prstGeom>
+          <a:noFill/>
+        </p:spPr>
+        <p:txBody>
+          <a:bodyPr wrap="square" lIns="0" rIns="0" tIns="0" bIns="0">
+            <a:spAutoFit/>
+          </a:bodyPr>
+          <a:lstStyle/>
+          <a:p>
+            <a:r>
+              <a:rPr sz="1750" b="0">
+                <a:solidFill>
+                  <a:srgbClr val="ECF1F6"/>
+                </a:solidFill>
+                <a:latin typeface="NanumGothic"/>
+                <a:ea typeface="NanumGothic"/>
+                <a:cs typeface="NanumGothic"/>
+              </a:rPr>
+              <a:t>비캐시 입력 ↑ · 추론+출력 ↓</a:t>
+            </a:r>
+          </a:p>
+        </p:txBody>
+      </p:sp>
+      <p:sp>
+        <p:nvSpPr>
+          <p:cNvPr id="8" name="audit:body-1"/>
+          <p:cNvSpPr txBox="1"/>
+          <p:nvPr/>
+        </p:nvSpPr>
+        <p:spPr>
+          <a:xfrm>
+            <a:off x="777240" y="2542032"/>
+            <a:ext cx="10652760" cy="612648"/>
+          </a:xfrm>
+          <a:prstGeom prst="rect">
+            <a:avLst/>
+          </a:prstGeom>
+          <a:noFill/>
+        </p:spPr>
+        <p:txBody>
+          <a:bodyPr wrap="square" lIns="0" rIns="0" tIns="0" bIns="0">
+            <a:spAutoFit/>
+          </a:bodyPr>
+          <a:lstStyle/>
+          <a:p>
+            <a:r>
+              <a:rPr sz="1750" b="0">
+                <a:solidFill>
+                  <a:srgbClr val="ECF1F6"/>
+                </a:solidFill>
+                <a:latin typeface="NanumGothic"/>
+                <a:ea typeface="NanumGothic"/>
+                <a:cs typeface="NanumGothic"/>
+              </a:rPr>
+              <a:t>합계는 거의 그대로, 구조만 바뀌었다</a:t>
+            </a:r>
+          </a:p>
+        </p:txBody>
+      </p:sp>
+      <p:pic>
+        <p:nvPicPr>
+          <p:cNvPr id="9" name="Picture 8" descr="case_tokens.png"/>
+          <p:cNvPicPr>
+            <a:picLocks noChangeAspect="1"/>
+          </p:cNvPicPr>
+          <p:nvPr/>
+        </p:nvPicPr>
+        <p:blipFill>
+          <a:blip r:embed="rId2"/>
+          <a:stretch>
+            <a:fillRect/>
+          </a:stretch>
+        </p:blipFill>
+        <p:spPr>
+          <a:xfrm>
+            <a:off x="777240" y="3101593"/>
+            <a:ext cx="10652760" cy="2959100"/>
+          </a:xfrm>
+          <a:prstGeom prst="rect">
+            <a:avLst/>
+          </a:prstGeom>
+        </p:spPr>
+      </p:pic>
+      <p:sp>
+        <p:nvSpPr>
+          <p:cNvPr id="10" name="audit:chart-caption"/>
+          <p:cNvSpPr txBox="1"/>
+          <p:nvPr/>
+        </p:nvSpPr>
+        <p:spPr>
+          <a:xfrm>
+            <a:off x="777240" y="6135624"/>
+            <a:ext cx="10652760" cy="237744"/>
+          </a:xfrm>
+          <a:prstGeom prst="rect">
+            <a:avLst/>
+          </a:prstGeom>
+          <a:noFill/>
+        </p:spPr>
+        <p:txBody>
+          <a:bodyPr wrap="square" lIns="0" rIns="0" tIns="0" bIns="0">
+            <a:spAutoFit/>
+          </a:bodyPr>
+          <a:lstStyle/>
+          <a:p>
+            <a:r>
+              <a:rPr sz="950" b="0">
+                <a:solidFill>
+                  <a:srgbClr val="93A4B5"/>
+                </a:solidFill>
+                <a:latin typeface="NanumGothic"/>
+                <a:ea typeface="NanumGothic"/>
+                <a:cs typeface="NanumGothic"/>
+              </a:rPr>
+              <a:t>그래프 · 토큰 수 (추정) · case_tokens.png</a:t>
+            </a:r>
+          </a:p>
+        </p:txBody>
+      </p:sp>
+      <p:sp>
+        <p:nvSpPr>
+          <p:cNvPr id="11" name="audit:source"/>
+          <p:cNvSpPr txBox="1"/>
+          <p:nvPr/>
+        </p:nvSpPr>
+        <p:spPr>
+          <a:xfrm>
+            <a:off x="777240" y="6382512"/>
+            <a:ext cx="10972800" cy="274320"/>
+          </a:xfrm>
+          <a:prstGeom prst="rect">
+            <a:avLst/>
+          </a:prstGeom>
+          <a:noFill/>
+        </p:spPr>
+        <p:txBody>
+          <a:bodyPr wrap="square" lIns="0" rIns="0" tIns="0" bIns="0">
+            <a:spAutoFit/>
+          </a:bodyPr>
+          <a:lstStyle/>
+          <a:p>
+            <a:r>
+              <a:rPr sz="1000" b="0">
+                <a:solidFill>
+                  <a:srgbClr val="93A4B5"/>
+                </a:solidFill>
+                <a:latin typeface="NanumGothic"/>
+                <a:ea typeface="NanumGothic"/>
+                <a:cs typeface="NanumGothic"/>
+              </a:rPr>
+              <a:t>demo/vibe_vs_spec/usage.json</a:t>
+            </a:r>
+          </a:p>
+        </p:txBody>
+      </p:sp>
+      <p:sp>
+        <p:nvSpPr>
+          <p:cNvPr id="12" name="audit:footer"/>
+          <p:cNvSpPr txBox="1"/>
+          <p:nvPr/>
+        </p:nvSpPr>
+        <p:spPr>
+          <a:xfrm>
+            <a:off x="777240" y="6583680"/>
+            <a:ext cx="10972800" cy="256032"/>
+          </a:xfrm>
+          <a:prstGeom prst="rect">
+            <a:avLst/>
+          </a:prstGeom>
+          <a:noFill/>
+        </p:spPr>
+        <p:txBody>
+          <a:bodyPr wrap="square" lIns="0" rIns="0" tIns="0" bIns="0">
+            <a:spAutoFit/>
+          </a:bodyPr>
+          <a:lstStyle/>
+          <a:p>
+            <a:r>
+              <a:rPr sz="1000" b="0">
+                <a:solidFill>
+                  <a:srgbClr val="93A4B5"/>
+                </a:solidFill>
+                <a:latin typeface="NanumGothic"/>
+                <a:ea typeface="NanumGothic"/>
+                <a:cs typeface="NanumGothic"/>
+              </a:rPr>
+              <a:t>2026-09-20  ·  근거와 조건을 함께 인용</a:t>
+            </a:r>
+          </a:p>
+        </p:txBody>
+      </p:sp>
+    </p:spTree>
+  </p:cSld>
+  <p:clrMapOvr>
+    <a:masterClrMapping/>
+  </p:clrMapOvr>
+</p:sld>
+</file>
+
+<file path=ppt/slides/slide7.xml><?xml version="1.0" encoding="utf-8"?>
+<p:sld xmlns:a="http://schemas.openxmlformats.org/drawingml/2006/main" xmlns:p="http://schemas.openxmlformats.org/presentationml/2006/main" xmlns:r="http://schemas.openxmlformats.org/officeDocument/2006/relationships">
+  <p:cSld>
+    <p:bg>
+      <p:bgPr>
+        <a:solidFill>
+          <a:srgbClr val="0E141B"/>
+        </a:solidFill>
+        <a:effectLst/>
+      </p:bgPr>
+    </p:bg>
+    <p:spTree>
+      <p:nvGrpSpPr>
+        <p:cNvPr id="1" name=""/>
+        <p:cNvGrpSpPr/>
+        <p:nvPr/>
+      </p:nvGrpSpPr>
+      <p:grpSpPr/>
+      <p:sp>
+        <p:nvSpPr>
+          <p:cNvPr id="2" name="Rectangle 1"/>
+          <p:cNvSpPr/>
+          <p:nvPr/>
+        </p:nvSpPr>
+        <p:spPr>
+          <a:xfrm>
+            <a:off x="0" y="0"/>
+            <a:ext cx="100584" cy="6858000"/>
+          </a:xfrm>
+          <a:prstGeom prst="rect">
+            <a:avLst/>
+          </a:prstGeom>
+          <a:solidFill>
+            <a:srgbClr val="36D399"/>
+          </a:solidFill>
+          <a:ln>
+            <a:noFill/>
+          </a:ln>
+        </p:spPr>
+        <p:style>
+          <a:lnRef idx="1">
+            <a:schemeClr val="accent1"/>
+          </a:lnRef>
+          <a:fillRef idx="3">
+            <a:schemeClr val="accent1"/>
+          </a:fillRef>
+          <a:effectRef idx="2">
+            <a:schemeClr val="accent1"/>
+          </a:effectRef>
+          <a:fontRef idx="minor">
+            <a:schemeClr val="lt1"/>
+          </a:fontRef>
+        </p:style>
+        <p:txBody>
+          <a:bodyPr rtlCol="0" anchor="ctr"/>
+          <a:lstStyle/>
+          <a:p>
+            <a:pPr algn="ctr"/>
+          </a:p>
+        </p:txBody>
+      </p:sp>
+      <p:sp>
+        <p:nvSpPr>
+          <p:cNvPr id="3" name="audit:index"/>
+          <p:cNvSpPr txBox="1"/>
+          <p:nvPr/>
+        </p:nvSpPr>
+        <p:spPr>
+          <a:xfrm>
+            <a:off x="640080" y="274320"/>
+            <a:ext cx="4572000" cy="274320"/>
+          </a:xfrm>
+          <a:prstGeom prst="rect">
+            <a:avLst/>
+          </a:prstGeom>
+          <a:noFill/>
+        </p:spPr>
+        <p:txBody>
+          <a:bodyPr wrap="square" lIns="0" rIns="0" tIns="0" bIns="0">
+            <a:spAutoFit/>
+          </a:bodyPr>
+          <a:lstStyle/>
+          <a:p>
+            <a:r>
+              <a:rPr sz="1100" b="0">
+                <a:solidFill>
+                  <a:srgbClr val="93A4B5"/>
+                </a:solidFill>
+                <a:latin typeface="NanumGothic"/>
+                <a:ea typeface="NanumGothic"/>
+                <a:cs typeface="NanumGothic"/>
+              </a:rPr>
+              <a:t>TOKEN COST LAB  /  07</a:t>
             </a:r>
           </a:p>
         </p:txBody>
@@ -8988,7 +10527,7 @@
 </p:sld>
 </file>
 
-<file path=ppt/slides/slide7.xml><?xml version="1.0" encoding="utf-8"?>
+<file path=ppt/slides/slide8.xml><?xml version="1.0" encoding="utf-8"?>
 <p:sld xmlns:a="http://schemas.openxmlformats.org/drawingml/2006/main" xmlns:p="http://schemas.openxmlformats.org/presentationml/2006/main" xmlns:r="http://schemas.openxmlformats.org/officeDocument/2006/relationships">
   <p:cSld>
     <p:bg>
@@ -9080,7 +10619,7 @@
                 <a:ea typeface="NanumGothic"/>
                 <a:cs typeface="NanumGothic"/>
               </a:rPr>
-              <a:t>TOKEN COST LAB  /  07</a:t>
+              <a:t>TOKEN COST LAB  /  08</a:t>
             </a:r>
           </a:p>
         </p:txBody>
@@ -9521,589 +11060,6 @@
 </p:sld>
 </file>
 
-<file path=ppt/slides/slide8.xml><?xml version="1.0" encoding="utf-8"?>
-<p:sld xmlns:a="http://schemas.openxmlformats.org/drawingml/2006/main" xmlns:p="http://schemas.openxmlformats.org/presentationml/2006/main" xmlns:r="http://schemas.openxmlformats.org/officeDocument/2006/relationships">
-  <p:cSld>
-    <p:bg>
-      <p:bgPr>
-        <a:solidFill>
-          <a:srgbClr val="0E141B"/>
-        </a:solidFill>
-        <a:effectLst/>
-      </p:bgPr>
-    </p:bg>
-    <p:spTree>
-      <p:nvGrpSpPr>
-        <p:cNvPr id="1" name=""/>
-        <p:cNvGrpSpPr/>
-        <p:nvPr/>
-      </p:nvGrpSpPr>
-      <p:grpSpPr/>
-      <p:sp>
-        <p:nvSpPr>
-          <p:cNvPr id="2" name="Rectangle 1"/>
-          <p:cNvSpPr/>
-          <p:nvPr/>
-        </p:nvSpPr>
-        <p:spPr>
-          <a:xfrm>
-            <a:off x="0" y="0"/>
-            <a:ext cx="100584" cy="6858000"/>
-          </a:xfrm>
-          <a:prstGeom prst="rect">
-            <a:avLst/>
-          </a:prstGeom>
-          <a:solidFill>
-            <a:srgbClr val="36D399"/>
-          </a:solidFill>
-          <a:ln>
-            <a:noFill/>
-          </a:ln>
-        </p:spPr>
-        <p:style>
-          <a:lnRef idx="1">
-            <a:schemeClr val="accent1"/>
-          </a:lnRef>
-          <a:fillRef idx="3">
-            <a:schemeClr val="accent1"/>
-          </a:fillRef>
-          <a:effectRef idx="2">
-            <a:schemeClr val="accent1"/>
-          </a:effectRef>
-          <a:fontRef idx="minor">
-            <a:schemeClr val="lt1"/>
-          </a:fontRef>
-        </p:style>
-        <p:txBody>
-          <a:bodyPr rtlCol="0" anchor="ctr"/>
-          <a:lstStyle/>
-          <a:p>
-            <a:pPr algn="ctr"/>
-          </a:p>
-        </p:txBody>
-      </p:sp>
-      <p:sp>
-        <p:nvSpPr>
-          <p:cNvPr id="3" name="audit:index"/>
-          <p:cNvSpPr txBox="1"/>
-          <p:nvPr/>
-        </p:nvSpPr>
-        <p:spPr>
-          <a:xfrm>
-            <a:off x="640080" y="274320"/>
-            <a:ext cx="4572000" cy="274320"/>
-          </a:xfrm>
-          <a:prstGeom prst="rect">
-            <a:avLst/>
-          </a:prstGeom>
-          <a:noFill/>
-        </p:spPr>
-        <p:txBody>
-          <a:bodyPr wrap="square" lIns="0" rIns="0" tIns="0" bIns="0">
-            <a:spAutoFit/>
-          </a:bodyPr>
-          <a:lstStyle/>
-          <a:p>
-            <a:r>
-              <a:rPr sz="1100" b="0">
-                <a:solidFill>
-                  <a:srgbClr val="93A4B5"/>
-                </a:solidFill>
-                <a:latin typeface="NanumGothic"/>
-                <a:ea typeface="NanumGothic"/>
-                <a:cs typeface="NanumGothic"/>
-              </a:rPr>
-              <a:t>TOKEN COST LAB  /  08</a:t>
-            </a:r>
-          </a:p>
-        </p:txBody>
-      </p:sp>
-      <p:sp>
-        <p:nvSpPr>
-          <p:cNvPr id="4" name="audit:scope"/>
-          <p:cNvSpPr txBox="1"/>
-          <p:nvPr/>
-        </p:nvSpPr>
-        <p:spPr>
-          <a:xfrm>
-            <a:off x="5760720" y="274320"/>
-            <a:ext cx="5760720" cy="274320"/>
-          </a:xfrm>
-          <a:prstGeom prst="rect">
-            <a:avLst/>
-          </a:prstGeom>
-          <a:noFill/>
-        </p:spPr>
-        <p:txBody>
-          <a:bodyPr wrap="square" lIns="0" rIns="0" tIns="0" bIns="0">
-            <a:spAutoFit/>
-          </a:bodyPr>
-          <a:lstStyle/>
-          <a:p>
-            <a:r>
-              <a:rPr sz="1100" b="0">
-                <a:solidFill>
-                  <a:srgbClr val="36D399"/>
-                </a:solidFill>
-                <a:latin typeface="NanumGothic"/>
-                <a:ea typeface="NanumGothic"/>
-                <a:cs typeface="NanumGothic"/>
-              </a:rPr>
-              <a:t>단가 민감도</a:t>
-            </a:r>
-          </a:p>
-        </p:txBody>
-      </p:sp>
-      <p:sp>
-        <p:nvSpPr>
-          <p:cNvPr id="5" name="audit:title"/>
-          <p:cNvSpPr txBox="1"/>
-          <p:nvPr/>
-        </p:nvSpPr>
-        <p:spPr>
-          <a:xfrm>
-            <a:off x="640080" y="822960"/>
-            <a:ext cx="10881360" cy="822960"/>
-          </a:xfrm>
-          <a:prstGeom prst="rect">
-            <a:avLst/>
-          </a:prstGeom>
-          <a:noFill/>
-        </p:spPr>
-        <p:txBody>
-          <a:bodyPr wrap="square" lIns="0" rIns="0" tIns="0" bIns="0">
-            <a:spAutoFit/>
-          </a:bodyPr>
-          <a:lstStyle/>
-          <a:p>
-            <a:r>
-              <a:rPr sz="2900" b="1">
-                <a:solidFill>
-                  <a:srgbClr val="ECF1F6"/>
-                </a:solidFill>
-                <a:latin typeface="NanumGothic"/>
-                <a:ea typeface="NanumGothic"/>
-                <a:cs typeface="NanumGothic"/>
-              </a:rPr>
-              <a:t>단가비가 손익을 결정한다</a:t>
-            </a:r>
-          </a:p>
-        </p:txBody>
-      </p:sp>
-      <p:sp>
-        <p:nvSpPr>
-          <p:cNvPr id="6" name="audit:hero"/>
-          <p:cNvSpPr txBox="1"/>
-          <p:nvPr/>
-        </p:nvSpPr>
-        <p:spPr>
-          <a:xfrm>
-            <a:off x="640080" y="1783080"/>
-            <a:ext cx="6583680" cy="777240"/>
-          </a:xfrm>
-          <a:prstGeom prst="rect">
-            <a:avLst/>
-          </a:prstGeom>
-          <a:noFill/>
-        </p:spPr>
-        <p:txBody>
-          <a:bodyPr wrap="square" lIns="0" rIns="0" tIns="0" bIns="0">
-            <a:spAutoFit/>
-          </a:bodyPr>
-          <a:lstStyle/>
-          <a:p>
-            <a:r>
-              <a:rPr sz="2900" b="1">
-                <a:solidFill>
-                  <a:srgbClr val="36D399"/>
-                </a:solidFill>
-                <a:latin typeface="NanumGothic"/>
-                <a:ea typeface="NanumGothic"/>
-                <a:cs typeface="NanumGothic"/>
-              </a:rPr>
-              <a:t>r &gt; (666 + 156h) / 680</a:t>
-            </a:r>
-          </a:p>
-        </p:txBody>
-      </p:sp>
-      <p:sp>
-        <p:nvSpPr>
-          <p:cNvPr id="7" name="audit:body-0"/>
-          <p:cNvSpPr txBox="1"/>
-          <p:nvPr/>
-        </p:nvSpPr>
-        <p:spPr>
-          <a:xfrm>
-            <a:off x="777240" y="2862072"/>
-            <a:ext cx="6400800" cy="612648"/>
-          </a:xfrm>
-          <a:prstGeom prst="rect">
-            <a:avLst/>
-          </a:prstGeom>
-          <a:noFill/>
-        </p:spPr>
-        <p:txBody>
-          <a:bodyPr wrap="square" lIns="0" rIns="0" tIns="0" bIns="0">
-            <a:spAutoFit/>
-          </a:bodyPr>
-          <a:lstStyle/>
-          <a:p>
-            <a:r>
-              <a:rPr sz="1750" b="0">
-                <a:solidFill>
-                  <a:srgbClr val="ECF1F6"/>
-                </a:solidFill>
-                <a:latin typeface="NanumGothic"/>
-                <a:ea typeface="NanumGothic"/>
-                <a:cs typeface="NanumGothic"/>
-              </a:rPr>
-              <a:t>r = 출력/입력 단가, h = 캐시 읽기/입력 단가</a:t>
-            </a:r>
-          </a:p>
-        </p:txBody>
-      </p:sp>
-      <p:sp>
-        <p:nvSpPr>
-          <p:cNvPr id="8" name="audit:body-1"/>
-          <p:cNvSpPr txBox="1"/>
-          <p:nvPr/>
-        </p:nvSpPr>
-        <p:spPr>
-          <a:xfrm>
-            <a:off x="777240" y="3502152"/>
-            <a:ext cx="6400800" cy="612648"/>
-          </a:xfrm>
-          <a:prstGeom prst="rect">
-            <a:avLst/>
-          </a:prstGeom>
-          <a:noFill/>
-        </p:spPr>
-        <p:txBody>
-          <a:bodyPr wrap="square" lIns="0" rIns="0" tIns="0" bIns="0">
-            <a:spAutoFit/>
-          </a:bodyPr>
-          <a:lstStyle/>
-          <a:p>
-            <a:r>
-              <a:rPr sz="1750" b="0">
-                <a:solidFill>
-                  <a:srgbClr val="ECF1F6"/>
-                </a:solidFill>
-                <a:latin typeface="NanumGothic"/>
-                <a:ea typeface="NanumGothic"/>
-                <a:cs typeface="NanumGothic"/>
-              </a:rPr>
-              <a:t>출력 단가가 조금만 높아도 스펙 쪽이 유리해진다</a:t>
-            </a:r>
-          </a:p>
-        </p:txBody>
-      </p:sp>
-      <p:graphicFrame>
-        <p:nvGraphicFramePr>
-          <p:cNvPr id="9" name="Table 8"/>
-          <p:cNvGraphicFramePr>
-            <a:graphicFrameLocks noGrp="1"/>
-          </p:cNvGraphicFramePr>
-          <p:nvPr/>
-        </p:nvGraphicFramePr>
-        <p:xfrm>
-          <a:off x="777240" y="4233671"/>
-          <a:ext cx="10652760" cy="1682496"/>
-        </p:xfrm>
-        <a:graphic>
-          <a:graphicData uri="http://schemas.openxmlformats.org/drawingml/2006/table">
-            <a:tbl>
-              <a:tblPr>
-                <a:tableStyleId>{5C22544A-7EE6-4342-B048-85BDC9FD1C3A}</a:tableStyleId>
-              </a:tblPr>
-              <a:tblGrid>
-                <a:gridCol w="3931920"/>
-                <a:gridCol w="6720840"/>
-              </a:tblGrid>
-              <a:tr h="420624">
-                <a:tc>
-                  <a:txBody>
-                    <a:bodyPr wrap="square"/>
-                    <a:lstStyle/>
-                    <a:p>
-                      <a:r>
-                        <a:rPr sz="1250" b="0">
-                          <a:solidFill>
-                            <a:srgbClr val="93A4B5"/>
-                          </a:solidFill>
-                          <a:latin typeface="NanumGothic"/>
-                          <a:ea typeface="NanumGothic"/>
-                          <a:cs typeface="NanumGothic"/>
-                        </a:rPr>
-                        <a:t>손익분기 조건</a:t>
-                      </a:r>
-                    </a:p>
-                  </a:txBody>
-                  <a:tcPr marL="91440" marR="91440">
-                    <a:solidFill>
-                      <a:srgbClr val="111A24"/>
-                    </a:solidFill>
-                  </a:tcPr>
-                </a:tc>
-                <a:tc>
-                  <a:txBody>
-                    <a:bodyPr wrap="square"/>
-                    <a:lstStyle/>
-                    <a:p>
-                      <a:r>
-                        <a:rPr sz="1400" b="1">
-                          <a:solidFill>
-                            <a:srgbClr val="ECF1F6"/>
-                          </a:solidFill>
-                          <a:latin typeface="NanumGothic"/>
-                          <a:ea typeface="NanumGothic"/>
-                          <a:cs typeface="NanumGothic"/>
-                        </a:rPr>
-                        <a:t>r &gt; (666 + 156h) / 680</a:t>
-                      </a:r>
-                    </a:p>
-                  </a:txBody>
-                  <a:tcPr marL="91440" marR="91440">
-                    <a:solidFill>
-                      <a:srgbClr val="111A24"/>
-                    </a:solidFill>
-                  </a:tcPr>
-                </a:tc>
-              </a:tr>
-              <a:tr h="420624">
-                <a:tc>
-                  <a:txBody>
-                    <a:bodyPr wrap="square"/>
-                    <a:lstStyle/>
-                    <a:p>
-                      <a:r>
-                        <a:rPr sz="1250" b="0">
-                          <a:solidFill>
-                            <a:srgbClr val="93A4B5"/>
-                          </a:solidFill>
-                          <a:latin typeface="NanumGothic"/>
-                          <a:ea typeface="NanumGothic"/>
-                          <a:cs typeface="NanumGothic"/>
-                        </a:rPr>
-                        <a:t>h = 0.1이면</a:t>
-                      </a:r>
-                    </a:p>
-                  </a:txBody>
-                  <a:tcPr marL="91440" marR="91440">
-                    <a:solidFill>
-                      <a:srgbClr val="18222E"/>
-                    </a:solidFill>
-                  </a:tcPr>
-                </a:tc>
-                <a:tc>
-                  <a:txBody>
-                    <a:bodyPr wrap="square"/>
-                    <a:lstStyle/>
-                    <a:p>
-                      <a:r>
-                        <a:rPr sz="1400" b="1">
-                          <a:solidFill>
-                            <a:srgbClr val="ECF1F6"/>
-                          </a:solidFill>
-                          <a:latin typeface="NanumGothic"/>
-                          <a:ea typeface="NanumGothic"/>
-                          <a:cs typeface="NanumGothic"/>
-                        </a:rPr>
-                        <a:t>r = 1.0024</a:t>
-                      </a:r>
-                    </a:p>
-                  </a:txBody>
-                  <a:tcPr marL="91440" marR="91440">
-                    <a:solidFill>
-                      <a:srgbClr val="18222E"/>
-                    </a:solidFill>
-                  </a:tcPr>
-                </a:tc>
-              </a:tr>
-              <a:tr h="420624">
-                <a:tc>
-                  <a:txBody>
-                    <a:bodyPr wrap="square"/>
-                    <a:lstStyle/>
-                    <a:p>
-                      <a:r>
-                        <a:rPr sz="1250" b="0">
-                          <a:solidFill>
-                            <a:srgbClr val="93A4B5"/>
-                          </a:solidFill>
-                          <a:latin typeface="NanumGothic"/>
-                          <a:ea typeface="NanumGothic"/>
-                          <a:cs typeface="NanumGothic"/>
-                        </a:rPr>
-                        <a:t>r → ∞ 수렴</a:t>
-                      </a:r>
-                    </a:p>
-                  </a:txBody>
-                  <a:tcPr marL="91440" marR="91440">
-                    <a:solidFill>
-                      <a:srgbClr val="111A24"/>
-                    </a:solidFill>
-                  </a:tcPr>
-                </a:tc>
-                <a:tc>
-                  <a:txBody>
-                    <a:bodyPr wrap="square"/>
-                    <a:lstStyle/>
-                    <a:p>
-                      <a:r>
-                        <a:rPr sz="1400" b="1">
-                          <a:solidFill>
-                            <a:srgbClr val="ECF1F6"/>
-                          </a:solidFill>
-                          <a:latin typeface="NanumGothic"/>
-                          <a:ea typeface="NanumGothic"/>
-                          <a:cs typeface="NanumGothic"/>
-                        </a:rPr>
-                        <a:t>약 9.62% 감소에 수렴</a:t>
-                      </a:r>
-                    </a:p>
-                  </a:txBody>
-                  <a:tcPr marL="91440" marR="91440">
-                    <a:solidFill>
-                      <a:srgbClr val="111A24"/>
-                    </a:solidFill>
-                  </a:tcPr>
-                </a:tc>
-              </a:tr>
-              <a:tr h="420624">
-                <a:tc>
-                  <a:txBody>
-                    <a:bodyPr wrap="square"/>
-                    <a:lstStyle/>
-                    <a:p>
-                      <a:r>
-                        <a:rPr sz="1250" b="0">
-                          <a:solidFill>
-                            <a:srgbClr val="93A4B5"/>
-                          </a:solidFill>
-                          <a:latin typeface="NanumGothic"/>
-                          <a:ea typeface="NanumGothic"/>
-                          <a:cs typeface="NanumGothic"/>
-                        </a:rPr>
-                        <a:t>실제 청구서</a:t>
-                      </a:r>
-                    </a:p>
-                  </a:txBody>
-                  <a:tcPr marL="91440" marR="91440">
-                    <a:solidFill>
-                      <a:srgbClr val="18222E"/>
-                    </a:solidFill>
-                  </a:tcPr>
-                </a:tc>
-                <a:tc>
-                  <a:txBody>
-                    <a:bodyPr wrap="square"/>
-                    <a:lstStyle/>
-                    <a:p>
-                      <a:r>
-                        <a:rPr sz="1400" b="1">
-                          <a:solidFill>
-                            <a:srgbClr val="ECF1F6"/>
-                          </a:solidFill>
-                          <a:latin typeface="NanumGothic"/>
-                          <a:ea typeface="NanumGothic"/>
-                          <a:cs typeface="NanumGothic"/>
-                        </a:rPr>
-                        <a:t>미확인 (usage 추정치 산술)</a:t>
-                      </a:r>
-                    </a:p>
-                  </a:txBody>
-                  <a:tcPr marL="91440" marR="91440">
-                    <a:solidFill>
-                      <a:srgbClr val="18222E"/>
-                    </a:solidFill>
-                  </a:tcPr>
-                </a:tc>
-              </a:tr>
-            </a:tbl>
-          </a:graphicData>
-        </a:graphic>
-      </p:graphicFrame>
-      <p:sp>
-        <p:nvSpPr>
-          <p:cNvPr id="10" name="audit:source"/>
-          <p:cNvSpPr txBox="1"/>
-          <p:nvPr/>
-        </p:nvSpPr>
-        <p:spPr>
-          <a:xfrm>
-            <a:off x="640080" y="6080760"/>
-            <a:ext cx="10972800" cy="274320"/>
-          </a:xfrm>
-          <a:prstGeom prst="rect">
-            <a:avLst/>
-          </a:prstGeom>
-          <a:noFill/>
-        </p:spPr>
-        <p:txBody>
-          <a:bodyPr wrap="square" lIns="0" rIns="0" tIns="0" bIns="0">
-            <a:spAutoFit/>
-          </a:bodyPr>
-          <a:lstStyle/>
-          <a:p>
-            <a:r>
-              <a:rPr sz="1000" b="0">
-                <a:solidFill>
-                  <a:srgbClr val="93A4B5"/>
-                </a:solidFill>
-                <a:latin typeface="NanumGothic"/>
-                <a:ea typeface="NanumGothic"/>
-                <a:cs typeface="NanumGothic"/>
-              </a:rPr>
-              <a:t>demo/vibe_vs_spec/sensitivity.py</a:t>
-            </a:r>
-          </a:p>
-        </p:txBody>
-      </p:sp>
-      <p:sp>
-        <p:nvSpPr>
-          <p:cNvPr id="11" name="audit:footer"/>
-          <p:cNvSpPr txBox="1"/>
-          <p:nvPr/>
-        </p:nvSpPr>
-        <p:spPr>
-          <a:xfrm>
-            <a:off x="640080" y="6419088"/>
-            <a:ext cx="10972800" cy="256032"/>
-          </a:xfrm>
-          <a:prstGeom prst="rect">
-            <a:avLst/>
-          </a:prstGeom>
-          <a:noFill/>
-        </p:spPr>
-        <p:txBody>
-          <a:bodyPr wrap="square" lIns="0" rIns="0" tIns="0" bIns="0">
-            <a:spAutoFit/>
-          </a:bodyPr>
-          <a:lstStyle/>
-          <a:p>
-            <a:r>
-              <a:rPr sz="1000" b="0">
-                <a:solidFill>
-                  <a:srgbClr val="93A4B5"/>
-                </a:solidFill>
-                <a:latin typeface="NanumGothic"/>
-                <a:ea typeface="NanumGothic"/>
-                <a:cs typeface="NanumGothic"/>
-              </a:rPr>
-              <a:t>2026-09-20  ·  근거와 조건을 함께 인용</a:t>
-            </a:r>
-          </a:p>
-        </p:txBody>
-      </p:sp>
-    </p:spTree>
-  </p:cSld>
-  <p:clrMapOvr>
-    <a:masterClrMapping/>
-  </p:clrMapOvr>
-</p:sld>
-</file>
-
 <file path=ppt/slides/slide9.xml><?xml version="1.0" encoding="utf-8"?>
 <p:sld xmlns:a="http://schemas.openxmlformats.org/drawingml/2006/main" xmlns:p="http://schemas.openxmlformats.org/presentationml/2006/main" xmlns:r="http://schemas.openxmlformats.org/officeDocument/2006/relationships">
   <p:cSld>
@@ -10232,7 +11188,7 @@
                 <a:ea typeface="NanumGothic"/>
                 <a:cs typeface="NanumGothic"/>
               </a:rPr>
-              <a:t>실동작 검사 (Chromium)</a:t>
+              <a:t>단가별 비용 재계산</a:t>
             </a:r>
           </a:p>
         </p:txBody>
@@ -10245,7 +11201,7 @@
         </p:nvSpPr>
         <p:spPr>
           <a:xfrm>
-            <a:off x="640080" y="822960"/>
+            <a:off x="640080" y="566928"/>
             <a:ext cx="10881360" cy="822960"/>
           </a:xfrm>
           <a:prstGeom prst="rect">
@@ -10268,7 +11224,7 @@
                 <a:ea typeface="NanumGothic"/>
                 <a:cs typeface="NanumGothic"/>
               </a:rPr>
-              <a:t>무엇을 확인했나</a:t>
+              <a:t>단가가 바뀌어도 방향은 같다</a:t>
             </a:r>
           </a:p>
         </p:txBody>
@@ -10281,7 +11237,7 @@
         </p:nvSpPr>
         <p:spPr>
           <a:xfrm>
-            <a:off x="640080" y="1783080"/>
+            <a:off x="640080" y="1261872"/>
             <a:ext cx="10881360" cy="777240"/>
           </a:xfrm>
           <a:prstGeom prst="rect">
@@ -10304,7 +11260,7 @@
                 <a:ea typeface="NanumGothic"/>
                 <a:cs typeface="NanumGothic"/>
               </a:rPr>
-              <a:t>정적 16 + 브라우저 29항목</a:t>
+              <a:t>감소 8.3% · 7.6% · 8.1%</a:t>
             </a:r>
           </a:p>
         </p:txBody>
@@ -10317,7 +11273,7 @@
         </p:nvSpPr>
         <p:spPr>
           <a:xfrm>
-            <a:off x="777240" y="2862072"/>
+            <a:off x="777240" y="2029968"/>
             <a:ext cx="10652760" cy="612648"/>
           </a:xfrm>
           <a:prstGeom prst="rect">
@@ -10340,7 +11296,7 @@
                 <a:ea typeface="NanumGothic"/>
                 <a:cs typeface="NanumGothic"/>
               </a:rPr>
-              <a:t>390 · 820 · 821 · 1280px 렌더링과 앵커 이동 검사</a:t>
+              <a:t>같은 추정 usage를 세 단가로 환산</a:t>
             </a:r>
           </a:p>
         </p:txBody>
@@ -10353,7 +11309,7 @@
         </p:nvSpPr>
         <p:spPr>
           <a:xfrm>
-            <a:off x="777240" y="3502152"/>
+            <a:off x="777240" y="2542032"/>
             <a:ext cx="10652760" cy="612648"/>
           </a:xfrm>
           <a:prstGeom prst="rect">
@@ -10376,20 +11332,80 @@
                 <a:ea typeface="NanumGothic"/>
                 <a:cs typeface="NanumGothic"/>
               </a:rPr>
-              <a:t>실패하는 변조를 넣어 검사가 실제로 잡는지도 확인</a:t>
-            </a:r>
-          </a:p>
-        </p:txBody>
-      </p:sp>
-      <p:sp>
-        <p:nvSpPr>
-          <p:cNvPr id="9" name="audit:source"/>
-          <p:cNvSpPr txBox="1"/>
-          <p:nvPr/>
-        </p:nvSpPr>
-        <p:spPr>
-          <a:xfrm>
-            <a:off x="640080" y="6080760"/>
+              <a:t>출력 단가가 높을수록 격차가 커진다</a:t>
+            </a:r>
+          </a:p>
+        </p:txBody>
+      </p:sp>
+      <p:pic>
+        <p:nvPicPr>
+          <p:cNvPr id="9" name="Picture 8" descr="case_bases.png"/>
+          <p:cNvPicPr>
+            <a:picLocks noChangeAspect="1"/>
+          </p:cNvPicPr>
+          <p:nvPr/>
+        </p:nvPicPr>
+        <p:blipFill>
+          <a:blip r:embed="rId2"/>
+          <a:stretch>
+            <a:fillRect/>
+          </a:stretch>
+        </p:blipFill>
+        <p:spPr>
+          <a:xfrm>
+            <a:off x="777240" y="3101593"/>
+            <a:ext cx="10652760" cy="2959100"/>
+          </a:xfrm>
+          <a:prstGeom prst="rect">
+            <a:avLst/>
+          </a:prstGeom>
+        </p:spPr>
+      </p:pic>
+      <p:sp>
+        <p:nvSpPr>
+          <p:cNvPr id="10" name="audit:chart-caption"/>
+          <p:cNvSpPr txBox="1"/>
+          <p:nvPr/>
+        </p:nvSpPr>
+        <p:spPr>
+          <a:xfrm>
+            <a:off x="777240" y="6135624"/>
+            <a:ext cx="10652760" cy="237744"/>
+          </a:xfrm>
+          <a:prstGeom prst="rect">
+            <a:avLst/>
+          </a:prstGeom>
+          <a:noFill/>
+        </p:spPr>
+        <p:txBody>
+          <a:bodyPr wrap="square" lIns="0" rIns="0" tIns="0" bIns="0">
+            <a:spAutoFit/>
+          </a:bodyPr>
+          <a:lstStyle/>
+          <a:p>
+            <a:r>
+              <a:rPr sz="950" b="0">
+                <a:solidFill>
+                  <a:srgbClr val="93A4B5"/>
+                </a:solidFill>
+                <a:latin typeface="NanumGothic"/>
+                <a:ea typeface="NanumGothic"/>
+                <a:cs typeface="NanumGothic"/>
+              </a:rPr>
+              <a:t>그래프 · 추정 비용 (USD) · case_bases.png</a:t>
+            </a:r>
+          </a:p>
+        </p:txBody>
+      </p:sp>
+      <p:sp>
+        <p:nvSpPr>
+          <p:cNvPr id="11" name="audit:source"/>
+          <p:cNvSpPr txBox="1"/>
+          <p:nvPr/>
+        </p:nvSpPr>
+        <p:spPr>
+          <a:xfrm>
+            <a:off x="777240" y="6382512"/>
             <a:ext cx="10972800" cy="274320"/>
           </a:xfrm>
           <a:prstGeom prst="rect">
@@ -10412,20 +11428,20 @@
                 <a:ea typeface="NanumGothic"/>
                 <a:cs typeface="NanumGothic"/>
               </a:rPr>
-              <a:t>demo/vibe_vs_spec/verify_ac.py</a:t>
-            </a:r>
-          </a:p>
-        </p:txBody>
-      </p:sp>
-      <p:sp>
-        <p:nvSpPr>
-          <p:cNvPr id="10" name="audit:footer"/>
-          <p:cNvSpPr txBox="1"/>
-          <p:nvPr/>
-        </p:nvSpPr>
-        <p:spPr>
-          <a:xfrm>
-            <a:off x="640080" y="6419088"/>
+              <a:t>presentation/case_vibe_vs_spec/cost_comparison.md</a:t>
+            </a:r>
+          </a:p>
+        </p:txBody>
+      </p:sp>
+      <p:sp>
+        <p:nvSpPr>
+          <p:cNvPr id="12" name="audit:footer"/>
+          <p:cNvSpPr txBox="1"/>
+          <p:nvPr/>
+        </p:nvSpPr>
+        <p:spPr>
+          <a:xfrm>
+            <a:off x="777240" y="6583680"/>
             <a:ext cx="10972800" cy="256032"/>
           </a:xfrm>
           <a:prstGeom prst="rect">

</xml_diff>

<commit_message>
feat: rebuild the decks as a visual talk — bigger charts, price table, section dividers
그래프를 슬라이드 전폭·전고로 키우고, 단가 표 슬라이드와 구간 표지를 넣어
발표 흐름(01 언어 → 02 출력·추론 → 03 캐시·컨텍스트 → 04 사례·적용)을 만들었다.

- 그래프 11종으로 확대: 추가 3종
  · monthly  워크플로 A/B 월 청구서(월 1,760건, 모델 6종) — B가 -64~-69%
  · cache_hit 캐시 적중률별 100콜 비용 곡선 + 손익분기 22.0%
  · usage_mix 20턴 세션 토큰 구성 — 이력 재전송 75.1%, 생성은 2.3%
  tokenizer 차트는 영어=1.00 기준 4개 가로 막대로 재작성(넓은 화면에서 읽히게)
- 단가 표 슬라이드: lab/pricing.py에서 셀을 직접 생성(모델·입력·출력·출력÷입력·캐시 읽기)
- 구간 표지 5종(01~04 + 심화). 렌더러에 divider/table 레이아웃 추가
- 덱 구성: 통합 44 · 본편 34 · 보너스 16 · 에이전트 23 · 케이스 15장
  차트 33장 · 표 2장 · 표지 5장. stack 차트와 중복되는 텍스트 슬라이드는 제거
- 검증: 표 셀 대조(단가 스냅샷) · 모든 차트가 덱에서 실제 사용되는지 · 표지에도 멘트·노트 요구
  · 월 청구서/캐시 곡선/토큰 구성의 재계산 대조 — 테스트 120 (신규 3)
- 문서: presentation/README(그래프 표), RETIRED(장수·재주장 17), REASSERTED·CORRECTIONS 동기화
</commit_message>
<xml_diff>
--- a/presentation/case_vibe_vs_spec/vibe_vs_spec.pptx
+++ b/presentation/case_vibe_vs_spec/vibe_vs_spec.pptx
@@ -9704,7 +9704,7 @@
         </p:nvSpPr>
         <p:spPr>
           <a:xfrm>
-            <a:off x="640080" y="1261872"/>
+            <a:off x="640080" y="1188720"/>
             <a:ext cx="10881360" cy="777240"/>
           </a:xfrm>
           <a:prstGeom prst="rect">
@@ -9740,7 +9740,7 @@
         </p:nvSpPr>
         <p:spPr>
           <a:xfrm>
-            <a:off x="777240" y="2029968"/>
+            <a:off x="777240" y="1920240"/>
             <a:ext cx="10652760" cy="612648"/>
           </a:xfrm>
           <a:prstGeom prst="rect">
@@ -9776,7 +9776,7 @@
         </p:nvSpPr>
         <p:spPr>
           <a:xfrm>
-            <a:off x="777240" y="2542032"/>
+            <a:off x="777240" y="2359152"/>
             <a:ext cx="10652760" cy="612648"/>
           </a:xfrm>
           <a:prstGeom prst="rect">
@@ -9820,8 +9820,8 @@
         </p:blipFill>
         <p:spPr>
           <a:xfrm>
-            <a:off x="777240" y="3101593"/>
-            <a:ext cx="10652760" cy="2959100"/>
+            <a:off x="980030" y="2670048"/>
+            <a:ext cx="10247179" cy="3529584"/>
           </a:xfrm>
           <a:prstGeom prst="rect">
             <a:avLst/>
@@ -9836,8 +9836,8 @@
         </p:nvSpPr>
         <p:spPr>
           <a:xfrm>
-            <a:off x="777240" y="6135624"/>
-            <a:ext cx="10652760" cy="237744"/>
+            <a:off x="777240" y="6217920"/>
+            <a:ext cx="5120640" cy="219456"/>
           </a:xfrm>
           <a:prstGeom prst="rect">
             <a:avLst/>
@@ -9872,22 +9872,22 @@
         </p:nvSpPr>
         <p:spPr>
           <a:xfrm>
-            <a:off x="777240" y="6382512"/>
-            <a:ext cx="10972800" cy="274320"/>
-          </a:xfrm>
-          <a:prstGeom prst="rect">
-            <a:avLst/>
-          </a:prstGeom>
-          <a:noFill/>
-        </p:spPr>
-        <p:txBody>
-          <a:bodyPr wrap="square" lIns="0" rIns="0" tIns="0" bIns="0">
-            <a:spAutoFit/>
-          </a:bodyPr>
-          <a:lstStyle/>
-          <a:p>
-            <a:r>
-              <a:rPr sz="1000" b="0">
+            <a:off x="6035040" y="6217920"/>
+            <a:ext cx="5394960" cy="219456"/>
+          </a:xfrm>
+          <a:prstGeom prst="rect">
+            <a:avLst/>
+          </a:prstGeom>
+          <a:noFill/>
+        </p:spPr>
+        <p:txBody>
+          <a:bodyPr wrap="square" lIns="0" rIns="0" tIns="0" bIns="0">
+            <a:spAutoFit/>
+          </a:bodyPr>
+          <a:lstStyle/>
+          <a:p>
+            <a:r>
+              <a:rPr sz="950" b="0">
                 <a:solidFill>
                   <a:srgbClr val="93A4B5"/>
                 </a:solidFill>
@@ -9908,22 +9908,22 @@
         </p:nvSpPr>
         <p:spPr>
           <a:xfrm>
-            <a:off x="777240" y="6583680"/>
-            <a:ext cx="10972800" cy="256032"/>
-          </a:xfrm>
-          <a:prstGeom prst="rect">
-            <a:avLst/>
-          </a:prstGeom>
-          <a:noFill/>
-        </p:spPr>
-        <p:txBody>
-          <a:bodyPr wrap="square" lIns="0" rIns="0" tIns="0" bIns="0">
-            <a:spAutoFit/>
-          </a:bodyPr>
-          <a:lstStyle/>
-          <a:p>
-            <a:r>
-              <a:rPr sz="1000" b="0">
+            <a:off x="777240" y="6620256"/>
+            <a:ext cx="10972800" cy="219456"/>
+          </a:xfrm>
+          <a:prstGeom prst="rect">
+            <a:avLst/>
+          </a:prstGeom>
+          <a:noFill/>
+        </p:spPr>
+        <p:txBody>
+          <a:bodyPr wrap="square" lIns="0" rIns="0" tIns="0" bIns="0">
+            <a:spAutoFit/>
+          </a:bodyPr>
+          <a:lstStyle/>
+          <a:p>
+            <a:r>
+              <a:rPr sz="950" b="0">
                 <a:solidFill>
                   <a:srgbClr val="93A4B5"/>
                 </a:solidFill>
@@ -11237,7 +11237,7 @@
         </p:nvSpPr>
         <p:spPr>
           <a:xfrm>
-            <a:off x="640080" y="1261872"/>
+            <a:off x="640080" y="1188720"/>
             <a:ext cx="10881360" cy="777240"/>
           </a:xfrm>
           <a:prstGeom prst="rect">
@@ -11273,7 +11273,7 @@
         </p:nvSpPr>
         <p:spPr>
           <a:xfrm>
-            <a:off x="777240" y="2029968"/>
+            <a:off x="777240" y="1920240"/>
             <a:ext cx="10652760" cy="612648"/>
           </a:xfrm>
           <a:prstGeom prst="rect">
@@ -11309,7 +11309,7 @@
         </p:nvSpPr>
         <p:spPr>
           <a:xfrm>
-            <a:off x="777240" y="2542032"/>
+            <a:off x="777240" y="2359152"/>
             <a:ext cx="10652760" cy="612648"/>
           </a:xfrm>
           <a:prstGeom prst="rect">
@@ -11353,8 +11353,8 @@
         </p:blipFill>
         <p:spPr>
           <a:xfrm>
-            <a:off x="777240" y="3101593"/>
-            <a:ext cx="10652760" cy="2959100"/>
+            <a:off x="980030" y="2670048"/>
+            <a:ext cx="10247179" cy="3529584"/>
           </a:xfrm>
           <a:prstGeom prst="rect">
             <a:avLst/>
@@ -11369,8 +11369,8 @@
         </p:nvSpPr>
         <p:spPr>
           <a:xfrm>
-            <a:off x="777240" y="6135624"/>
-            <a:ext cx="10652760" cy="237744"/>
+            <a:off x="777240" y="6217920"/>
+            <a:ext cx="5120640" cy="219456"/>
           </a:xfrm>
           <a:prstGeom prst="rect">
             <a:avLst/>
@@ -11405,22 +11405,22 @@
         </p:nvSpPr>
         <p:spPr>
           <a:xfrm>
-            <a:off x="777240" y="6382512"/>
-            <a:ext cx="10972800" cy="274320"/>
-          </a:xfrm>
-          <a:prstGeom prst="rect">
-            <a:avLst/>
-          </a:prstGeom>
-          <a:noFill/>
-        </p:spPr>
-        <p:txBody>
-          <a:bodyPr wrap="square" lIns="0" rIns="0" tIns="0" bIns="0">
-            <a:spAutoFit/>
-          </a:bodyPr>
-          <a:lstStyle/>
-          <a:p>
-            <a:r>
-              <a:rPr sz="1000" b="0">
+            <a:off x="6035040" y="6217920"/>
+            <a:ext cx="5394960" cy="219456"/>
+          </a:xfrm>
+          <a:prstGeom prst="rect">
+            <a:avLst/>
+          </a:prstGeom>
+          <a:noFill/>
+        </p:spPr>
+        <p:txBody>
+          <a:bodyPr wrap="square" lIns="0" rIns="0" tIns="0" bIns="0">
+            <a:spAutoFit/>
+          </a:bodyPr>
+          <a:lstStyle/>
+          <a:p>
+            <a:r>
+              <a:rPr sz="950" b="0">
                 <a:solidFill>
                   <a:srgbClr val="93A4B5"/>
                 </a:solidFill>
@@ -11441,22 +11441,22 @@
         </p:nvSpPr>
         <p:spPr>
           <a:xfrm>
-            <a:off x="777240" y="6583680"/>
-            <a:ext cx="10972800" cy="256032"/>
-          </a:xfrm>
-          <a:prstGeom prst="rect">
-            <a:avLst/>
-          </a:prstGeom>
-          <a:noFill/>
-        </p:spPr>
-        <p:txBody>
-          <a:bodyPr wrap="square" lIns="0" rIns="0" tIns="0" bIns="0">
-            <a:spAutoFit/>
-          </a:bodyPr>
-          <a:lstStyle/>
-          <a:p>
-            <a:r>
-              <a:rPr sz="1000" b="0">
+            <a:off x="777240" y="6620256"/>
+            <a:ext cx="10972800" cy="219456"/>
+          </a:xfrm>
+          <a:prstGeom prst="rect">
+            <a:avLst/>
+          </a:prstGeom>
+          <a:noFill/>
+        </p:spPr>
+        <p:txBody>
+          <a:bodyPr wrap="square" lIns="0" rIns="0" tIns="0" bIns="0">
+            <a:spAutoFit/>
+          </a:bodyPr>
+          <a:lstStyle/>
+          <a:p>
+            <a:r>
+              <a:rPr sz="950" b="0">
                 <a:solidFill>
                   <a:srgbClr val="93A4B5"/>
                 </a:solidFill>

</xml_diff>